<commit_message>
Use larger Pokemon artwork and teach image-labeled Tableau charts
</commit_message>
<xml_diff>
--- a/lectures/w04-pokemon-challenge.pptx
+++ b/lectures/w04-pokemon-challenge.pptx
@@ -2,15 +2,15 @@
 <file path=ppt/presentation.xml><?xml version="1.0" encoding="utf-8"?>
 <p:presentation xmlns:p="http://schemas.openxmlformats.org/presentationml/2006/main">
   <p:sldMasterIdLst>
-    <p:sldMasterId xmlns:r="http://schemas.openxmlformats.org/officeDocument/2006/relationships" id="2147483648" r:id="R5179326d767a4069"/>
+    <p:sldMasterId xmlns:r="http://schemas.openxmlformats.org/officeDocument/2006/relationships" id="2147483648" r:id="Rcf9865cc384449bc"/>
   </p:sldMasterIdLst>
   <p:notesMasterIdLst>
-    <p:notesMasterId xmlns:r="http://schemas.openxmlformats.org/officeDocument/2006/relationships" r:id="R717455aa52754703"/>
+    <p:notesMasterId xmlns:r="http://schemas.openxmlformats.org/officeDocument/2006/relationships" r:id="R8c24d137fe48436c"/>
   </p:notesMasterIdLst>
   <p:sldIdLst>
-    <p:sldId xmlns:r="http://schemas.openxmlformats.org/officeDocument/2006/relationships" id="256" r:id="Rd133765b2b444009"/>
-    <p:sldId xmlns:r="http://schemas.openxmlformats.org/officeDocument/2006/relationships" id="257" r:id="R31250a4bf09a4e0d"/>
-    <p:sldId xmlns:r="http://schemas.openxmlformats.org/officeDocument/2006/relationships" id="258" r:id="Ra275323ffc6148d4"/>
+    <p:sldId xmlns:r="http://schemas.openxmlformats.org/officeDocument/2006/relationships" id="256" r:id="R1276fc5fcb644cf1"/>
+    <p:sldId xmlns:r="http://schemas.openxmlformats.org/officeDocument/2006/relationships" id="257" r:id="Rd7bebddbb1334343"/>
+    <p:sldId xmlns:r="http://schemas.openxmlformats.org/officeDocument/2006/relationships" id="258" r:id="Rf0de1584fa394861"/>
   </p:sldIdLst>
   <p:sldSz cx="12192000" cy="6858000"/>
   <p:notesSz cx="6858000" cy="9144000"/>
@@ -584,7 +584,7 @@
           <a:lstStyle xmlns:a="http://schemas.openxmlformats.org/drawingml/2006/main"/>
           <a:p xmlns:a="http://schemas.openxmlformats.org/drawingml/2006/main">
             <a:r>
-              <a:t>Use the class CSV data/pokemon-review.csv. One default form per species. Starter example filters Generation to1 to reduce the scope. Keep Generation as a discrete dimension. Drag Type_1 to Rows. Drag Attack to Columns, then change its aggregation from Sum to Average via pill menu Measure &gt; Average. Marks: Bar. Sort descending, use a zero baseline, show mark labels. The chart uses all Generation1 species from the supplied CSV, grouped by their current primary type in that snapshot. Secondary type is deliberately not included. Current types are not necessarily original-release types. These are fictional game base attack stats, not a universal battle-strength ranking. After this starter, change the measure or question and create your own finding. Guide: https://help.tableau.com/current/pro/desktop/en-us/buildexamples_bar.htm</a:t>
+              <a:t>Download the updated class CSV and refresh the Tableau connection. Filter Name to Bulbasaur, Charmander, Eevee, Pikachu and Squirtle. Use a discrete Image_URL dimension with Image Role &gt; URL. Rows shelves, left to right: Image_URL then Name. Columns: AVG(Attack). Marks Bar. Right-click Image_URL on Rows and choose Sort: Descending, Sort by Field, Attack, Average, turn on labels and retain a zero baseline. Increase row height to roughly80 pixels by dragging a row divider, and widen the image header column to make the artwork visible. Use Standard view rather than Entire View if fitting shrinks the five rows. Images appear in headers, not as scatterplot marks. The illustrated bars are actual base Attack from the CSV: Pikachu55, Eevee55, Charmander52, Bulbasaur49, Squirtle48. Tie order may differ. These are base Attack statistics, not universal battle strength. Artwork from the Image_URL values. https://help.tableau.com/current/pro/desktop/en-us/image_role.htm</a:t>
             </a:r>
           </a:p>
         </p:txBody>
@@ -631,7 +631,7 @@
           <p:cNvPr id="3" name="Title">
             <a:extLst xmlns:a="http://schemas.openxmlformats.org/drawingml/2006/main">
               <a:ext uri="{FF2B5EF4-FFF2-40B4-BE49-F238E27FC236}">
-                <a16:creationId xmlns:a16="http://schemas.microsoft.com/office/drawing/2014/main" id="{5BF8B3BF-FC83-4AAF-B586-E7B6800337CA}"/>
+                <a16:creationId xmlns:a16="http://schemas.microsoft.com/office/drawing/2014/main" id="{4548CAA9-697A-466F-AB2B-B32951D0E5CC}"/>
               </a:ext>
             </a:extLst>
           </p:cNvPr>
@@ -788,7 +788,7 @@
           <p:cNvPr id="2" name="Subtitle">
             <a:extLst xmlns:a="http://schemas.openxmlformats.org/drawingml/2006/main">
               <a:ext uri="{FF2B5EF4-FFF2-40B4-BE49-F238E27FC236}">
-                <a16:creationId xmlns:a16="http://schemas.microsoft.com/office/drawing/2014/main" id="{062B3586-160D-4355-A365-B1AD481865B6}"/>
+                <a16:creationId xmlns:a16="http://schemas.microsoft.com/office/drawing/2014/main" id="{1D3AFA94-E1DA-4C3F-94A0-F3112F9C6D47}"/>
               </a:ext>
             </a:extLst>
           </p:cNvPr>
@@ -962,7 +962,7 @@
           <p:cNvPr id="2" name="Section title">
             <a:extLst xmlns:a="http://schemas.openxmlformats.org/drawingml/2006/main">
               <a:ext uri="{FF2B5EF4-FFF2-40B4-BE49-F238E27FC236}">
-                <a16:creationId xmlns:a16="http://schemas.microsoft.com/office/drawing/2014/main" id="{BC6A071C-553A-492C-840C-C2125AE3DB9B}"/>
+                <a16:creationId xmlns:a16="http://schemas.microsoft.com/office/drawing/2014/main" id="{98E7FC82-2300-4F04-8169-11B0F2969E4A}"/>
               </a:ext>
             </a:extLst>
           </p:cNvPr>
@@ -1136,7 +1136,7 @@
           <p:cNvPr id="3" name="Title">
             <a:extLst xmlns:a="http://schemas.openxmlformats.org/drawingml/2006/main">
               <a:ext uri="{FF2B5EF4-FFF2-40B4-BE49-F238E27FC236}">
-                <a16:creationId xmlns:a16="http://schemas.microsoft.com/office/drawing/2014/main" id="{E3896B53-7B4C-4FBF-A0F6-23F50AC160D7}"/>
+                <a16:creationId xmlns:a16="http://schemas.microsoft.com/office/drawing/2014/main" id="{E9F3FFAF-B9C4-48E5-87AB-4E3D0A7E4E81}"/>
               </a:ext>
             </a:extLst>
           </p:cNvPr>
@@ -1293,7 +1293,7 @@
           <p:cNvPr id="2" name="Body">
             <a:extLst xmlns:a="http://schemas.openxmlformats.org/drawingml/2006/main">
               <a:ext uri="{FF2B5EF4-FFF2-40B4-BE49-F238E27FC236}">
-                <a16:creationId xmlns:a16="http://schemas.microsoft.com/office/drawing/2014/main" id="{9D08D921-BB5B-43A1-833E-D13362A1ED12}"/>
+                <a16:creationId xmlns:a16="http://schemas.microsoft.com/office/drawing/2014/main" id="{C5827725-E960-43F7-B7F1-2942A192EBD0}"/>
               </a:ext>
             </a:extLst>
           </p:cNvPr>
@@ -1467,7 +1467,7 @@
           <p:cNvPr id="4" name="Title">
             <a:extLst xmlns:a="http://schemas.openxmlformats.org/drawingml/2006/main">
               <a:ext uri="{FF2B5EF4-FFF2-40B4-BE49-F238E27FC236}">
-                <a16:creationId xmlns:a16="http://schemas.microsoft.com/office/drawing/2014/main" id="{A68A419B-96B7-4C8F-8DCF-420DAD952D6C}"/>
+                <a16:creationId xmlns:a16="http://schemas.microsoft.com/office/drawing/2014/main" id="{889BA6FD-FC76-49CB-A711-258E21F39CAE}"/>
               </a:ext>
             </a:extLst>
           </p:cNvPr>
@@ -1624,7 +1624,7 @@
           <p:cNvPr id="2" name="Left column">
             <a:extLst xmlns:a="http://schemas.openxmlformats.org/drawingml/2006/main">
               <a:ext uri="{FF2B5EF4-FFF2-40B4-BE49-F238E27FC236}">
-                <a16:creationId xmlns:a16="http://schemas.microsoft.com/office/drawing/2014/main" id="{DC6B6C14-740D-4142-9FE4-495DBBD3FB57}"/>
+                <a16:creationId xmlns:a16="http://schemas.microsoft.com/office/drawing/2014/main" id="{CE592BE3-413D-408E-A516-5400A252FA3A}"/>
               </a:ext>
             </a:extLst>
           </p:cNvPr>
@@ -1781,7 +1781,7 @@
           <p:cNvPr id="3" name="Right column">
             <a:extLst xmlns:a="http://schemas.openxmlformats.org/drawingml/2006/main">
               <a:ext uri="{FF2B5EF4-FFF2-40B4-BE49-F238E27FC236}">
-                <a16:creationId xmlns:a16="http://schemas.microsoft.com/office/drawing/2014/main" id="{50DC2613-334A-4651-990D-A8C3BFD67143}"/>
+                <a16:creationId xmlns:a16="http://schemas.microsoft.com/office/drawing/2014/main" id="{3CD816BB-2D89-45C1-9AD1-8BFFE06FC173}"/>
               </a:ext>
             </a:extLst>
           </p:cNvPr>
@@ -1955,7 +1955,7 @@
           <p:cNvPr id="3" name="Title">
             <a:extLst xmlns:a="http://schemas.openxmlformats.org/drawingml/2006/main">
               <a:ext uri="{FF2B5EF4-FFF2-40B4-BE49-F238E27FC236}">
-                <a16:creationId xmlns:a16="http://schemas.microsoft.com/office/drawing/2014/main" id="{DA182875-5406-41CA-BD58-A19D45BDD3DC}"/>
+                <a16:creationId xmlns:a16="http://schemas.microsoft.com/office/drawing/2014/main" id="{FD564569-30CD-4AF9-99F7-F32DA85FF120}"/>
               </a:ext>
             </a:extLst>
           </p:cNvPr>
@@ -2112,7 +2112,7 @@
           <p:cNvPr id="2" name="Left column">
             <a:extLst xmlns:a="http://schemas.openxmlformats.org/drawingml/2006/main">
               <a:ext uri="{FF2B5EF4-FFF2-40B4-BE49-F238E27FC236}">
-                <a16:creationId xmlns:a16="http://schemas.microsoft.com/office/drawing/2014/main" id="{18567474-BB30-4016-916B-1B155480F565}"/>
+                <a16:creationId xmlns:a16="http://schemas.microsoft.com/office/drawing/2014/main" id="{65E32D35-F719-4B49-9F14-5562D0E81F08}"/>
               </a:ext>
             </a:extLst>
           </p:cNvPr>
@@ -2307,12 +2307,12 @@
   </p:cSld>
   <p:clrMap bg1="lt1" tx1="dk1" bg2="lt2" tx2="dk2" accent1="accent1" accent2="accent2" accent3="accent3" accent4="accent4" accent5="accent5" accent6="accent6" hlink="hlink" folHlink="folHlink"/>
   <p:sldLayoutIdLst>
-    <p:sldLayoutId xmlns:r="http://schemas.openxmlformats.org/officeDocument/2006/relationships" id="2147483649" r:id="Rca07690650744898"/>
-    <p:sldLayoutId xmlns:r="http://schemas.openxmlformats.org/officeDocument/2006/relationships" id="2147483650" r:id="Rfeab96e1d1074f72"/>
-    <p:sldLayoutId xmlns:r="http://schemas.openxmlformats.org/officeDocument/2006/relationships" id="2147483651" r:id="R500a0aaaac974134"/>
-    <p:sldLayoutId xmlns:r="http://schemas.openxmlformats.org/officeDocument/2006/relationships" id="2147483652" r:id="Re089623efac045b7"/>
-    <p:sldLayoutId xmlns:r="http://schemas.openxmlformats.org/officeDocument/2006/relationships" id="2147483653" r:id="R9ea7548024294a8c"/>
-    <p:sldLayoutId xmlns:r="http://schemas.openxmlformats.org/officeDocument/2006/relationships" id="2147483654" r:id="R7c72b612619a45d2"/>
+    <p:sldLayoutId xmlns:r="http://schemas.openxmlformats.org/officeDocument/2006/relationships" id="2147483649" r:id="Rf9e3bcd6619946ac"/>
+    <p:sldLayoutId xmlns:r="http://schemas.openxmlformats.org/officeDocument/2006/relationships" id="2147483650" r:id="R837bbf99ae89420f"/>
+    <p:sldLayoutId xmlns:r="http://schemas.openxmlformats.org/officeDocument/2006/relationships" id="2147483651" r:id="R2057b59a14cf4f2e"/>
+    <p:sldLayoutId xmlns:r="http://schemas.openxmlformats.org/officeDocument/2006/relationships" id="2147483652" r:id="Rf797418c6ee04a9f"/>
+    <p:sldLayoutId xmlns:r="http://schemas.openxmlformats.org/officeDocument/2006/relationships" id="2147483653" r:id="R01441d9c5d8a4a83"/>
+    <p:sldLayoutId xmlns:r="http://schemas.openxmlformats.org/officeDocument/2006/relationships" id="2147483654" r:id="R7c02a0e088874c4c"/>
   </p:sldLayoutIdLst>
   <p:txStyles>
     <p:titleStyle>
@@ -2852,7 +2852,7 @@
           <c:idx val="0"/>
           <c:order val="0"/>
           <c:tx>
-            <c:v>Average Attack</c:v>
+            <c:v>Attack</c:v>
           </c:tx>
           <c:spPr>
             <a:solidFill xmlns:a="http://schemas.openxmlformats.org/drawingml/2006/main">
@@ -2862,120 +2862,60 @@
           <c:invertIfNegative val="0"/>
           <c:cat>
             <c:strRef>
-              <c:f>'Chart Data'!$A$2:$A$16</c:f>
+              <c:f>'Chart Data'!$A$2:$A$6</c:f>
               <c:strCache>
-                <c:ptCount val="15"/>
+                <c:ptCount val="5"/>
                 <c:pt idx="0">
-                  <c:v>Ghost</c:v>
+                  <c:v>Squirtle</c:v>
                 </c:pt>
                 <c:pt idx="1">
-                  <c:v>Fairy</c:v>
+                  <c:v>Bulbasaur</c:v>
                 </c:pt>
                 <c:pt idx="2">
-                  <c:v>Psychic</c:v>
+                  <c:v>Charmander</c:v>
                 </c:pt>
                 <c:pt idx="3">
-                  <c:v>Electric</c:v>
+                  <c:v>Eevee</c:v>
                 </c:pt>
                 <c:pt idx="4">
-                  <c:v>Bug</c:v>
-                </c:pt>
-                <c:pt idx="5">
-                  <c:v>Ice</c:v>
-                </c:pt>
-                <c:pt idx="6">
-                  <c:v>Normal</c:v>
-                </c:pt>
-                <c:pt idx="7">
-                  <c:v>Water</c:v>
-                </c:pt>
-                <c:pt idx="8">
-                  <c:v>Grass</c:v>
-                </c:pt>
-                <c:pt idx="9">
-                  <c:v>Poison</c:v>
-                </c:pt>
-                <c:pt idx="10">
-                  <c:v>Rock</c:v>
-                </c:pt>
-                <c:pt idx="11">
-                  <c:v>Fire</c:v>
-                </c:pt>
-                <c:pt idx="12">
-                  <c:v>Ground</c:v>
-                </c:pt>
-                <c:pt idx="13">
-                  <c:v>Dragon</c:v>
-                </c:pt>
-                <c:pt idx="14">
-                  <c:v>Fighting</c:v>
+                  <c:v>Pikachu</c:v>
                 </c:pt>
               </c:strCache>
             </c:strRef>
           </c:cat>
           <c:val>
             <c:numRef>
-              <c:f>'Chart Data'!$B$2:$B$16</c:f>
+              <c:f>'Chart Data'!$B$2:$B$6</c:f>
               <c:numCache>
                 <c:formatCode>General</c:formatCode>
-                <c:ptCount val="15"/>
+                <c:ptCount val="5"/>
                 <c:pt idx="0">
-                  <c:v>50</c:v>
+                  <c:v>48</c:v>
                 </c:pt>
                 <c:pt idx="1">
-                  <c:v>57.5</c:v>
+                  <c:v>49</c:v>
                 </c:pt>
                 <c:pt idx="2">
-                  <c:v>60.1</c:v>
+                  <c:v>52</c:v>
                 </c:pt>
                 <c:pt idx="3">
-                  <c:v>62</c:v>
+                  <c:v>55</c:v>
                 </c:pt>
                 <c:pt idx="4">
-                  <c:v>63.8</c:v>
-                </c:pt>
-                <c:pt idx="5">
-                  <c:v>67.5</c:v>
-                </c:pt>
-                <c:pt idx="6">
-                  <c:v>68.9</c:v>
-                </c:pt>
-                <c:pt idx="7">
-                  <c:v>70.3</c:v>
-                </c:pt>
-                <c:pt idx="8">
-                  <c:v>70.7</c:v>
-                </c:pt>
-                <c:pt idx="9">
-                  <c:v>75.1</c:v>
-                </c:pt>
-                <c:pt idx="10">
-                  <c:v>82.2</c:v>
-                </c:pt>
-                <c:pt idx="11">
-                  <c:v>83.9</c:v>
-                </c:pt>
-                <c:pt idx="12">
-                  <c:v>84.4</c:v>
-                </c:pt>
-                <c:pt idx="13">
-                  <c:v>94</c:v>
-                </c:pt>
-                <c:pt idx="14">
-                  <c:v>102.9</c:v>
+                  <c:v>55</c:v>
                 </c:pt>
               </c:numCache>
             </c:numRef>
           </c:val>
         </c:ser>
         <c:dLbls>
-          <c:numFmt formatCode="0.0" sourceLinked="0"/>
+          <c:numFmt formatCode="0" sourceLinked="0"/>
           <c:txPr>
             <a:bodyPr xmlns:a="http://schemas.openxmlformats.org/drawingml/2006/main" anchorCtr="1"/>
             <a:lstStyle xmlns:a="http://schemas.openxmlformats.org/drawingml/2006/main"/>
             <a:p xmlns:a="http://schemas.openxmlformats.org/drawingml/2006/main">
               <a:pPr>
-                <a:defRPr sz="1275">
+                <a:defRPr sz="1725">
                   <a:solidFill>
                     <a:srgbClr val="38332E"/>
                   </a:solidFill>
@@ -2995,7 +2935,7 @@
           <c:showBubbleSize val="0"/>
           <c:showLeaderLines val="0"/>
         </c:dLbls>
-        <c:gapWidth val="50"/>
+        <c:gapWidth val="130"/>
         <c:axId val="48650112"/>
         <c:axId val="48672768"/>
       </c:barChart>
@@ -3022,7 +2962,7 @@
           <a:lstStyle xmlns:a="http://schemas.openxmlformats.org/drawingml/2006/main"/>
           <a:p xmlns:a="http://schemas.openxmlformats.org/drawingml/2006/main">
             <a:pPr>
-              <a:defRPr sz="1275">
+              <a:defRPr sz="1500">
                 <a:solidFill>
                   <a:srgbClr val="38332E"/>
                 </a:solidFill>
@@ -3039,7 +2979,7 @@
         <c:axId val="48672768"/>
         <c:scaling>
           <c:orientation val="minMax"/>
-          <c:max val="130"/>
+          <c:max val="70"/>
           <c:min val="0"/>
         </c:scaling>
         <c:delete val="0"/>
@@ -3060,7 +3000,7 @@
               <a:lstStyle xmlns:a="http://schemas.openxmlformats.org/drawingml/2006/main"/>
               <a:p xmlns:a="http://schemas.openxmlformats.org/drawingml/2006/main">
                 <a:r>
-                  <a:rPr sz="1500">
+                  <a:rPr sz="1650">
                     <a:solidFill>
                       <a:srgbClr val="38332E"/>
                     </a:solidFill>
@@ -3068,7 +3008,7 @@
                     <a:ea typeface="Ubuntu Condensed"/>
                     <a:cs typeface="Ubuntu Condensed"/>
                   </a:rPr>
-                  <a:t>Average Attack</a:t>
+                  <a:t>Attack</a:t>
                 </a:r>
               </a:p>
             </c:rich>
@@ -3079,7 +3019,7 @@
             <a:lstStyle xmlns:a="http://schemas.openxmlformats.org/drawingml/2006/main"/>
             <a:p xmlns:a="http://schemas.openxmlformats.org/drawingml/2006/main">
               <a:pPr>
-                <a:defRPr sz="1500">
+                <a:defRPr sz="1650">
                   <a:solidFill>
                     <a:srgbClr val="38332E"/>
                   </a:solidFill>
@@ -3120,7 +3060,7 @@
         </c:txPr>
         <c:crossAx val="48650112"/>
         <c:crossBetween val="between"/>
-        <c:majorUnit val="50"/>
+        <c:majorUnit val="20"/>
       </c:valAx>
       <c:spPr>
         <a:noFill xmlns:a="http://schemas.openxmlformats.org/drawingml/2006/main"/>
@@ -3161,7 +3101,7 @@
           <p:cNvPr id="2" name="">
             <a:extLst xmlns:a="http://schemas.openxmlformats.org/drawingml/2006/main">
               <a:ext uri="{FF2B5EF4-FFF2-40B4-BE49-F238E27FC236}">
-                <a16:creationId xmlns:a16="http://schemas.microsoft.com/office/drawing/2014/main" id="{77942041-DA19-4C7C-AE8E-690F6FC244A5}"/>
+                <a16:creationId xmlns:a16="http://schemas.microsoft.com/office/drawing/2014/main" id="{F44438EC-06B3-4E8E-A8AE-62A2314059E5}"/>
               </a:ext>
             </a:extLst>
           </p:cNvPr>
@@ -3171,7 +3111,7 @@
           <p:nvPr/>
         </p:nvPicPr>
         <p:blipFill>
-          <a:blip xmlns:r="http://schemas.openxmlformats.org/officeDocument/2006/relationships" xmlns:a="http://schemas.openxmlformats.org/drawingml/2006/main" r:embed="R6dda702a784043b8"/>
+          <a:blip xmlns:r="http://schemas.openxmlformats.org/officeDocument/2006/relationships" xmlns:a="http://schemas.openxmlformats.org/drawingml/2006/main" r:embed="R6beda985300b45fa"/>
           <a:stretch xmlns:a="http://schemas.openxmlformats.org/drawingml/2006/main"/>
         </p:blipFill>
         <p:spPr>
@@ -3187,7 +3127,7 @@
     </p:spTree>
     <p:extLst>
       <p:ext uri="{BB962C8B-B14F-4D97-AF65-F5344CB8AC3E}">
-        <p14:creationId xmlns:p14="http://schemas.microsoft.com/office/powerpoint/2010/main" val="1079669612"/>
+        <p14:creationId xmlns:p14="http://schemas.microsoft.com/office/powerpoint/2010/main" val="820940641"/>
       </p:ext>
     </p:extLst>
   </p:cSld>
@@ -3218,7 +3158,7 @@
           <p:cNvPr id="12" name="">
             <a:extLst xmlns:a="http://schemas.openxmlformats.org/drawingml/2006/main">
               <a:ext uri="{FF2B5EF4-FFF2-40B4-BE49-F238E27FC236}">
-                <a16:creationId xmlns:a16="http://schemas.microsoft.com/office/drawing/2014/main" id="{FB2139D7-5525-48FA-811B-CDD737D55617}"/>
+                <a16:creationId xmlns:a16="http://schemas.microsoft.com/office/drawing/2014/main" id="{3650F159-3FCC-411E-858F-FD28FC2AB5BD}"/>
               </a:ext>
             </a:extLst>
           </p:cNvPr>
@@ -3284,7 +3224,7 @@
           <p:cNvPr id="2" name="">
             <a:extLst xmlns:a="http://schemas.openxmlformats.org/drawingml/2006/main">
               <a:ext uri="{FF2B5EF4-FFF2-40B4-BE49-F238E27FC236}">
-                <a16:creationId xmlns:a16="http://schemas.microsoft.com/office/drawing/2014/main" id="{B9DABF2B-EC7A-4B62-BF8F-893FFEA7C533}"/>
+                <a16:creationId xmlns:a16="http://schemas.microsoft.com/office/drawing/2014/main" id="{7822F6D4-4877-40C4-A9ED-4B6C4A0D64EB}"/>
               </a:ext>
             </a:extLst>
           </p:cNvPr>
@@ -3350,7 +3290,7 @@
           <p:cNvPr id="3" name="">
             <a:extLst xmlns:a="http://schemas.openxmlformats.org/drawingml/2006/main">
               <a:ext uri="{FF2B5EF4-FFF2-40B4-BE49-F238E27FC236}">
-                <a16:creationId xmlns:a16="http://schemas.microsoft.com/office/drawing/2014/main" id="{78F58C11-0233-44B9-926F-96E7214C1A16}"/>
+                <a16:creationId xmlns:a16="http://schemas.microsoft.com/office/drawing/2014/main" id="{4A2920BF-B064-42DA-AEEA-ED96998C7947}"/>
               </a:ext>
             </a:extLst>
           </p:cNvPr>
@@ -3416,7 +3356,7 @@
           <p:cNvPr id="4" name="">
             <a:extLst xmlns:a="http://schemas.openxmlformats.org/drawingml/2006/main">
               <a:ext uri="{FF2B5EF4-FFF2-40B4-BE49-F238E27FC236}">
-                <a16:creationId xmlns:a16="http://schemas.microsoft.com/office/drawing/2014/main" id="{5579CAC6-B5D0-4C30-A5DC-14927E15EB37}"/>
+                <a16:creationId xmlns:a16="http://schemas.microsoft.com/office/drawing/2014/main" id="{C430F238-77F8-42F1-AEB8-6764B14A6786}"/>
               </a:ext>
             </a:extLst>
           </p:cNvPr>
@@ -3505,7 +3445,7 @@
           <p:cNvPr id="5" name="">
             <a:extLst xmlns:a="http://schemas.openxmlformats.org/drawingml/2006/main">
               <a:ext uri="{FF2B5EF4-FFF2-40B4-BE49-F238E27FC236}">
-                <a16:creationId xmlns:a16="http://schemas.microsoft.com/office/drawing/2014/main" id="{3FEC13E3-53BF-4CD7-965E-A3BD9CD6192E}"/>
+                <a16:creationId xmlns:a16="http://schemas.microsoft.com/office/drawing/2014/main" id="{35ED04CF-E913-4AF9-BF26-F91BA000FC7F}"/>
               </a:ext>
             </a:extLst>
           </p:cNvPr>
@@ -3571,7 +3511,7 @@
           <p:cNvPr id="6" name="">
             <a:extLst xmlns:a="http://schemas.openxmlformats.org/drawingml/2006/main">
               <a:ext uri="{FF2B5EF4-FFF2-40B4-BE49-F238E27FC236}">
-                <a16:creationId xmlns:a16="http://schemas.microsoft.com/office/drawing/2014/main" id="{A229427A-821E-41DD-8FE3-410C97D2D4AD}"/>
+                <a16:creationId xmlns:a16="http://schemas.microsoft.com/office/drawing/2014/main" id="{AF09BD06-20FD-439E-86EA-931BBD9191BE}"/>
               </a:ext>
             </a:extLst>
           </p:cNvPr>
@@ -3660,7 +3600,7 @@
           <p:cNvPr id="7" name="">
             <a:extLst xmlns:a="http://schemas.openxmlformats.org/drawingml/2006/main">
               <a:ext uri="{FF2B5EF4-FFF2-40B4-BE49-F238E27FC236}">
-                <a16:creationId xmlns:a16="http://schemas.microsoft.com/office/drawing/2014/main" id="{AB097217-4188-4723-851A-F2C42013EB05}"/>
+                <a16:creationId xmlns:a16="http://schemas.microsoft.com/office/drawing/2014/main" id="{E054A4B9-4E29-4488-A662-C0A6302FD4A7}"/>
               </a:ext>
             </a:extLst>
           </p:cNvPr>
@@ -3726,7 +3666,7 @@
           <p:cNvPr id="8" name="">
             <a:extLst xmlns:a="http://schemas.openxmlformats.org/drawingml/2006/main">
               <a:ext uri="{FF2B5EF4-FFF2-40B4-BE49-F238E27FC236}">
-                <a16:creationId xmlns:a16="http://schemas.microsoft.com/office/drawing/2014/main" id="{6ED71EC2-8D15-4A0D-A522-F4D891E325DA}"/>
+                <a16:creationId xmlns:a16="http://schemas.microsoft.com/office/drawing/2014/main" id="{09D58379-8EC8-47B1-A9AE-E99A568374E1}"/>
               </a:ext>
             </a:extLst>
           </p:cNvPr>
@@ -3815,7 +3755,7 @@
           <p:cNvPr id="9" name="">
             <a:extLst xmlns:a="http://schemas.openxmlformats.org/drawingml/2006/main">
               <a:ext uri="{FF2B5EF4-FFF2-40B4-BE49-F238E27FC236}">
-                <a16:creationId xmlns:a16="http://schemas.microsoft.com/office/drawing/2014/main" id="{2CE865B9-4866-4355-B420-3F2F4EF7E972}"/>
+                <a16:creationId xmlns:a16="http://schemas.microsoft.com/office/drawing/2014/main" id="{C11C46FD-CDC9-4125-85DB-A26504937B2F}"/>
               </a:ext>
             </a:extLst>
           </p:cNvPr>
@@ -3881,7 +3821,7 @@
           <p:cNvPr id="10" name="">
             <a:extLst xmlns:a="http://schemas.openxmlformats.org/drawingml/2006/main">
               <a:ext uri="{FF2B5EF4-FFF2-40B4-BE49-F238E27FC236}">
-                <a16:creationId xmlns:a16="http://schemas.microsoft.com/office/drawing/2014/main" id="{1945F3F5-A370-45E2-831B-0F12858F903E}"/>
+                <a16:creationId xmlns:a16="http://schemas.microsoft.com/office/drawing/2014/main" id="{1678E336-B4FC-4E79-A556-6A6137573562}"/>
               </a:ext>
             </a:extLst>
           </p:cNvPr>
@@ -3947,7 +3887,7 @@
           <p:cNvPr id="11" name="">
             <a:extLst xmlns:a="http://schemas.openxmlformats.org/drawingml/2006/main">
               <a:ext uri="{FF2B5EF4-FFF2-40B4-BE49-F238E27FC236}">
-                <a16:creationId xmlns:a16="http://schemas.microsoft.com/office/drawing/2014/main" id="{CA52D06A-7C2E-4F8A-A2FB-62608A761B66}"/>
+                <a16:creationId xmlns:a16="http://schemas.microsoft.com/office/drawing/2014/main" id="{8848D4D1-0FFB-4F10-926C-FFE10DA277EA}"/>
               </a:ext>
             </a:extLst>
           </p:cNvPr>
@@ -4011,7 +3951,7 @@
     </p:spTree>
     <p:extLst>
       <p:ext uri="{BB962C8B-B14F-4D97-AF65-F5344CB8AC3E}">
-        <p14:creationId xmlns:p14="http://schemas.microsoft.com/office/powerpoint/2010/main" val="1443111071"/>
+        <p14:creationId xmlns:p14="http://schemas.microsoft.com/office/powerpoint/2010/main" val="1571833073"/>
       </p:ext>
     </p:extLst>
   </p:cSld>
@@ -4039,10 +3979,10 @@
       </p:grpSpPr>
       <p:sp>
         <p:nvSpPr>
-          <p:cNvPr id="11" name="">
+          <p:cNvPr id="16" name="">
             <a:extLst xmlns:a="http://schemas.openxmlformats.org/drawingml/2006/main">
               <a:ext uri="{FF2B5EF4-FFF2-40B4-BE49-F238E27FC236}">
-                <a16:creationId xmlns:a16="http://schemas.microsoft.com/office/drawing/2014/main" id="{D4EDCC5D-034F-42A1-AC65-C35081A48263}"/>
+                <a16:creationId xmlns:a16="http://schemas.microsoft.com/office/drawing/2014/main" id="{2ED063D3-DE9B-4D9B-97AC-D6C294324B16}"/>
               </a:ext>
             </a:extLst>
           </p:cNvPr>
@@ -4098,7 +4038,7 @@
                 <a:ea typeface="Ubuntu Condensed"/>
                 <a:cs typeface="Ubuntu Condensed"/>
               </a:rPr>
-              <a:t>A first Tableau chart</a:t>
+              <a:t>A first chart with Pokémon images</a:t>
             </a:r>
           </a:p>
         </p:txBody>
@@ -4108,7 +4048,7 @@
           <p:cNvPr id="2" name="">
             <a:extLst xmlns:a="http://schemas.openxmlformats.org/drawingml/2006/main">
               <a:ext uri="{FF2B5EF4-FFF2-40B4-BE49-F238E27FC236}">
-                <a16:creationId xmlns:a16="http://schemas.microsoft.com/office/drawing/2014/main" id="{03EE2F46-BA45-43F2-94B3-4CF517DEE6E1}"/>
+                <a16:creationId xmlns:a16="http://schemas.microsoft.com/office/drawing/2014/main" id="{B9835351-A7E8-4424-B06B-C3F4E44A5CB4}"/>
               </a:ext>
             </a:extLst>
           </p:cNvPr>
@@ -4164,7 +4104,7 @@
                 <a:ea typeface="Ubuntu Condensed"/>
                 <a:cs typeface="Ubuntu Condensed"/>
               </a:rPr>
-              <a:t>Which primary types have higher average Attack?</a:t>
+              <a:t>Compare Attack for five Pokémon</a:t>
             </a:r>
           </a:p>
         </p:txBody>
@@ -4174,7 +4114,7 @@
           <p:cNvPr id="3" name="">
             <a:extLst xmlns:a="http://schemas.openxmlformats.org/drawingml/2006/main">
               <a:ext uri="{FF2B5EF4-FFF2-40B4-BE49-F238E27FC236}">
-                <a16:creationId xmlns:a16="http://schemas.microsoft.com/office/drawing/2014/main" id="{FBB65998-E835-43E9-8ACF-78139BB0EB65}"/>
+                <a16:creationId xmlns:a16="http://schemas.microsoft.com/office/drawing/2014/main" id="{BC5C4BE6-645B-4B1A-AF66-3D726EAC00E2}"/>
               </a:ext>
             </a:extLst>
           </p:cNvPr>
@@ -4230,7 +4170,7 @@
                 <a:ea typeface="Ubuntu Condensed"/>
                 <a:cs typeface="Ubuntu Condensed"/>
               </a:rPr>
-              <a:t>1  Open the Pokémon CSV</a:t>
+              <a:t>1  Updated CSV + five names</a:t>
             </a:r>
           </a:p>
         </p:txBody>
@@ -4240,7 +4180,7 @@
           <p:cNvPr id="4" name="">
             <a:extLst xmlns:a="http://schemas.openxmlformats.org/drawingml/2006/main">
               <a:ext uri="{FF2B5EF4-FFF2-40B4-BE49-F238E27FC236}">
-                <a16:creationId xmlns:a16="http://schemas.microsoft.com/office/drawing/2014/main" id="{9EC76AFA-7156-47FC-A441-EBAA05B7F1A3}"/>
+                <a16:creationId xmlns:a16="http://schemas.microsoft.com/office/drawing/2014/main" id="{52642A38-A08A-4E3A-AFD9-60265FAEB488}"/>
               </a:ext>
             </a:extLst>
           </p:cNvPr>
@@ -4252,7 +4192,7 @@
         <p:spPr>
           <a:xfrm xmlns:a="http://schemas.openxmlformats.org/drawingml/2006/main">
             <a:off x="457200" y="2171700"/>
-            <a:ext cx="5238750" cy="695325"/>
+            <a:ext cx="5238750" cy="723900"/>
           </a:xfrm>
           <a:prstGeom xmlns:a="http://schemas.openxmlformats.org/drawingml/2006/main" prst="rect">
             <a:avLst/>
@@ -4296,7 +4236,7 @@
                 <a:ea typeface="Ubuntu Condensed"/>
                 <a:cs typeface="Ubuntu Condensed"/>
               </a:rPr>
-              <a:t>New worksheet. Generation: Dimension.</a:t>
+              <a:t>Filter Name: Bulbasaur, Charmander,</a:t>
             </a:r>
           </a:p>
           <a:p xmlns:a="http://schemas.openxmlformats.org/drawingml/2006/main">
@@ -4319,7 +4259,7 @@
                 <a:ea typeface="Ubuntu Condensed"/>
                 <a:cs typeface="Ubuntu Condensed"/>
               </a:rPr>
-              <a:t>Filter Generation to 1.</a:t>
+              <a:t>Eevee, Pikachu and Squirtle.</a:t>
             </a:r>
           </a:p>
         </p:txBody>
@@ -4329,7 +4269,7 @@
           <p:cNvPr id="5" name="">
             <a:extLst xmlns:a="http://schemas.openxmlformats.org/drawingml/2006/main">
               <a:ext uri="{FF2B5EF4-FFF2-40B4-BE49-F238E27FC236}">
-                <a16:creationId xmlns:a16="http://schemas.microsoft.com/office/drawing/2014/main" id="{5148AB99-2032-4B45-BC9C-B165858561CE}"/>
+                <a16:creationId xmlns:a16="http://schemas.microsoft.com/office/drawing/2014/main" id="{2CDCDCBB-108E-4846-972F-337E7F1332AF}"/>
               </a:ext>
             </a:extLst>
           </p:cNvPr>
@@ -4340,7 +4280,7 @@
         </p:nvSpPr>
         <p:spPr>
           <a:xfrm xmlns:a="http://schemas.openxmlformats.org/drawingml/2006/main">
-            <a:off x="457200" y="3114675"/>
+            <a:off x="457200" y="3057525"/>
             <a:ext cx="5238750" cy="400050"/>
           </a:xfrm>
           <a:prstGeom xmlns:a="http://schemas.openxmlformats.org/drawingml/2006/main" prst="rect">
@@ -4385,7 +4325,7 @@
                 <a:ea typeface="Ubuntu Condensed"/>
                 <a:cs typeface="Ubuntu Condensed"/>
               </a:rPr>
-              <a:t>2  Arrange the fields</a:t>
+              <a:t>2  Images beside the bars</a:t>
             </a:r>
           </a:p>
         </p:txBody>
@@ -4395,7 +4335,7 @@
           <p:cNvPr id="6" name="">
             <a:extLst xmlns:a="http://schemas.openxmlformats.org/drawingml/2006/main">
               <a:ext uri="{FF2B5EF4-FFF2-40B4-BE49-F238E27FC236}">
-                <a16:creationId xmlns:a16="http://schemas.microsoft.com/office/drawing/2014/main" id="{DAB1103E-8242-43BC-A07E-5D5A459DB638}"/>
+                <a16:creationId xmlns:a16="http://schemas.microsoft.com/office/drawing/2014/main" id="{C6405718-96AC-41EA-A60C-6E9049F45038}"/>
               </a:ext>
             </a:extLst>
           </p:cNvPr>
@@ -4406,8 +4346,8 @@
         </p:nvSpPr>
         <p:spPr>
           <a:xfrm xmlns:a="http://schemas.openxmlformats.org/drawingml/2006/main">
-            <a:off x="457200" y="3562350"/>
-            <a:ext cx="5238750" cy="1066800"/>
+            <a:off x="457200" y="3505200"/>
+            <a:ext cx="5238750" cy="1095375"/>
           </a:xfrm>
           <a:prstGeom xmlns:a="http://schemas.openxmlformats.org/drawingml/2006/main" prst="rect">
             <a:avLst/>
@@ -4451,7 +4391,7 @@
                 <a:ea typeface="Ubuntu Condensed"/>
                 <a:cs typeface="Ubuntu Condensed"/>
               </a:rPr>
-              <a:t>Rows: Type_1</a:t>
+              <a:t>Image_URL: Image Role &gt; URL</a:t>
             </a:r>
           </a:p>
           <a:p xmlns:a="http://schemas.openxmlformats.org/drawingml/2006/main">
@@ -4474,7 +4414,7 @@
                 <a:ea typeface="Ubuntu Condensed"/>
                 <a:cs typeface="Ubuntu Condensed"/>
               </a:rPr>
-              <a:t>Columns: Attack &gt; Measure &gt; Average</a:t>
+              <a:t>Rows: Image_URL, then Name</a:t>
             </a:r>
           </a:p>
           <a:p xmlns:a="http://schemas.openxmlformats.org/drawingml/2006/main">
@@ -4497,7 +4437,7 @@
                 <a:ea typeface="Ubuntu Condensed"/>
                 <a:cs typeface="Ubuntu Condensed"/>
               </a:rPr>
-              <a:t>Marks: Bar</a:t>
+              <a:t>Columns: AVG(Attack)     Marks: Bar</a:t>
             </a:r>
           </a:p>
         </p:txBody>
@@ -4507,7 +4447,7 @@
           <p:cNvPr id="7" name="">
             <a:extLst xmlns:a="http://schemas.openxmlformats.org/drawingml/2006/main">
               <a:ext uri="{FF2B5EF4-FFF2-40B4-BE49-F238E27FC236}">
-                <a16:creationId xmlns:a16="http://schemas.microsoft.com/office/drawing/2014/main" id="{965C2736-F301-4E9D-ACC5-746D3568A7C4}"/>
+                <a16:creationId xmlns:a16="http://schemas.microsoft.com/office/drawing/2014/main" id="{9EB8FBCC-AA9A-45EA-A669-1F28B09F10BB}"/>
               </a:ext>
             </a:extLst>
           </p:cNvPr>
@@ -4518,7 +4458,7 @@
         </p:nvSpPr>
         <p:spPr>
           <a:xfrm xmlns:a="http://schemas.openxmlformats.org/drawingml/2006/main">
-            <a:off x="457200" y="4886325"/>
+            <a:off x="457200" y="4819650"/>
             <a:ext cx="5238750" cy="400050"/>
           </a:xfrm>
           <a:prstGeom xmlns:a="http://schemas.openxmlformats.org/drawingml/2006/main" prst="rect">
@@ -4563,7 +4503,7 @@
                 <a:ea typeface="Ubuntu Condensed"/>
                 <a:cs typeface="Ubuntu Condensed"/>
               </a:rPr>
-              <a:t>3  Make the comparison clear</a:t>
+              <a:t>3  Bigger images, clear values</a:t>
             </a:r>
           </a:p>
         </p:txBody>
@@ -4573,7 +4513,7 @@
           <p:cNvPr id="8" name="">
             <a:extLst xmlns:a="http://schemas.openxmlformats.org/drawingml/2006/main">
               <a:ext uri="{FF2B5EF4-FFF2-40B4-BE49-F238E27FC236}">
-                <a16:creationId xmlns:a16="http://schemas.microsoft.com/office/drawing/2014/main" id="{BA1F3AB5-0773-4819-AB63-A665220AC7A6}"/>
+                <a16:creationId xmlns:a16="http://schemas.microsoft.com/office/drawing/2014/main" id="{AE6DFB74-9218-473C-B56F-56896FCDCD0A}"/>
               </a:ext>
             </a:extLst>
           </p:cNvPr>
@@ -4584,8 +4524,8 @@
         </p:nvSpPr>
         <p:spPr>
           <a:xfrm xmlns:a="http://schemas.openxmlformats.org/drawingml/2006/main">
-            <a:off x="457200" y="5334000"/>
-            <a:ext cx="5238750" cy="762000"/>
+            <a:off x="457200" y="5267325"/>
+            <a:ext cx="5238750" cy="1085850"/>
           </a:xfrm>
           <a:prstGeom xmlns:a="http://schemas.openxmlformats.org/drawingml/2006/main" prst="rect">
             <a:avLst/>
@@ -4599,7 +4539,7 @@
           <a:bodyPr xmlns:a="http://schemas.openxmlformats.org/drawingml/2006/main" lIns="0" tIns="0" rIns="0" bIns="0"/>
           <a:lstStyle xmlns:a="http://schemas.openxmlformats.org/drawingml/2006/main">
             <a:defPPr>
-              <a:defRPr sz="2025">
+              <a:defRPr sz="1950">
                 <a:solidFill>
                   <a:srgbClr val="38332E"/>
                 </a:solidFill>
@@ -4611,7 +4551,7 @@
           </a:lstStyle>
           <a:p xmlns:a="http://schemas.openxmlformats.org/drawingml/2006/main">
             <a:pPr>
-              <a:defRPr sz="2025">
+              <a:defRPr sz="1950">
                 <a:solidFill>
                   <a:srgbClr val="38332E"/>
                 </a:solidFill>
@@ -4621,7 +4561,7 @@
               </a:defRPr>
             </a:pPr>
             <a:r>
-              <a:rPr sz="2025">
+              <a:rPr sz="1950">
                 <a:solidFill>
                   <a:srgbClr val="38332E"/>
                 </a:solidFill>
@@ -4629,12 +4569,12 @@
                 <a:ea typeface="Ubuntu Condensed"/>
                 <a:cs typeface="Ubuntu Condensed"/>
               </a:rPr>
-              <a:t>Sort descending. Show labels. Start at zero.</a:t>
+              <a:t>Sort Image_URL by Average of Attack.</a:t>
             </a:r>
           </a:p>
           <a:p xmlns:a="http://schemas.openxmlformats.org/drawingml/2006/main">
             <a:pPr>
-              <a:defRPr sz="2025">
+              <a:defRPr sz="1950">
                 <a:solidFill>
                   <a:srgbClr val="38332E"/>
                 </a:solidFill>
@@ -4644,7 +4584,7 @@
               </a:defRPr>
             </a:pPr>
             <a:r>
-              <a:rPr sz="2025">
+              <a:rPr sz="1950">
                 <a:solidFill>
                   <a:srgbClr val="38332E"/>
                 </a:solidFill>
@@ -4652,7 +4592,30 @@
                 <a:ea typeface="Ubuntu Condensed"/>
                 <a:cs typeface="Ubuntu Condensed"/>
               </a:rPr>
-              <a:t>Then try another measure or question.</a:t>
+              <a:t>Show labels. Widen the image column.</a:t>
+            </a:r>
+          </a:p>
+          <a:p xmlns:a="http://schemas.openxmlformats.org/drawingml/2006/main">
+            <a:pPr>
+              <a:defRPr sz="1950">
+                <a:solidFill>
+                  <a:srgbClr val="38332E"/>
+                </a:solidFill>
+                <a:latin typeface="Ubuntu Condensed"/>
+                <a:ea typeface="Ubuntu Condensed"/>
+                <a:cs typeface="Ubuntu Condensed"/>
+              </a:defRPr>
+            </a:pPr>
+            <a:r>
+              <a:rPr sz="1950">
+                <a:solidFill>
+                  <a:srgbClr val="38332E"/>
+                </a:solidFill>
+                <a:latin typeface="Ubuntu Condensed"/>
+                <a:ea typeface="Ubuntu Condensed"/>
+                <a:cs typeface="Ubuntu Condensed"/>
+              </a:rPr>
+              <a:t>Make rows taller. Keep a zero baseline.</a:t>
             </a:r>
           </a:p>
         </p:txBody>
@@ -4662,7 +4625,7 @@
           <p:cNvPr id="9" name="Chart">
             <a:extLst xmlns:a="http://schemas.openxmlformats.org/drawingml/2006/main">
               <a:ext uri="{FF2B5EF4-FFF2-40B4-BE49-F238E27FC236}">
-                <a16:creationId xmlns:a16="http://schemas.microsoft.com/office/drawing/2014/main" id="{59B8EED7-9F1C-42F3-ACEE-A5DDB3641E90}"/>
+                <a16:creationId xmlns:a16="http://schemas.microsoft.com/office/drawing/2014/main" id="{DEB6AC59-8253-48F0-A7F3-8047226B784F}"/>
               </a:ext>
             </a:extLst>
           </p:cNvPr>
@@ -4670,21 +4633,161 @@
           <p:nvPr/>
         </p:nvGraphicFramePr>
         <p:xfrm>
-          <a:off xmlns:a="http://schemas.openxmlformats.org/drawingml/2006/main" x="6105525" y="1714500"/>
-          <a:ext xmlns:a="http://schemas.openxmlformats.org/drawingml/2006/main" cx="5619750" cy="4381500"/>
+          <a:off xmlns:a="http://schemas.openxmlformats.org/drawingml/2006/main" x="7029450" y="1905000"/>
+          <a:ext xmlns:a="http://schemas.openxmlformats.org/drawingml/2006/main" cx="4762500" cy="4095750"/>
         </p:xfrm>
         <a:graphic xmlns:a="http://schemas.openxmlformats.org/drawingml/2006/main">
           <a:graphicData uri="http://schemas.openxmlformats.org/drawingml/2006/chart">
-            <c:chart xmlns:r="http://schemas.openxmlformats.org/officeDocument/2006/relationships" xmlns:c="http://schemas.openxmlformats.org/drawingml/2006/chart" r:id="R244b832da49b464e"/>
+            <c:chart xmlns:r="http://schemas.openxmlformats.org/officeDocument/2006/relationships" xmlns:c="http://schemas.openxmlformats.org/drawingml/2006/chart" r:id="R99eefdff61c34949"/>
           </a:graphicData>
         </a:graphic>
       </p:graphicFrame>
-      <p:sp>
-        <p:nvSpPr>
+      <p:pic>
+        <p:nvPicPr>
           <p:cNvPr id="10" name="">
             <a:extLst xmlns:a="http://schemas.openxmlformats.org/drawingml/2006/main">
               <a:ext uri="{FF2B5EF4-FFF2-40B4-BE49-F238E27FC236}">
-                <a16:creationId xmlns:a16="http://schemas.microsoft.com/office/drawing/2014/main" id="{E85E95C0-354D-49C3-940F-AED7BF49BBCC}"/>
+                <a16:creationId xmlns:a16="http://schemas.microsoft.com/office/drawing/2014/main" id="{66B41D22-2385-4D72-8BE6-19849394E6A8}"/>
+              </a:ext>
+            </a:extLst>
+          </p:cNvPr>
+          <p:cNvPicPr>
+            <a:picLocks xmlns:a="http://schemas.openxmlformats.org/drawingml/2006/main" noChangeAspect="1"/>
+          </p:cNvPicPr>
+          <p:nvPr/>
+        </p:nvPicPr>
+        <p:blipFill>
+          <a:blip xmlns:r="http://schemas.openxmlformats.org/officeDocument/2006/relationships" xmlns:a="http://schemas.openxmlformats.org/drawingml/2006/main" r:embed="R076b0b1f2aca40a5"/>
+          <a:stretch xmlns:a="http://schemas.openxmlformats.org/drawingml/2006/main"/>
+        </p:blipFill>
+        <p:spPr>
+          <a:xfrm xmlns:a="http://schemas.openxmlformats.org/drawingml/2006/main">
+            <a:off x="6248400" y="2143125"/>
+            <a:ext cx="571500" cy="571500"/>
+          </a:xfrm>
+          <a:prstGeom xmlns:a="http://schemas.openxmlformats.org/drawingml/2006/main" prst="rect">
+            <a:avLst/>
+          </a:prstGeom>
+        </p:spPr>
+      </p:pic>
+      <p:pic>
+        <p:nvPicPr>
+          <p:cNvPr id="11" name="">
+            <a:extLst xmlns:a="http://schemas.openxmlformats.org/drawingml/2006/main">
+              <a:ext uri="{FF2B5EF4-FFF2-40B4-BE49-F238E27FC236}">
+                <a16:creationId xmlns:a16="http://schemas.microsoft.com/office/drawing/2014/main" id="{D0FBBB19-6837-4957-B514-10559470B6F0}"/>
+              </a:ext>
+            </a:extLst>
+          </p:cNvPr>
+          <p:cNvPicPr>
+            <a:picLocks xmlns:a="http://schemas.openxmlformats.org/drawingml/2006/main" noChangeAspect="1"/>
+          </p:cNvPicPr>
+          <p:nvPr/>
+        </p:nvPicPr>
+        <p:blipFill>
+          <a:blip xmlns:r="http://schemas.openxmlformats.org/officeDocument/2006/relationships" xmlns:a="http://schemas.openxmlformats.org/drawingml/2006/main" r:embed="R5d7bec33ce254510"/>
+          <a:stretch xmlns:a="http://schemas.openxmlformats.org/drawingml/2006/main"/>
+        </p:blipFill>
+        <p:spPr>
+          <a:xfrm xmlns:a="http://schemas.openxmlformats.org/drawingml/2006/main">
+            <a:off x="6248400" y="2762250"/>
+            <a:ext cx="571500" cy="571500"/>
+          </a:xfrm>
+          <a:prstGeom xmlns:a="http://schemas.openxmlformats.org/drawingml/2006/main" prst="rect">
+            <a:avLst/>
+          </a:prstGeom>
+        </p:spPr>
+      </p:pic>
+      <p:pic>
+        <p:nvPicPr>
+          <p:cNvPr id="12" name="">
+            <a:extLst xmlns:a="http://schemas.openxmlformats.org/drawingml/2006/main">
+              <a:ext uri="{FF2B5EF4-FFF2-40B4-BE49-F238E27FC236}">
+                <a16:creationId xmlns:a16="http://schemas.microsoft.com/office/drawing/2014/main" id="{1DC4DE74-A139-4728-A80C-248D53350D2B}"/>
+              </a:ext>
+            </a:extLst>
+          </p:cNvPr>
+          <p:cNvPicPr>
+            <a:picLocks xmlns:a="http://schemas.openxmlformats.org/drawingml/2006/main" noChangeAspect="1"/>
+          </p:cNvPicPr>
+          <p:nvPr/>
+        </p:nvPicPr>
+        <p:blipFill>
+          <a:blip xmlns:r="http://schemas.openxmlformats.org/officeDocument/2006/relationships" xmlns:a="http://schemas.openxmlformats.org/drawingml/2006/main" r:embed="Rbd6ef7c14f384054"/>
+          <a:stretch xmlns:a="http://schemas.openxmlformats.org/drawingml/2006/main"/>
+        </p:blipFill>
+        <p:spPr>
+          <a:xfrm xmlns:a="http://schemas.openxmlformats.org/drawingml/2006/main">
+            <a:off x="6248400" y="3381375"/>
+            <a:ext cx="571500" cy="571500"/>
+          </a:xfrm>
+          <a:prstGeom xmlns:a="http://schemas.openxmlformats.org/drawingml/2006/main" prst="rect">
+            <a:avLst/>
+          </a:prstGeom>
+        </p:spPr>
+      </p:pic>
+      <p:pic>
+        <p:nvPicPr>
+          <p:cNvPr id="13" name="">
+            <a:extLst xmlns:a="http://schemas.openxmlformats.org/drawingml/2006/main">
+              <a:ext uri="{FF2B5EF4-FFF2-40B4-BE49-F238E27FC236}">
+                <a16:creationId xmlns:a16="http://schemas.microsoft.com/office/drawing/2014/main" id="{37668EE8-49B8-4283-A4B9-1296E4F481EC}"/>
+              </a:ext>
+            </a:extLst>
+          </p:cNvPr>
+          <p:cNvPicPr>
+            <a:picLocks xmlns:a="http://schemas.openxmlformats.org/drawingml/2006/main" noChangeAspect="1"/>
+          </p:cNvPicPr>
+          <p:nvPr/>
+        </p:nvPicPr>
+        <p:blipFill>
+          <a:blip xmlns:r="http://schemas.openxmlformats.org/officeDocument/2006/relationships" xmlns:a="http://schemas.openxmlformats.org/drawingml/2006/main" r:embed="Rfc5c9232a452436e"/>
+          <a:stretch xmlns:a="http://schemas.openxmlformats.org/drawingml/2006/main"/>
+        </p:blipFill>
+        <p:spPr>
+          <a:xfrm xmlns:a="http://schemas.openxmlformats.org/drawingml/2006/main">
+            <a:off x="6248400" y="4000500"/>
+            <a:ext cx="571500" cy="571500"/>
+          </a:xfrm>
+          <a:prstGeom xmlns:a="http://schemas.openxmlformats.org/drawingml/2006/main" prst="rect">
+            <a:avLst/>
+          </a:prstGeom>
+        </p:spPr>
+      </p:pic>
+      <p:pic>
+        <p:nvPicPr>
+          <p:cNvPr id="14" name="">
+            <a:extLst xmlns:a="http://schemas.openxmlformats.org/drawingml/2006/main">
+              <a:ext uri="{FF2B5EF4-FFF2-40B4-BE49-F238E27FC236}">
+                <a16:creationId xmlns:a16="http://schemas.microsoft.com/office/drawing/2014/main" id="{3C6E59B5-1528-43D6-A222-5B637B1197E3}"/>
+              </a:ext>
+            </a:extLst>
+          </p:cNvPr>
+          <p:cNvPicPr>
+            <a:picLocks xmlns:a="http://schemas.openxmlformats.org/drawingml/2006/main" noChangeAspect="1"/>
+          </p:cNvPicPr>
+          <p:nvPr/>
+        </p:nvPicPr>
+        <p:blipFill>
+          <a:blip xmlns:r="http://schemas.openxmlformats.org/officeDocument/2006/relationships" xmlns:a="http://schemas.openxmlformats.org/drawingml/2006/main" r:embed="Rbc5276746c444788"/>
+          <a:stretch xmlns:a="http://schemas.openxmlformats.org/drawingml/2006/main"/>
+        </p:blipFill>
+        <p:spPr>
+          <a:xfrm xmlns:a="http://schemas.openxmlformats.org/drawingml/2006/main">
+            <a:off x="6248400" y="4619625"/>
+            <a:ext cx="571500" cy="571500"/>
+          </a:xfrm>
+          <a:prstGeom xmlns:a="http://schemas.openxmlformats.org/drawingml/2006/main" prst="rect">
+            <a:avLst/>
+          </a:prstGeom>
+        </p:spPr>
+      </p:pic>
+      <p:sp>
+        <p:nvSpPr>
+          <p:cNvPr id="15" name="">
+            <a:extLst xmlns:a="http://schemas.openxmlformats.org/drawingml/2006/main">
+              <a:ext uri="{FF2B5EF4-FFF2-40B4-BE49-F238E27FC236}">
+                <a16:creationId xmlns:a16="http://schemas.microsoft.com/office/drawing/2014/main" id="{4588C76F-3248-4480-9C9E-EEFBFF31A6E6}"/>
               </a:ext>
             </a:extLst>
           </p:cNvPr>
@@ -4695,8 +4798,8 @@
         </p:nvSpPr>
         <p:spPr>
           <a:xfrm xmlns:a="http://schemas.openxmlformats.org/drawingml/2006/main">
-            <a:off x="6429375" y="6315075"/>
-            <a:ext cx="5238750" cy="333375"/>
+            <a:off x="6124575" y="6362700"/>
+            <a:ext cx="5619750" cy="333375"/>
           </a:xfrm>
           <a:prstGeom xmlns:a="http://schemas.openxmlformats.org/drawingml/2006/main" prst="rect">
             <a:avLst/>
@@ -4710,7 +4813,7 @@
           <a:bodyPr xmlns:a="http://schemas.openxmlformats.org/drawingml/2006/main" lIns="0" tIns="0" rIns="0" bIns="0"/>
           <a:lstStyle xmlns:a="http://schemas.openxmlformats.org/drawingml/2006/main">
             <a:defPPr>
-              <a:defRPr sz="1650">
+              <a:defRPr sz="1725">
                 <a:solidFill>
                   <a:srgbClr val="81796F"/>
                 </a:solidFill>
@@ -4722,7 +4825,7 @@
           </a:lstStyle>
           <a:p xmlns:a="http://schemas.openxmlformats.org/drawingml/2006/main">
             <a:pPr>
-              <a:defRPr sz="1650">
+              <a:defRPr sz="1725">
                 <a:solidFill>
                   <a:srgbClr val="81796F"/>
                 </a:solidFill>
@@ -4732,7 +4835,7 @@
               </a:defRPr>
             </a:pPr>
             <a:r>
-              <a:rPr sz="1650">
+              <a:rPr sz="1725">
                 <a:solidFill>
                   <a:srgbClr val="81796F"/>
                 </a:solidFill>
@@ -4740,7 +4843,7 @@
                 <a:ea typeface="Ubuntu Condensed"/>
                 <a:cs typeface="Ubuntu Condensed"/>
               </a:rPr>
-              <a:t>Generation 1 · 151 species · primary type only</a:t>
+              <a:t>Rows hold one name and one image per Pokémon.</a:t>
             </a:r>
           </a:p>
         </p:txBody>
@@ -4748,7 +4851,7 @@
     </p:spTree>
     <p:extLst>
       <p:ext uri="{BB962C8B-B14F-4D97-AF65-F5344CB8AC3E}">
-        <p14:creationId xmlns:p14="http://schemas.microsoft.com/office/powerpoint/2010/main" val="1821394164"/>
+        <p14:creationId xmlns:p14="http://schemas.microsoft.com/office/powerpoint/2010/main" val="459308524"/>
       </p:ext>
     </p:extLst>
   </p:cSld>

</xml_diff>

<commit_message>
Clarify Pokemon image chart with numbered Tableau steps
</commit_message>
<xml_diff>
--- a/lectures/w04-pokemon-challenge.pptx
+++ b/lectures/w04-pokemon-challenge.pptx
@@ -2,15 +2,15 @@
 <file path=ppt/presentation.xml><?xml version="1.0" encoding="utf-8"?>
 <p:presentation xmlns:p="http://schemas.openxmlformats.org/presentationml/2006/main">
   <p:sldMasterIdLst>
-    <p:sldMasterId xmlns:r="http://schemas.openxmlformats.org/officeDocument/2006/relationships" id="2147483648" r:id="Rcf9865cc384449bc"/>
+    <p:sldMasterId xmlns:r="http://schemas.openxmlformats.org/officeDocument/2006/relationships" id="2147483648" r:id="R42b85e33e1e54779"/>
   </p:sldMasterIdLst>
   <p:notesMasterIdLst>
-    <p:notesMasterId xmlns:r="http://schemas.openxmlformats.org/officeDocument/2006/relationships" r:id="R8c24d137fe48436c"/>
+    <p:notesMasterId xmlns:r="http://schemas.openxmlformats.org/officeDocument/2006/relationships" r:id="Reac203914dfe4fc1"/>
   </p:notesMasterIdLst>
   <p:sldIdLst>
-    <p:sldId xmlns:r="http://schemas.openxmlformats.org/officeDocument/2006/relationships" id="256" r:id="R1276fc5fcb644cf1"/>
-    <p:sldId xmlns:r="http://schemas.openxmlformats.org/officeDocument/2006/relationships" id="257" r:id="Rd7bebddbb1334343"/>
-    <p:sldId xmlns:r="http://schemas.openxmlformats.org/officeDocument/2006/relationships" id="258" r:id="Rf0de1584fa394861"/>
+    <p:sldId xmlns:r="http://schemas.openxmlformats.org/officeDocument/2006/relationships" id="256" r:id="Rbc09dc49d740467a"/>
+    <p:sldId xmlns:r="http://schemas.openxmlformats.org/officeDocument/2006/relationships" id="257" r:id="Rb7df2abb5bcc4bfa"/>
+    <p:sldId xmlns:r="http://schemas.openxmlformats.org/officeDocument/2006/relationships" id="258" r:id="Rda0051ce054b483c"/>
   </p:sldIdLst>
   <p:sldSz cx="12192000" cy="6858000"/>
   <p:notesSz cx="6858000" cy="9144000"/>
@@ -631,7 +631,7 @@
           <p:cNvPr id="3" name="Title">
             <a:extLst xmlns:a="http://schemas.openxmlformats.org/drawingml/2006/main">
               <a:ext uri="{FF2B5EF4-FFF2-40B4-BE49-F238E27FC236}">
-                <a16:creationId xmlns:a16="http://schemas.microsoft.com/office/drawing/2014/main" id="{4548CAA9-697A-466F-AB2B-B32951D0E5CC}"/>
+                <a16:creationId xmlns:a16="http://schemas.microsoft.com/office/drawing/2014/main" id="{9E6A16A5-1EA1-422D-9EBC-2B452E401705}"/>
               </a:ext>
             </a:extLst>
           </p:cNvPr>
@@ -788,7 +788,7 @@
           <p:cNvPr id="2" name="Subtitle">
             <a:extLst xmlns:a="http://schemas.openxmlformats.org/drawingml/2006/main">
               <a:ext uri="{FF2B5EF4-FFF2-40B4-BE49-F238E27FC236}">
-                <a16:creationId xmlns:a16="http://schemas.microsoft.com/office/drawing/2014/main" id="{1D3AFA94-E1DA-4C3F-94A0-F3112F9C6D47}"/>
+                <a16:creationId xmlns:a16="http://schemas.microsoft.com/office/drawing/2014/main" id="{7B972DD4-C0BA-47C4-AEB7-3FC23A08354A}"/>
               </a:ext>
             </a:extLst>
           </p:cNvPr>
@@ -962,7 +962,7 @@
           <p:cNvPr id="2" name="Section title">
             <a:extLst xmlns:a="http://schemas.openxmlformats.org/drawingml/2006/main">
               <a:ext uri="{FF2B5EF4-FFF2-40B4-BE49-F238E27FC236}">
-                <a16:creationId xmlns:a16="http://schemas.microsoft.com/office/drawing/2014/main" id="{98E7FC82-2300-4F04-8169-11B0F2969E4A}"/>
+                <a16:creationId xmlns:a16="http://schemas.microsoft.com/office/drawing/2014/main" id="{03C8890A-4590-4797-905D-80A57F60AA62}"/>
               </a:ext>
             </a:extLst>
           </p:cNvPr>
@@ -1136,7 +1136,7 @@
           <p:cNvPr id="3" name="Title">
             <a:extLst xmlns:a="http://schemas.openxmlformats.org/drawingml/2006/main">
               <a:ext uri="{FF2B5EF4-FFF2-40B4-BE49-F238E27FC236}">
-                <a16:creationId xmlns:a16="http://schemas.microsoft.com/office/drawing/2014/main" id="{E9F3FFAF-B9C4-48E5-87AB-4E3D0A7E4E81}"/>
+                <a16:creationId xmlns:a16="http://schemas.microsoft.com/office/drawing/2014/main" id="{81FA3425-36BF-4889-B987-F8B3E35772BD}"/>
               </a:ext>
             </a:extLst>
           </p:cNvPr>
@@ -1293,7 +1293,7 @@
           <p:cNvPr id="2" name="Body">
             <a:extLst xmlns:a="http://schemas.openxmlformats.org/drawingml/2006/main">
               <a:ext uri="{FF2B5EF4-FFF2-40B4-BE49-F238E27FC236}">
-                <a16:creationId xmlns:a16="http://schemas.microsoft.com/office/drawing/2014/main" id="{C5827725-E960-43F7-B7F1-2942A192EBD0}"/>
+                <a16:creationId xmlns:a16="http://schemas.microsoft.com/office/drawing/2014/main" id="{38F52B01-F568-4A2C-8936-E974507DB71D}"/>
               </a:ext>
             </a:extLst>
           </p:cNvPr>
@@ -1467,7 +1467,7 @@
           <p:cNvPr id="4" name="Title">
             <a:extLst xmlns:a="http://schemas.openxmlformats.org/drawingml/2006/main">
               <a:ext uri="{FF2B5EF4-FFF2-40B4-BE49-F238E27FC236}">
-                <a16:creationId xmlns:a16="http://schemas.microsoft.com/office/drawing/2014/main" id="{889BA6FD-FC76-49CB-A711-258E21F39CAE}"/>
+                <a16:creationId xmlns:a16="http://schemas.microsoft.com/office/drawing/2014/main" id="{4E18C594-2A00-4125-90CC-39270134D46A}"/>
               </a:ext>
             </a:extLst>
           </p:cNvPr>
@@ -1624,7 +1624,7 @@
           <p:cNvPr id="2" name="Left column">
             <a:extLst xmlns:a="http://schemas.openxmlformats.org/drawingml/2006/main">
               <a:ext uri="{FF2B5EF4-FFF2-40B4-BE49-F238E27FC236}">
-                <a16:creationId xmlns:a16="http://schemas.microsoft.com/office/drawing/2014/main" id="{CE592BE3-413D-408E-A516-5400A252FA3A}"/>
+                <a16:creationId xmlns:a16="http://schemas.microsoft.com/office/drawing/2014/main" id="{77EE469F-8D5E-4B96-9650-354FC03A7020}"/>
               </a:ext>
             </a:extLst>
           </p:cNvPr>
@@ -1781,7 +1781,7 @@
           <p:cNvPr id="3" name="Right column">
             <a:extLst xmlns:a="http://schemas.openxmlformats.org/drawingml/2006/main">
               <a:ext uri="{FF2B5EF4-FFF2-40B4-BE49-F238E27FC236}">
-                <a16:creationId xmlns:a16="http://schemas.microsoft.com/office/drawing/2014/main" id="{3CD816BB-2D89-45C1-9AD1-8BFFE06FC173}"/>
+                <a16:creationId xmlns:a16="http://schemas.microsoft.com/office/drawing/2014/main" id="{159CB76F-83A3-4A06-81B9-9166C3DF32A1}"/>
               </a:ext>
             </a:extLst>
           </p:cNvPr>
@@ -1955,7 +1955,7 @@
           <p:cNvPr id="3" name="Title">
             <a:extLst xmlns:a="http://schemas.openxmlformats.org/drawingml/2006/main">
               <a:ext uri="{FF2B5EF4-FFF2-40B4-BE49-F238E27FC236}">
-                <a16:creationId xmlns:a16="http://schemas.microsoft.com/office/drawing/2014/main" id="{FD564569-30CD-4AF9-99F7-F32DA85FF120}"/>
+                <a16:creationId xmlns:a16="http://schemas.microsoft.com/office/drawing/2014/main" id="{B2AC331E-73DD-401E-93E9-96022C277CCE}"/>
               </a:ext>
             </a:extLst>
           </p:cNvPr>
@@ -2112,7 +2112,7 @@
           <p:cNvPr id="2" name="Left column">
             <a:extLst xmlns:a="http://schemas.openxmlformats.org/drawingml/2006/main">
               <a:ext uri="{FF2B5EF4-FFF2-40B4-BE49-F238E27FC236}">
-                <a16:creationId xmlns:a16="http://schemas.microsoft.com/office/drawing/2014/main" id="{65E32D35-F719-4B49-9F14-5562D0E81F08}"/>
+                <a16:creationId xmlns:a16="http://schemas.microsoft.com/office/drawing/2014/main" id="{809373CC-24FC-47A3-9C11-6F676DFB6496}"/>
               </a:ext>
             </a:extLst>
           </p:cNvPr>
@@ -2307,12 +2307,12 @@
   </p:cSld>
   <p:clrMap bg1="lt1" tx1="dk1" bg2="lt2" tx2="dk2" accent1="accent1" accent2="accent2" accent3="accent3" accent4="accent4" accent5="accent5" accent6="accent6" hlink="hlink" folHlink="folHlink"/>
   <p:sldLayoutIdLst>
-    <p:sldLayoutId xmlns:r="http://schemas.openxmlformats.org/officeDocument/2006/relationships" id="2147483649" r:id="Rf9e3bcd6619946ac"/>
-    <p:sldLayoutId xmlns:r="http://schemas.openxmlformats.org/officeDocument/2006/relationships" id="2147483650" r:id="R837bbf99ae89420f"/>
-    <p:sldLayoutId xmlns:r="http://schemas.openxmlformats.org/officeDocument/2006/relationships" id="2147483651" r:id="R2057b59a14cf4f2e"/>
-    <p:sldLayoutId xmlns:r="http://schemas.openxmlformats.org/officeDocument/2006/relationships" id="2147483652" r:id="Rf797418c6ee04a9f"/>
-    <p:sldLayoutId xmlns:r="http://schemas.openxmlformats.org/officeDocument/2006/relationships" id="2147483653" r:id="R01441d9c5d8a4a83"/>
-    <p:sldLayoutId xmlns:r="http://schemas.openxmlformats.org/officeDocument/2006/relationships" id="2147483654" r:id="R7c02a0e088874c4c"/>
+    <p:sldLayoutId xmlns:r="http://schemas.openxmlformats.org/officeDocument/2006/relationships" id="2147483649" r:id="Rd628f78650134955"/>
+    <p:sldLayoutId xmlns:r="http://schemas.openxmlformats.org/officeDocument/2006/relationships" id="2147483650" r:id="R11c962e8c84b4f8f"/>
+    <p:sldLayoutId xmlns:r="http://schemas.openxmlformats.org/officeDocument/2006/relationships" id="2147483651" r:id="R0fe36e1a58184747"/>
+    <p:sldLayoutId xmlns:r="http://schemas.openxmlformats.org/officeDocument/2006/relationships" id="2147483652" r:id="Rc6c893cef72e409e"/>
+    <p:sldLayoutId xmlns:r="http://schemas.openxmlformats.org/officeDocument/2006/relationships" id="2147483653" r:id="Ra67651ab1e9540ea"/>
+    <p:sldLayoutId xmlns:r="http://schemas.openxmlformats.org/officeDocument/2006/relationships" id="2147483654" r:id="R933733d7686442af"/>
   </p:sldLayoutIdLst>
   <p:txStyles>
     <p:titleStyle>
@@ -3101,7 +3101,7 @@
           <p:cNvPr id="2" name="">
             <a:extLst xmlns:a="http://schemas.openxmlformats.org/drawingml/2006/main">
               <a:ext uri="{FF2B5EF4-FFF2-40B4-BE49-F238E27FC236}">
-                <a16:creationId xmlns:a16="http://schemas.microsoft.com/office/drawing/2014/main" id="{F44438EC-06B3-4E8E-A8AE-62A2314059E5}"/>
+                <a16:creationId xmlns:a16="http://schemas.microsoft.com/office/drawing/2014/main" id="{3F0200C2-4D25-456B-BFAE-5199D8B06493}"/>
               </a:ext>
             </a:extLst>
           </p:cNvPr>
@@ -3111,7 +3111,7 @@
           <p:nvPr/>
         </p:nvPicPr>
         <p:blipFill>
-          <a:blip xmlns:r="http://schemas.openxmlformats.org/officeDocument/2006/relationships" xmlns:a="http://schemas.openxmlformats.org/drawingml/2006/main" r:embed="R6beda985300b45fa"/>
+          <a:blip xmlns:r="http://schemas.openxmlformats.org/officeDocument/2006/relationships" xmlns:a="http://schemas.openxmlformats.org/drawingml/2006/main" r:embed="R160a02902aca44de"/>
           <a:stretch xmlns:a="http://schemas.openxmlformats.org/drawingml/2006/main"/>
         </p:blipFill>
         <p:spPr>
@@ -3127,7 +3127,7 @@
     </p:spTree>
     <p:extLst>
       <p:ext uri="{BB962C8B-B14F-4D97-AF65-F5344CB8AC3E}">
-        <p14:creationId xmlns:p14="http://schemas.microsoft.com/office/powerpoint/2010/main" val="820940641"/>
+        <p14:creationId xmlns:p14="http://schemas.microsoft.com/office/powerpoint/2010/main" val="1505657211"/>
       </p:ext>
     </p:extLst>
   </p:cSld>
@@ -3158,7 +3158,7 @@
           <p:cNvPr id="12" name="">
             <a:extLst xmlns:a="http://schemas.openxmlformats.org/drawingml/2006/main">
               <a:ext uri="{FF2B5EF4-FFF2-40B4-BE49-F238E27FC236}">
-                <a16:creationId xmlns:a16="http://schemas.microsoft.com/office/drawing/2014/main" id="{3650F159-3FCC-411E-858F-FD28FC2AB5BD}"/>
+                <a16:creationId xmlns:a16="http://schemas.microsoft.com/office/drawing/2014/main" id="{699EC380-0FA9-4B01-9CBE-09442B2F48FC}"/>
               </a:ext>
             </a:extLst>
           </p:cNvPr>
@@ -3224,7 +3224,7 @@
           <p:cNvPr id="2" name="">
             <a:extLst xmlns:a="http://schemas.openxmlformats.org/drawingml/2006/main">
               <a:ext uri="{FF2B5EF4-FFF2-40B4-BE49-F238E27FC236}">
-                <a16:creationId xmlns:a16="http://schemas.microsoft.com/office/drawing/2014/main" id="{7822F6D4-4877-40C4-A9ED-4B6C4A0D64EB}"/>
+                <a16:creationId xmlns:a16="http://schemas.microsoft.com/office/drawing/2014/main" id="{220E1D04-947B-4E2C-BE9C-D8620B79215A}"/>
               </a:ext>
             </a:extLst>
           </p:cNvPr>
@@ -3290,7 +3290,7 @@
           <p:cNvPr id="3" name="">
             <a:extLst xmlns:a="http://schemas.openxmlformats.org/drawingml/2006/main">
               <a:ext uri="{FF2B5EF4-FFF2-40B4-BE49-F238E27FC236}">
-                <a16:creationId xmlns:a16="http://schemas.microsoft.com/office/drawing/2014/main" id="{4A2920BF-B064-42DA-AEEA-ED96998C7947}"/>
+                <a16:creationId xmlns:a16="http://schemas.microsoft.com/office/drawing/2014/main" id="{8A3DFEF7-6D99-453C-B4E9-22C32072162D}"/>
               </a:ext>
             </a:extLst>
           </p:cNvPr>
@@ -3356,7 +3356,7 @@
           <p:cNvPr id="4" name="">
             <a:extLst xmlns:a="http://schemas.openxmlformats.org/drawingml/2006/main">
               <a:ext uri="{FF2B5EF4-FFF2-40B4-BE49-F238E27FC236}">
-                <a16:creationId xmlns:a16="http://schemas.microsoft.com/office/drawing/2014/main" id="{C430F238-77F8-42F1-AEB8-6764B14A6786}"/>
+                <a16:creationId xmlns:a16="http://schemas.microsoft.com/office/drawing/2014/main" id="{739FB109-EB92-46FF-B9F3-3CFE89B0270F}"/>
               </a:ext>
             </a:extLst>
           </p:cNvPr>
@@ -3445,7 +3445,7 @@
           <p:cNvPr id="5" name="">
             <a:extLst xmlns:a="http://schemas.openxmlformats.org/drawingml/2006/main">
               <a:ext uri="{FF2B5EF4-FFF2-40B4-BE49-F238E27FC236}">
-                <a16:creationId xmlns:a16="http://schemas.microsoft.com/office/drawing/2014/main" id="{35ED04CF-E913-4AF9-BF26-F91BA000FC7F}"/>
+                <a16:creationId xmlns:a16="http://schemas.microsoft.com/office/drawing/2014/main" id="{95E9BAD4-1906-44CB-B589-D9F6357602FA}"/>
               </a:ext>
             </a:extLst>
           </p:cNvPr>
@@ -3511,7 +3511,7 @@
           <p:cNvPr id="6" name="">
             <a:extLst xmlns:a="http://schemas.openxmlformats.org/drawingml/2006/main">
               <a:ext uri="{FF2B5EF4-FFF2-40B4-BE49-F238E27FC236}">
-                <a16:creationId xmlns:a16="http://schemas.microsoft.com/office/drawing/2014/main" id="{AF09BD06-20FD-439E-86EA-931BBD9191BE}"/>
+                <a16:creationId xmlns:a16="http://schemas.microsoft.com/office/drawing/2014/main" id="{DA4EFA99-4874-4014-B787-233FAEB276B9}"/>
               </a:ext>
             </a:extLst>
           </p:cNvPr>
@@ -3600,7 +3600,7 @@
           <p:cNvPr id="7" name="">
             <a:extLst xmlns:a="http://schemas.openxmlformats.org/drawingml/2006/main">
               <a:ext uri="{FF2B5EF4-FFF2-40B4-BE49-F238E27FC236}">
-                <a16:creationId xmlns:a16="http://schemas.microsoft.com/office/drawing/2014/main" id="{E054A4B9-4E29-4488-A662-C0A6302FD4A7}"/>
+                <a16:creationId xmlns:a16="http://schemas.microsoft.com/office/drawing/2014/main" id="{C62AC0DF-DB02-41DE-B4FD-BE3948CA9A03}"/>
               </a:ext>
             </a:extLst>
           </p:cNvPr>
@@ -3666,7 +3666,7 @@
           <p:cNvPr id="8" name="">
             <a:extLst xmlns:a="http://schemas.openxmlformats.org/drawingml/2006/main">
               <a:ext uri="{FF2B5EF4-FFF2-40B4-BE49-F238E27FC236}">
-                <a16:creationId xmlns:a16="http://schemas.microsoft.com/office/drawing/2014/main" id="{09D58379-8EC8-47B1-A9AE-E99A568374E1}"/>
+                <a16:creationId xmlns:a16="http://schemas.microsoft.com/office/drawing/2014/main" id="{2333FEC7-AD6D-4E37-B12F-7313364FD0C8}"/>
               </a:ext>
             </a:extLst>
           </p:cNvPr>
@@ -3755,7 +3755,7 @@
           <p:cNvPr id="9" name="">
             <a:extLst xmlns:a="http://schemas.openxmlformats.org/drawingml/2006/main">
               <a:ext uri="{FF2B5EF4-FFF2-40B4-BE49-F238E27FC236}">
-                <a16:creationId xmlns:a16="http://schemas.microsoft.com/office/drawing/2014/main" id="{C11C46FD-CDC9-4125-85DB-A26504937B2F}"/>
+                <a16:creationId xmlns:a16="http://schemas.microsoft.com/office/drawing/2014/main" id="{1E22F48E-76A5-46D3-A3B4-C2224B1AB2E3}"/>
               </a:ext>
             </a:extLst>
           </p:cNvPr>
@@ -3821,7 +3821,7 @@
           <p:cNvPr id="10" name="">
             <a:extLst xmlns:a="http://schemas.openxmlformats.org/drawingml/2006/main">
               <a:ext uri="{FF2B5EF4-FFF2-40B4-BE49-F238E27FC236}">
-                <a16:creationId xmlns:a16="http://schemas.microsoft.com/office/drawing/2014/main" id="{1678E336-B4FC-4E79-A556-6A6137573562}"/>
+                <a16:creationId xmlns:a16="http://schemas.microsoft.com/office/drawing/2014/main" id="{E64D690C-EC5A-4E31-8081-32A46D8E8003}"/>
               </a:ext>
             </a:extLst>
           </p:cNvPr>
@@ -3887,7 +3887,7 @@
           <p:cNvPr id="11" name="">
             <a:extLst xmlns:a="http://schemas.openxmlformats.org/drawingml/2006/main">
               <a:ext uri="{FF2B5EF4-FFF2-40B4-BE49-F238E27FC236}">
-                <a16:creationId xmlns:a16="http://schemas.microsoft.com/office/drawing/2014/main" id="{8848D4D1-0FFB-4F10-926C-FFE10DA277EA}"/>
+                <a16:creationId xmlns:a16="http://schemas.microsoft.com/office/drawing/2014/main" id="{BB3441EC-757B-4EE4-B92C-414577688F96}"/>
               </a:ext>
             </a:extLst>
           </p:cNvPr>
@@ -3951,7 +3951,7 @@
     </p:spTree>
     <p:extLst>
       <p:ext uri="{BB962C8B-B14F-4D97-AF65-F5344CB8AC3E}">
-        <p14:creationId xmlns:p14="http://schemas.microsoft.com/office/powerpoint/2010/main" val="1571833073"/>
+        <p14:creationId xmlns:p14="http://schemas.microsoft.com/office/powerpoint/2010/main" val="1086971844"/>
       </p:ext>
     </p:extLst>
   </p:cSld>
@@ -3979,10 +3979,10 @@
       </p:grpSpPr>
       <p:sp>
         <p:nvSpPr>
-          <p:cNvPr id="16" name="">
+          <p:cNvPr id="31" name="">
             <a:extLst xmlns:a="http://schemas.openxmlformats.org/drawingml/2006/main">
               <a:ext uri="{FF2B5EF4-FFF2-40B4-BE49-F238E27FC236}">
-                <a16:creationId xmlns:a16="http://schemas.microsoft.com/office/drawing/2014/main" id="{2ED063D3-DE9B-4D9B-97AC-D6C294324B16}"/>
+                <a16:creationId xmlns:a16="http://schemas.microsoft.com/office/drawing/2014/main" id="{85D0F02B-8D44-4595-856E-368D51DF2676}"/>
               </a:ext>
             </a:extLst>
           </p:cNvPr>
@@ -4048,7 +4048,7 @@
           <p:cNvPr id="2" name="">
             <a:extLst xmlns:a="http://schemas.openxmlformats.org/drawingml/2006/main">
               <a:ext uri="{FF2B5EF4-FFF2-40B4-BE49-F238E27FC236}">
-                <a16:creationId xmlns:a16="http://schemas.microsoft.com/office/drawing/2014/main" id="{B9835351-A7E8-4424-B06B-C3F4E44A5CB4}"/>
+                <a16:creationId xmlns:a16="http://schemas.microsoft.com/office/drawing/2014/main" id="{3E7D0452-74A2-43C1-8009-F6D72B2C53D5}"/>
               </a:ext>
             </a:extLst>
           </p:cNvPr>
@@ -4114,7 +4114,7 @@
           <p:cNvPr id="3" name="">
             <a:extLst xmlns:a="http://schemas.openxmlformats.org/drawingml/2006/main">
               <a:ext uri="{FF2B5EF4-FFF2-40B4-BE49-F238E27FC236}">
-                <a16:creationId xmlns:a16="http://schemas.microsoft.com/office/drawing/2014/main" id="{BC5C4BE6-645B-4B1A-AF66-3D726EAC00E2}"/>
+                <a16:creationId xmlns:a16="http://schemas.microsoft.com/office/drawing/2014/main" id="{886E40D7-ACC5-4EDE-8450-01084D764096}"/>
               </a:ext>
             </a:extLst>
           </p:cNvPr>
@@ -4125,74 +4125,8 @@
         </p:nvSpPr>
         <p:spPr>
           <a:xfrm xmlns:a="http://schemas.openxmlformats.org/drawingml/2006/main">
-            <a:off x="457200" y="1724025"/>
-            <a:ext cx="5238750" cy="400050"/>
-          </a:xfrm>
-          <a:prstGeom xmlns:a="http://schemas.openxmlformats.org/drawingml/2006/main" prst="rect">
-            <a:avLst/>
-          </a:prstGeom>
-          <a:noFill xmlns:a="http://schemas.openxmlformats.org/drawingml/2006/main"/>
-          <a:ln xmlns:a="http://schemas.openxmlformats.org/drawingml/2006/main" w="0">
-            <a:noFill/>
-          </a:ln>
-        </p:spPr>
-        <p:txBody>
-          <a:bodyPr xmlns:a="http://schemas.openxmlformats.org/drawingml/2006/main" lIns="0" tIns="0" rIns="0" bIns="0"/>
-          <a:lstStyle xmlns:a="http://schemas.openxmlformats.org/drawingml/2006/main">
-            <a:defPPr>
-              <a:defRPr sz="2250">
-                <a:solidFill>
-                  <a:srgbClr val="B23C50"/>
-                </a:solidFill>
-                <a:latin typeface="Ubuntu Condensed"/>
-                <a:ea typeface="Ubuntu Condensed"/>
-                <a:cs typeface="Ubuntu Condensed"/>
-              </a:defRPr>
-            </a:defPPr>
-          </a:lstStyle>
-          <a:p xmlns:a="http://schemas.openxmlformats.org/drawingml/2006/main">
-            <a:pPr>
-              <a:defRPr sz="2250">
-                <a:solidFill>
-                  <a:srgbClr val="B23C50"/>
-                </a:solidFill>
-                <a:latin typeface="Ubuntu Condensed"/>
-                <a:ea typeface="Ubuntu Condensed"/>
-                <a:cs typeface="Ubuntu Condensed"/>
-              </a:defRPr>
-            </a:pPr>
-            <a:r>
-              <a:rPr sz="2250">
-                <a:solidFill>
-                  <a:srgbClr val="B23C50"/>
-                </a:solidFill>
-                <a:latin typeface="Ubuntu Condensed"/>
-                <a:ea typeface="Ubuntu Condensed"/>
-                <a:cs typeface="Ubuntu Condensed"/>
-              </a:rPr>
-              <a:t>1  Updated CSV + five names</a:t>
-            </a:r>
-          </a:p>
-        </p:txBody>
-      </p:sp>
-      <p:sp>
-        <p:nvSpPr>
-          <p:cNvPr id="4" name="">
-            <a:extLst xmlns:a="http://schemas.openxmlformats.org/drawingml/2006/main">
-              <a:ext uri="{FF2B5EF4-FFF2-40B4-BE49-F238E27FC236}">
-                <a16:creationId xmlns:a16="http://schemas.microsoft.com/office/drawing/2014/main" id="{52642A38-A08A-4E3A-AFD9-60265FAEB488}"/>
-              </a:ext>
-            </a:extLst>
-          </p:cNvPr>
-          <p:cNvSpPr>
-            <a:spLocks xmlns:a="http://schemas.openxmlformats.org/drawingml/2006/main" noGrp="1"/>
-          </p:cNvSpPr>
-          <p:nvPr/>
-        </p:nvSpPr>
-        <p:spPr>
-          <a:xfrm xmlns:a="http://schemas.openxmlformats.org/drawingml/2006/main">
-            <a:off x="457200" y="2171700"/>
-            <a:ext cx="5238750" cy="723900"/>
+            <a:off x="457200" y="1571625"/>
+            <a:ext cx="361950" cy="304800"/>
           </a:xfrm>
           <a:prstGeom xmlns:a="http://schemas.openxmlformats.org/drawingml/2006/main" prst="rect">
             <a:avLst/>
@@ -4208,7 +4142,7 @@
             <a:defPPr>
               <a:defRPr sz="2025">
                 <a:solidFill>
-                  <a:srgbClr val="38332E"/>
+                  <a:srgbClr val="B23C50"/>
                 </a:solidFill>
                 <a:latin typeface="Ubuntu Condensed"/>
                 <a:ea typeface="Ubuntu Condensed"/>
@@ -4220,7 +4154,7 @@
             <a:pPr>
               <a:defRPr sz="2025">
                 <a:solidFill>
-                  <a:srgbClr val="38332E"/>
+                  <a:srgbClr val="B23C50"/>
                 </a:solidFill>
                 <a:latin typeface="Ubuntu Condensed"/>
                 <a:ea typeface="Ubuntu Condensed"/>
@@ -4230,46 +4164,23 @@
             <a:r>
               <a:rPr sz="2025">
                 <a:solidFill>
-                  <a:srgbClr val="38332E"/>
+                  <a:srgbClr val="B23C50"/>
                 </a:solidFill>
                 <a:latin typeface="Ubuntu Condensed"/>
                 <a:ea typeface="Ubuntu Condensed"/>
                 <a:cs typeface="Ubuntu Condensed"/>
               </a:rPr>
-              <a:t>Filter Name: Bulbasaur, Charmander,</a:t>
-            </a:r>
-          </a:p>
-          <a:p xmlns:a="http://schemas.openxmlformats.org/drawingml/2006/main">
-            <a:pPr>
-              <a:defRPr sz="2025">
-                <a:solidFill>
-                  <a:srgbClr val="38332E"/>
-                </a:solidFill>
-                <a:latin typeface="Ubuntu Condensed"/>
-                <a:ea typeface="Ubuntu Condensed"/>
-                <a:cs typeface="Ubuntu Condensed"/>
-              </a:defRPr>
-            </a:pPr>
-            <a:r>
-              <a:rPr sz="2025">
-                <a:solidFill>
-                  <a:srgbClr val="38332E"/>
-                </a:solidFill>
-                <a:latin typeface="Ubuntu Condensed"/>
-                <a:ea typeface="Ubuntu Condensed"/>
-                <a:cs typeface="Ubuntu Condensed"/>
-              </a:rPr>
-              <a:t>Eevee, Pikachu and Squirtle.</a:t>
+              <a:t>01</a:t>
             </a:r>
           </a:p>
         </p:txBody>
       </p:sp>
       <p:sp>
         <p:nvSpPr>
-          <p:cNvPr id="5" name="">
+          <p:cNvPr id="4" name="">
             <a:extLst xmlns:a="http://schemas.openxmlformats.org/drawingml/2006/main">
               <a:ext uri="{FF2B5EF4-FFF2-40B4-BE49-F238E27FC236}">
-                <a16:creationId xmlns:a16="http://schemas.microsoft.com/office/drawing/2014/main" id="{2CDCDCBB-108E-4846-972F-337E7F1332AF}"/>
+                <a16:creationId xmlns:a16="http://schemas.microsoft.com/office/drawing/2014/main" id="{A8613F02-1E55-4280-A34D-EA5678931693}"/>
               </a:ext>
             </a:extLst>
           </p:cNvPr>
@@ -4280,74 +4191,8 @@
         </p:nvSpPr>
         <p:spPr>
           <a:xfrm xmlns:a="http://schemas.openxmlformats.org/drawingml/2006/main">
-            <a:off x="457200" y="3057525"/>
-            <a:ext cx="5238750" cy="400050"/>
-          </a:xfrm>
-          <a:prstGeom xmlns:a="http://schemas.openxmlformats.org/drawingml/2006/main" prst="rect">
-            <a:avLst/>
-          </a:prstGeom>
-          <a:noFill xmlns:a="http://schemas.openxmlformats.org/drawingml/2006/main"/>
-          <a:ln xmlns:a="http://schemas.openxmlformats.org/drawingml/2006/main" w="0">
-            <a:noFill/>
-          </a:ln>
-        </p:spPr>
-        <p:txBody>
-          <a:bodyPr xmlns:a="http://schemas.openxmlformats.org/drawingml/2006/main" lIns="0" tIns="0" rIns="0" bIns="0"/>
-          <a:lstStyle xmlns:a="http://schemas.openxmlformats.org/drawingml/2006/main">
-            <a:defPPr>
-              <a:defRPr sz="2250">
-                <a:solidFill>
-                  <a:srgbClr val="B23C50"/>
-                </a:solidFill>
-                <a:latin typeface="Ubuntu Condensed"/>
-                <a:ea typeface="Ubuntu Condensed"/>
-                <a:cs typeface="Ubuntu Condensed"/>
-              </a:defRPr>
-            </a:defPPr>
-          </a:lstStyle>
-          <a:p xmlns:a="http://schemas.openxmlformats.org/drawingml/2006/main">
-            <a:pPr>
-              <a:defRPr sz="2250">
-                <a:solidFill>
-                  <a:srgbClr val="B23C50"/>
-                </a:solidFill>
-                <a:latin typeface="Ubuntu Condensed"/>
-                <a:ea typeface="Ubuntu Condensed"/>
-                <a:cs typeface="Ubuntu Condensed"/>
-              </a:defRPr>
-            </a:pPr>
-            <a:r>
-              <a:rPr sz="2250">
-                <a:solidFill>
-                  <a:srgbClr val="B23C50"/>
-                </a:solidFill>
-                <a:latin typeface="Ubuntu Condensed"/>
-                <a:ea typeface="Ubuntu Condensed"/>
-                <a:cs typeface="Ubuntu Condensed"/>
-              </a:rPr>
-              <a:t>2  Images beside the bars</a:t>
-            </a:r>
-          </a:p>
-        </p:txBody>
-      </p:sp>
-      <p:sp>
-        <p:nvSpPr>
-          <p:cNvPr id="6" name="">
-            <a:extLst xmlns:a="http://schemas.openxmlformats.org/drawingml/2006/main">
-              <a:ext uri="{FF2B5EF4-FFF2-40B4-BE49-F238E27FC236}">
-                <a16:creationId xmlns:a16="http://schemas.microsoft.com/office/drawing/2014/main" id="{C6405718-96AC-41EA-A60C-6E9049F45038}"/>
-              </a:ext>
-            </a:extLst>
-          </p:cNvPr>
-          <p:cNvSpPr>
-            <a:spLocks xmlns:a="http://schemas.openxmlformats.org/drawingml/2006/main" noGrp="1"/>
-          </p:cNvSpPr>
-          <p:nvPr/>
-        </p:nvSpPr>
-        <p:spPr>
-          <a:xfrm xmlns:a="http://schemas.openxmlformats.org/drawingml/2006/main">
-            <a:off x="457200" y="3505200"/>
-            <a:ext cx="5238750" cy="1095375"/>
+            <a:off x="942975" y="1571625"/>
+            <a:ext cx="4667250" cy="304800"/>
           </a:xfrm>
           <a:prstGeom xmlns:a="http://schemas.openxmlformats.org/drawingml/2006/main" prst="rect">
             <a:avLst/>
@@ -4363,7 +4208,7 @@
             <a:defPPr>
               <a:defRPr sz="2025">
                 <a:solidFill>
-                  <a:srgbClr val="38332E"/>
+                  <a:srgbClr val="B23C50"/>
                 </a:solidFill>
                 <a:latin typeface="Ubuntu Condensed"/>
                 <a:ea typeface="Ubuntu Condensed"/>
@@ -4375,7 +4220,7 @@
             <a:pPr>
               <a:defRPr sz="2025">
                 <a:solidFill>
-                  <a:srgbClr val="38332E"/>
+                  <a:srgbClr val="B23C50"/>
                 </a:solidFill>
                 <a:latin typeface="Ubuntu Condensed"/>
                 <a:ea typeface="Ubuntu Condensed"/>
@@ -4385,69 +4230,23 @@
             <a:r>
               <a:rPr sz="2025">
                 <a:solidFill>
-                  <a:srgbClr val="38332E"/>
+                  <a:srgbClr val="B23C50"/>
                 </a:solidFill>
                 <a:latin typeface="Ubuntu Condensed"/>
                 <a:ea typeface="Ubuntu Condensed"/>
                 <a:cs typeface="Ubuntu Condensed"/>
               </a:rPr>
-              <a:t>Image_URL: Image Role &gt; URL</a:t>
-            </a:r>
-          </a:p>
-          <a:p xmlns:a="http://schemas.openxmlformats.org/drawingml/2006/main">
-            <a:pPr>
-              <a:defRPr sz="2025">
-                <a:solidFill>
-                  <a:srgbClr val="38332E"/>
-                </a:solidFill>
-                <a:latin typeface="Ubuntu Condensed"/>
-                <a:ea typeface="Ubuntu Condensed"/>
-                <a:cs typeface="Ubuntu Condensed"/>
-              </a:defRPr>
-            </a:pPr>
-            <a:r>
-              <a:rPr sz="2025">
-                <a:solidFill>
-                  <a:srgbClr val="38332E"/>
-                </a:solidFill>
-                <a:latin typeface="Ubuntu Condensed"/>
-                <a:ea typeface="Ubuntu Condensed"/>
-                <a:cs typeface="Ubuntu Condensed"/>
-              </a:rPr>
-              <a:t>Rows: Image_URL, then Name</a:t>
-            </a:r>
-          </a:p>
-          <a:p xmlns:a="http://schemas.openxmlformats.org/drawingml/2006/main">
-            <a:pPr>
-              <a:defRPr sz="2025">
-                <a:solidFill>
-                  <a:srgbClr val="38332E"/>
-                </a:solidFill>
-                <a:latin typeface="Ubuntu Condensed"/>
-                <a:ea typeface="Ubuntu Condensed"/>
-                <a:cs typeface="Ubuntu Condensed"/>
-              </a:defRPr>
-            </a:pPr>
-            <a:r>
-              <a:rPr sz="2025">
-                <a:solidFill>
-                  <a:srgbClr val="38332E"/>
-                </a:solidFill>
-                <a:latin typeface="Ubuntu Condensed"/>
-                <a:ea typeface="Ubuntu Condensed"/>
-                <a:cs typeface="Ubuntu Condensed"/>
-              </a:rPr>
-              <a:t>Columns: AVG(Attack)     Marks: Bar</a:t>
+              <a:t>Open the updated CSV</a:t>
             </a:r>
           </a:p>
         </p:txBody>
       </p:sp>
       <p:sp>
         <p:nvSpPr>
-          <p:cNvPr id="7" name="">
+          <p:cNvPr id="5" name="">
             <a:extLst xmlns:a="http://schemas.openxmlformats.org/drawingml/2006/main">
               <a:ext uri="{FF2B5EF4-FFF2-40B4-BE49-F238E27FC236}">
-                <a16:creationId xmlns:a16="http://schemas.microsoft.com/office/drawing/2014/main" id="{9EB8FBCC-AA9A-45EA-A669-1F28B09F10BB}"/>
+                <a16:creationId xmlns:a16="http://schemas.microsoft.com/office/drawing/2014/main" id="{BF6ADF24-37BB-4A76-BD53-37DE0E0C9FAB}"/>
               </a:ext>
             </a:extLst>
           </p:cNvPr>
@@ -4458,8 +4257,8 @@
         </p:nvSpPr>
         <p:spPr>
           <a:xfrm xmlns:a="http://schemas.openxmlformats.org/drawingml/2006/main">
-            <a:off x="457200" y="4819650"/>
-            <a:ext cx="5238750" cy="400050"/>
+            <a:off x="942975" y="1866900"/>
+            <a:ext cx="4857750" cy="457200"/>
           </a:xfrm>
           <a:prstGeom xmlns:a="http://schemas.openxmlformats.org/drawingml/2006/main" prst="rect">
             <a:avLst/>
@@ -4473,9 +4272,9 @@
           <a:bodyPr xmlns:a="http://schemas.openxmlformats.org/drawingml/2006/main" lIns="0" tIns="0" rIns="0" bIns="0"/>
           <a:lstStyle xmlns:a="http://schemas.openxmlformats.org/drawingml/2006/main">
             <a:defPPr>
-              <a:defRPr sz="2250">
-                <a:solidFill>
-                  <a:srgbClr val="B23C50"/>
+              <a:defRPr sz="1575">
+                <a:solidFill>
+                  <a:srgbClr val="38332E"/>
                 </a:solidFill>
                 <a:latin typeface="Ubuntu Condensed"/>
                 <a:ea typeface="Ubuntu Condensed"/>
@@ -4485,9 +4284,9 @@
           </a:lstStyle>
           <a:p xmlns:a="http://schemas.openxmlformats.org/drawingml/2006/main">
             <a:pPr>
-              <a:defRPr sz="2250">
-                <a:solidFill>
-                  <a:srgbClr val="B23C50"/>
+              <a:defRPr sz="1575">
+                <a:solidFill>
+                  <a:srgbClr val="38332E"/>
                 </a:solidFill>
                 <a:latin typeface="Ubuntu Condensed"/>
                 <a:ea typeface="Ubuntu Condensed"/>
@@ -4495,25 +4294,25 @@
               </a:defRPr>
             </a:pPr>
             <a:r>
-              <a:rPr sz="2250">
-                <a:solidFill>
-                  <a:srgbClr val="B23C50"/>
+              <a:rPr sz="1575">
+                <a:solidFill>
+                  <a:srgbClr val="38332E"/>
                 </a:solidFill>
                 <a:latin typeface="Ubuntu Condensed"/>
                 <a:ea typeface="Ubuntu Condensed"/>
                 <a:cs typeface="Ubuntu Condensed"/>
               </a:rPr>
-              <a:t>3  Bigger images, clear values</a:t>
+              <a:t>Text file: pokemon-review.csv. Open Sheet 1.</a:t>
             </a:r>
           </a:p>
         </p:txBody>
       </p:sp>
       <p:sp>
         <p:nvSpPr>
-          <p:cNvPr id="8" name="">
+          <p:cNvPr id="6" name="">
             <a:extLst xmlns:a="http://schemas.openxmlformats.org/drawingml/2006/main">
               <a:ext uri="{FF2B5EF4-FFF2-40B4-BE49-F238E27FC236}">
-                <a16:creationId xmlns:a16="http://schemas.microsoft.com/office/drawing/2014/main" id="{AE6DFB74-9218-473C-B56F-56896FCDCD0A}"/>
+                <a16:creationId xmlns:a16="http://schemas.microsoft.com/office/drawing/2014/main" id="{C39C8BA8-DD32-446C-83EF-386D31BCF0C2}"/>
               </a:ext>
             </a:extLst>
           </p:cNvPr>
@@ -4524,8 +4323,8 @@
         </p:nvSpPr>
         <p:spPr>
           <a:xfrm xmlns:a="http://schemas.openxmlformats.org/drawingml/2006/main">
-            <a:off x="457200" y="5267325"/>
-            <a:ext cx="5238750" cy="1085850"/>
+            <a:off x="457200" y="2295525"/>
+            <a:ext cx="361950" cy="304800"/>
           </a:xfrm>
           <a:prstGeom xmlns:a="http://schemas.openxmlformats.org/drawingml/2006/main" prst="rect">
             <a:avLst/>
@@ -4539,9 +4338,9 @@
           <a:bodyPr xmlns:a="http://schemas.openxmlformats.org/drawingml/2006/main" lIns="0" tIns="0" rIns="0" bIns="0"/>
           <a:lstStyle xmlns:a="http://schemas.openxmlformats.org/drawingml/2006/main">
             <a:defPPr>
-              <a:defRPr sz="1950">
-                <a:solidFill>
-                  <a:srgbClr val="38332E"/>
+              <a:defRPr sz="2025">
+                <a:solidFill>
+                  <a:srgbClr val="B23C50"/>
                 </a:solidFill>
                 <a:latin typeface="Ubuntu Condensed"/>
                 <a:ea typeface="Ubuntu Condensed"/>
@@ -4551,9 +4350,9 @@
           </a:lstStyle>
           <a:p xmlns:a="http://schemas.openxmlformats.org/drawingml/2006/main">
             <a:pPr>
-              <a:defRPr sz="1950">
-                <a:solidFill>
-                  <a:srgbClr val="38332E"/>
+              <a:defRPr sz="2025">
+                <a:solidFill>
+                  <a:srgbClr val="B23C50"/>
                 </a:solidFill>
                 <a:latin typeface="Ubuntu Condensed"/>
                 <a:ea typeface="Ubuntu Condensed"/>
@@ -4561,20 +4360,152 @@
               </a:defRPr>
             </a:pPr>
             <a:r>
-              <a:rPr sz="1950">
+              <a:rPr sz="2025">
+                <a:solidFill>
+                  <a:srgbClr val="B23C50"/>
+                </a:solidFill>
+                <a:latin typeface="Ubuntu Condensed"/>
+                <a:ea typeface="Ubuntu Condensed"/>
+                <a:cs typeface="Ubuntu Condensed"/>
+              </a:rPr>
+              <a:t>02</a:t>
+            </a:r>
+          </a:p>
+        </p:txBody>
+      </p:sp>
+      <p:sp>
+        <p:nvSpPr>
+          <p:cNvPr id="7" name="">
+            <a:extLst xmlns:a="http://schemas.openxmlformats.org/drawingml/2006/main">
+              <a:ext uri="{FF2B5EF4-FFF2-40B4-BE49-F238E27FC236}">
+                <a16:creationId xmlns:a16="http://schemas.microsoft.com/office/drawing/2014/main" id="{7F5E95B9-747B-4B96-9EED-9522112B3F29}"/>
+              </a:ext>
+            </a:extLst>
+          </p:cNvPr>
+          <p:cNvSpPr>
+            <a:spLocks xmlns:a="http://schemas.openxmlformats.org/drawingml/2006/main" noGrp="1"/>
+          </p:cNvSpPr>
+          <p:nvPr/>
+        </p:nvSpPr>
+        <p:spPr>
+          <a:xfrm xmlns:a="http://schemas.openxmlformats.org/drawingml/2006/main">
+            <a:off x="942975" y="2295525"/>
+            <a:ext cx="4667250" cy="304800"/>
+          </a:xfrm>
+          <a:prstGeom xmlns:a="http://schemas.openxmlformats.org/drawingml/2006/main" prst="rect">
+            <a:avLst/>
+          </a:prstGeom>
+          <a:noFill xmlns:a="http://schemas.openxmlformats.org/drawingml/2006/main"/>
+          <a:ln xmlns:a="http://schemas.openxmlformats.org/drawingml/2006/main" w="0">
+            <a:noFill/>
+          </a:ln>
+        </p:spPr>
+        <p:txBody>
+          <a:bodyPr xmlns:a="http://schemas.openxmlformats.org/drawingml/2006/main" lIns="0" tIns="0" rIns="0" bIns="0"/>
+          <a:lstStyle xmlns:a="http://schemas.openxmlformats.org/drawingml/2006/main">
+            <a:defPPr>
+              <a:defRPr sz="2025">
+                <a:solidFill>
+                  <a:srgbClr val="B23C50"/>
+                </a:solidFill>
+                <a:latin typeface="Ubuntu Condensed"/>
+                <a:ea typeface="Ubuntu Condensed"/>
+                <a:cs typeface="Ubuntu Condensed"/>
+              </a:defRPr>
+            </a:defPPr>
+          </a:lstStyle>
+          <a:p xmlns:a="http://schemas.openxmlformats.org/drawingml/2006/main">
+            <a:pPr>
+              <a:defRPr sz="2025">
+                <a:solidFill>
+                  <a:srgbClr val="B23C50"/>
+                </a:solidFill>
+                <a:latin typeface="Ubuntu Condensed"/>
+                <a:ea typeface="Ubuntu Condensed"/>
+                <a:cs typeface="Ubuntu Condensed"/>
+              </a:defRPr>
+            </a:pPr>
+            <a:r>
+              <a:rPr sz="2025">
+                <a:solidFill>
+                  <a:srgbClr val="B23C50"/>
+                </a:solidFill>
+                <a:latin typeface="Ubuntu Condensed"/>
+                <a:ea typeface="Ubuntu Condensed"/>
+                <a:cs typeface="Ubuntu Condensed"/>
+              </a:rPr>
+              <a:t>Choose five Pokémon</a:t>
+            </a:r>
+          </a:p>
+        </p:txBody>
+      </p:sp>
+      <p:sp>
+        <p:nvSpPr>
+          <p:cNvPr id="8" name="">
+            <a:extLst xmlns:a="http://schemas.openxmlformats.org/drawingml/2006/main">
+              <a:ext uri="{FF2B5EF4-FFF2-40B4-BE49-F238E27FC236}">
+                <a16:creationId xmlns:a16="http://schemas.microsoft.com/office/drawing/2014/main" id="{40086466-FCD0-4440-82DC-42103C71AED7}"/>
+              </a:ext>
+            </a:extLst>
+          </p:cNvPr>
+          <p:cNvSpPr>
+            <a:spLocks xmlns:a="http://schemas.openxmlformats.org/drawingml/2006/main" noGrp="1"/>
+          </p:cNvSpPr>
+          <p:nvPr/>
+        </p:nvSpPr>
+        <p:spPr>
+          <a:xfrm xmlns:a="http://schemas.openxmlformats.org/drawingml/2006/main">
+            <a:off x="942975" y="2590800"/>
+            <a:ext cx="4857750" cy="457200"/>
+          </a:xfrm>
+          <a:prstGeom xmlns:a="http://schemas.openxmlformats.org/drawingml/2006/main" prst="rect">
+            <a:avLst/>
+          </a:prstGeom>
+          <a:noFill xmlns:a="http://schemas.openxmlformats.org/drawingml/2006/main"/>
+          <a:ln xmlns:a="http://schemas.openxmlformats.org/drawingml/2006/main" w="0">
+            <a:noFill/>
+          </a:ln>
+        </p:spPr>
+        <p:txBody>
+          <a:bodyPr xmlns:a="http://schemas.openxmlformats.org/drawingml/2006/main" lIns="0" tIns="0" rIns="0" bIns="0"/>
+          <a:lstStyle xmlns:a="http://schemas.openxmlformats.org/drawingml/2006/main">
+            <a:defPPr>
+              <a:defRPr sz="1575">
                 <a:solidFill>
                   <a:srgbClr val="38332E"/>
                 </a:solidFill>
                 <a:latin typeface="Ubuntu Condensed"/>
                 <a:ea typeface="Ubuntu Condensed"/>
                 <a:cs typeface="Ubuntu Condensed"/>
+              </a:defRPr>
+            </a:defPPr>
+          </a:lstStyle>
+          <a:p xmlns:a="http://schemas.openxmlformats.org/drawingml/2006/main">
+            <a:pPr>
+              <a:defRPr sz="1575">
+                <a:solidFill>
+                  <a:srgbClr val="38332E"/>
+                </a:solidFill>
+                <a:latin typeface="Ubuntu Condensed"/>
+                <a:ea typeface="Ubuntu Condensed"/>
+                <a:cs typeface="Ubuntu Condensed"/>
+              </a:defRPr>
+            </a:pPr>
+            <a:r>
+              <a:rPr sz="1575">
+                <a:solidFill>
+                  <a:srgbClr val="38332E"/>
+                </a:solidFill>
+                <a:latin typeface="Ubuntu Condensed"/>
+                <a:ea typeface="Ubuntu Condensed"/>
+                <a:cs typeface="Ubuntu Condensed"/>
               </a:rPr>
-              <a:t>Sort Image_URL by Average of Attack.</a:t>
+              <a:t>Name to Filters: Bulbasaur, Charmander, Eevee,</a:t>
             </a:r>
           </a:p>
           <a:p xmlns:a="http://schemas.openxmlformats.org/drawingml/2006/main">
             <a:pPr>
-              <a:defRPr sz="1950">
+              <a:defRPr sz="1575">
                 <a:solidFill>
                   <a:srgbClr val="38332E"/>
                 </a:solidFill>
@@ -4584,7 +4515,7 @@
               </a:defRPr>
             </a:pPr>
             <a:r>
-              <a:rPr sz="1950">
+              <a:rPr sz="1575">
                 <a:solidFill>
                   <a:srgbClr val="38332E"/>
                 </a:solidFill>
@@ -4592,12 +4523,210 @@
                 <a:ea typeface="Ubuntu Condensed"/>
                 <a:cs typeface="Ubuntu Condensed"/>
               </a:rPr>
-              <a:t>Show labels. Widen the image column.</a:t>
+              <a:t>Pikachu and Squirtle.</a:t>
+            </a:r>
+          </a:p>
+        </p:txBody>
+      </p:sp>
+      <p:sp>
+        <p:nvSpPr>
+          <p:cNvPr id="9" name="">
+            <a:extLst xmlns:a="http://schemas.openxmlformats.org/drawingml/2006/main">
+              <a:ext uri="{FF2B5EF4-FFF2-40B4-BE49-F238E27FC236}">
+                <a16:creationId xmlns:a16="http://schemas.microsoft.com/office/drawing/2014/main" id="{45C8B533-1967-4E5E-8F2C-FA3CED4F293F}"/>
+              </a:ext>
+            </a:extLst>
+          </p:cNvPr>
+          <p:cNvSpPr>
+            <a:spLocks xmlns:a="http://schemas.openxmlformats.org/drawingml/2006/main" noGrp="1"/>
+          </p:cNvSpPr>
+          <p:nvPr/>
+        </p:nvSpPr>
+        <p:spPr>
+          <a:xfrm xmlns:a="http://schemas.openxmlformats.org/drawingml/2006/main">
+            <a:off x="457200" y="3019425"/>
+            <a:ext cx="361950" cy="304800"/>
+          </a:xfrm>
+          <a:prstGeom xmlns:a="http://schemas.openxmlformats.org/drawingml/2006/main" prst="rect">
+            <a:avLst/>
+          </a:prstGeom>
+          <a:noFill xmlns:a="http://schemas.openxmlformats.org/drawingml/2006/main"/>
+          <a:ln xmlns:a="http://schemas.openxmlformats.org/drawingml/2006/main" w="0">
+            <a:noFill/>
+          </a:ln>
+        </p:spPr>
+        <p:txBody>
+          <a:bodyPr xmlns:a="http://schemas.openxmlformats.org/drawingml/2006/main" lIns="0" tIns="0" rIns="0" bIns="0"/>
+          <a:lstStyle xmlns:a="http://schemas.openxmlformats.org/drawingml/2006/main">
+            <a:defPPr>
+              <a:defRPr sz="2025">
+                <a:solidFill>
+                  <a:srgbClr val="B23C50"/>
+                </a:solidFill>
+                <a:latin typeface="Ubuntu Condensed"/>
+                <a:ea typeface="Ubuntu Condensed"/>
+                <a:cs typeface="Ubuntu Condensed"/>
+              </a:defRPr>
+            </a:defPPr>
+          </a:lstStyle>
+          <a:p xmlns:a="http://schemas.openxmlformats.org/drawingml/2006/main">
+            <a:pPr>
+              <a:defRPr sz="2025">
+                <a:solidFill>
+                  <a:srgbClr val="B23C50"/>
+                </a:solidFill>
+                <a:latin typeface="Ubuntu Condensed"/>
+                <a:ea typeface="Ubuntu Condensed"/>
+                <a:cs typeface="Ubuntu Condensed"/>
+              </a:defRPr>
+            </a:pPr>
+            <a:r>
+              <a:rPr sz="2025">
+                <a:solidFill>
+                  <a:srgbClr val="B23C50"/>
+                </a:solidFill>
+                <a:latin typeface="Ubuntu Condensed"/>
+                <a:ea typeface="Ubuntu Condensed"/>
+                <a:cs typeface="Ubuntu Condensed"/>
+              </a:rPr>
+              <a:t>03</a:t>
+            </a:r>
+          </a:p>
+        </p:txBody>
+      </p:sp>
+      <p:sp>
+        <p:nvSpPr>
+          <p:cNvPr id="10" name="">
+            <a:extLst xmlns:a="http://schemas.openxmlformats.org/drawingml/2006/main">
+              <a:ext uri="{FF2B5EF4-FFF2-40B4-BE49-F238E27FC236}">
+                <a16:creationId xmlns:a16="http://schemas.microsoft.com/office/drawing/2014/main" id="{98837F7C-D5C2-445A-A5C2-8832F91F4C49}"/>
+              </a:ext>
+            </a:extLst>
+          </p:cNvPr>
+          <p:cNvSpPr>
+            <a:spLocks xmlns:a="http://schemas.openxmlformats.org/drawingml/2006/main" noGrp="1"/>
+          </p:cNvSpPr>
+          <p:nvPr/>
+        </p:nvSpPr>
+        <p:spPr>
+          <a:xfrm xmlns:a="http://schemas.openxmlformats.org/drawingml/2006/main">
+            <a:off x="942975" y="3019425"/>
+            <a:ext cx="4667250" cy="304800"/>
+          </a:xfrm>
+          <a:prstGeom xmlns:a="http://schemas.openxmlformats.org/drawingml/2006/main" prst="rect">
+            <a:avLst/>
+          </a:prstGeom>
+          <a:noFill xmlns:a="http://schemas.openxmlformats.org/drawingml/2006/main"/>
+          <a:ln xmlns:a="http://schemas.openxmlformats.org/drawingml/2006/main" w="0">
+            <a:noFill/>
+          </a:ln>
+        </p:spPr>
+        <p:txBody>
+          <a:bodyPr xmlns:a="http://schemas.openxmlformats.org/drawingml/2006/main" lIns="0" tIns="0" rIns="0" bIns="0"/>
+          <a:lstStyle xmlns:a="http://schemas.openxmlformats.org/drawingml/2006/main">
+            <a:defPPr>
+              <a:defRPr sz="2025">
+                <a:solidFill>
+                  <a:srgbClr val="B23C50"/>
+                </a:solidFill>
+                <a:latin typeface="Ubuntu Condensed"/>
+                <a:ea typeface="Ubuntu Condensed"/>
+                <a:cs typeface="Ubuntu Condensed"/>
+              </a:defRPr>
+            </a:defPPr>
+          </a:lstStyle>
+          <a:p xmlns:a="http://schemas.openxmlformats.org/drawingml/2006/main">
+            <a:pPr>
+              <a:defRPr sz="2025">
+                <a:solidFill>
+                  <a:srgbClr val="B23C50"/>
+                </a:solidFill>
+                <a:latin typeface="Ubuntu Condensed"/>
+                <a:ea typeface="Ubuntu Condensed"/>
+                <a:cs typeface="Ubuntu Condensed"/>
+              </a:defRPr>
+            </a:pPr>
+            <a:r>
+              <a:rPr sz="2025">
+                <a:solidFill>
+                  <a:srgbClr val="B23C50"/>
+                </a:solidFill>
+                <a:latin typeface="Ubuntu Condensed"/>
+                <a:ea typeface="Ubuntu Condensed"/>
+                <a:cs typeface="Ubuntu Condensed"/>
+              </a:rPr>
+              <a:t>Enable image URLs</a:t>
+            </a:r>
+          </a:p>
+        </p:txBody>
+      </p:sp>
+      <p:sp>
+        <p:nvSpPr>
+          <p:cNvPr id="11" name="">
+            <a:extLst xmlns:a="http://schemas.openxmlformats.org/drawingml/2006/main">
+              <a:ext uri="{FF2B5EF4-FFF2-40B4-BE49-F238E27FC236}">
+                <a16:creationId xmlns:a16="http://schemas.microsoft.com/office/drawing/2014/main" id="{085E88F2-4627-4B42-A1B0-E5DF9B1CDB98}"/>
+              </a:ext>
+            </a:extLst>
+          </p:cNvPr>
+          <p:cNvSpPr>
+            <a:spLocks xmlns:a="http://schemas.openxmlformats.org/drawingml/2006/main" noGrp="1"/>
+          </p:cNvSpPr>
+          <p:nvPr/>
+        </p:nvSpPr>
+        <p:spPr>
+          <a:xfrm xmlns:a="http://schemas.openxmlformats.org/drawingml/2006/main">
+            <a:off x="942975" y="3314700"/>
+            <a:ext cx="4857750" cy="457200"/>
+          </a:xfrm>
+          <a:prstGeom xmlns:a="http://schemas.openxmlformats.org/drawingml/2006/main" prst="rect">
+            <a:avLst/>
+          </a:prstGeom>
+          <a:noFill xmlns:a="http://schemas.openxmlformats.org/drawingml/2006/main"/>
+          <a:ln xmlns:a="http://schemas.openxmlformats.org/drawingml/2006/main" w="0">
+            <a:noFill/>
+          </a:ln>
+        </p:spPr>
+        <p:txBody>
+          <a:bodyPr xmlns:a="http://schemas.openxmlformats.org/drawingml/2006/main" lIns="0" tIns="0" rIns="0" bIns="0"/>
+          <a:lstStyle xmlns:a="http://schemas.openxmlformats.org/drawingml/2006/main">
+            <a:defPPr>
+              <a:defRPr sz="1575">
+                <a:solidFill>
+                  <a:srgbClr val="38332E"/>
+                </a:solidFill>
+                <a:latin typeface="Ubuntu Condensed"/>
+                <a:ea typeface="Ubuntu Condensed"/>
+                <a:cs typeface="Ubuntu Condensed"/>
+              </a:defRPr>
+            </a:defPPr>
+          </a:lstStyle>
+          <a:p xmlns:a="http://schemas.openxmlformats.org/drawingml/2006/main">
+            <a:pPr>
+              <a:defRPr sz="1575">
+                <a:solidFill>
+                  <a:srgbClr val="38332E"/>
+                </a:solidFill>
+                <a:latin typeface="Ubuntu Condensed"/>
+                <a:ea typeface="Ubuntu Condensed"/>
+                <a:cs typeface="Ubuntu Condensed"/>
+              </a:defRPr>
+            </a:pPr>
+            <a:r>
+              <a:rPr sz="1575">
+                <a:solidFill>
+                  <a:srgbClr val="38332E"/>
+                </a:solidFill>
+                <a:latin typeface="Ubuntu Condensed"/>
+                <a:ea typeface="Ubuntu Condensed"/>
+                <a:cs typeface="Ubuntu Condensed"/>
+              </a:rPr>
+              <a:t>Right-click Image_URL in the Data pane.</a:t>
             </a:r>
           </a:p>
           <a:p xmlns:a="http://schemas.openxmlformats.org/drawingml/2006/main">
             <a:pPr>
-              <a:defRPr sz="1950">
+              <a:defRPr sz="1575">
                 <a:solidFill>
                   <a:srgbClr val="38332E"/>
                 </a:solidFill>
@@ -4607,7 +4736,7 @@
               </a:defRPr>
             </a:pPr>
             <a:r>
-              <a:rPr sz="1950">
+              <a:rPr sz="1575">
                 <a:solidFill>
                   <a:srgbClr val="38332E"/>
                 </a:solidFill>
@@ -4615,17 +4744,878 @@
                 <a:ea typeface="Ubuntu Condensed"/>
                 <a:cs typeface="Ubuntu Condensed"/>
               </a:rPr>
-              <a:t>Make rows taller. Keep a zero baseline.</a:t>
+              <a:t>Choose Image Role &gt; URL.</a:t>
+            </a:r>
+          </a:p>
+        </p:txBody>
+      </p:sp>
+      <p:sp>
+        <p:nvSpPr>
+          <p:cNvPr id="12" name="">
+            <a:extLst xmlns:a="http://schemas.openxmlformats.org/drawingml/2006/main">
+              <a:ext uri="{FF2B5EF4-FFF2-40B4-BE49-F238E27FC236}">
+                <a16:creationId xmlns:a16="http://schemas.microsoft.com/office/drawing/2014/main" id="{F603F0BE-E824-4381-B47C-FE84B72EAB3F}"/>
+              </a:ext>
+            </a:extLst>
+          </p:cNvPr>
+          <p:cNvSpPr>
+            <a:spLocks xmlns:a="http://schemas.openxmlformats.org/drawingml/2006/main" noGrp="1"/>
+          </p:cNvSpPr>
+          <p:nvPr/>
+        </p:nvSpPr>
+        <p:spPr>
+          <a:xfrm xmlns:a="http://schemas.openxmlformats.org/drawingml/2006/main">
+            <a:off x="457200" y="3743325"/>
+            <a:ext cx="361950" cy="304800"/>
+          </a:xfrm>
+          <a:prstGeom xmlns:a="http://schemas.openxmlformats.org/drawingml/2006/main" prst="rect">
+            <a:avLst/>
+          </a:prstGeom>
+          <a:noFill xmlns:a="http://schemas.openxmlformats.org/drawingml/2006/main"/>
+          <a:ln xmlns:a="http://schemas.openxmlformats.org/drawingml/2006/main" w="0">
+            <a:noFill/>
+          </a:ln>
+        </p:spPr>
+        <p:txBody>
+          <a:bodyPr xmlns:a="http://schemas.openxmlformats.org/drawingml/2006/main" lIns="0" tIns="0" rIns="0" bIns="0"/>
+          <a:lstStyle xmlns:a="http://schemas.openxmlformats.org/drawingml/2006/main">
+            <a:defPPr>
+              <a:defRPr sz="2025">
+                <a:solidFill>
+                  <a:srgbClr val="B23C50"/>
+                </a:solidFill>
+                <a:latin typeface="Ubuntu Condensed"/>
+                <a:ea typeface="Ubuntu Condensed"/>
+                <a:cs typeface="Ubuntu Condensed"/>
+              </a:defRPr>
+            </a:defPPr>
+          </a:lstStyle>
+          <a:p xmlns:a="http://schemas.openxmlformats.org/drawingml/2006/main">
+            <a:pPr>
+              <a:defRPr sz="2025">
+                <a:solidFill>
+                  <a:srgbClr val="B23C50"/>
+                </a:solidFill>
+                <a:latin typeface="Ubuntu Condensed"/>
+                <a:ea typeface="Ubuntu Condensed"/>
+                <a:cs typeface="Ubuntu Condensed"/>
+              </a:defRPr>
+            </a:pPr>
+            <a:r>
+              <a:rPr sz="2025">
+                <a:solidFill>
+                  <a:srgbClr val="B23C50"/>
+                </a:solidFill>
+                <a:latin typeface="Ubuntu Condensed"/>
+                <a:ea typeface="Ubuntu Condensed"/>
+                <a:cs typeface="Ubuntu Condensed"/>
+              </a:rPr>
+              <a:t>04</a:t>
+            </a:r>
+          </a:p>
+        </p:txBody>
+      </p:sp>
+      <p:sp>
+        <p:nvSpPr>
+          <p:cNvPr id="13" name="">
+            <a:extLst xmlns:a="http://schemas.openxmlformats.org/drawingml/2006/main">
+              <a:ext uri="{FF2B5EF4-FFF2-40B4-BE49-F238E27FC236}">
+                <a16:creationId xmlns:a16="http://schemas.microsoft.com/office/drawing/2014/main" id="{A6FD208B-AFB8-435A-81B4-92C2F4A40C08}"/>
+              </a:ext>
+            </a:extLst>
+          </p:cNvPr>
+          <p:cNvSpPr>
+            <a:spLocks xmlns:a="http://schemas.openxmlformats.org/drawingml/2006/main" noGrp="1"/>
+          </p:cNvSpPr>
+          <p:nvPr/>
+        </p:nvSpPr>
+        <p:spPr>
+          <a:xfrm xmlns:a="http://schemas.openxmlformats.org/drawingml/2006/main">
+            <a:off x="942975" y="3743325"/>
+            <a:ext cx="4667250" cy="304800"/>
+          </a:xfrm>
+          <a:prstGeom xmlns:a="http://schemas.openxmlformats.org/drawingml/2006/main" prst="rect">
+            <a:avLst/>
+          </a:prstGeom>
+          <a:noFill xmlns:a="http://schemas.openxmlformats.org/drawingml/2006/main"/>
+          <a:ln xmlns:a="http://schemas.openxmlformats.org/drawingml/2006/main" w="0">
+            <a:noFill/>
+          </a:ln>
+        </p:spPr>
+        <p:txBody>
+          <a:bodyPr xmlns:a="http://schemas.openxmlformats.org/drawingml/2006/main" lIns="0" tIns="0" rIns="0" bIns="0"/>
+          <a:lstStyle xmlns:a="http://schemas.openxmlformats.org/drawingml/2006/main">
+            <a:defPPr>
+              <a:defRPr sz="2025">
+                <a:solidFill>
+                  <a:srgbClr val="B23C50"/>
+                </a:solidFill>
+                <a:latin typeface="Ubuntu Condensed"/>
+                <a:ea typeface="Ubuntu Condensed"/>
+                <a:cs typeface="Ubuntu Condensed"/>
+              </a:defRPr>
+            </a:defPPr>
+          </a:lstStyle>
+          <a:p xmlns:a="http://schemas.openxmlformats.org/drawingml/2006/main">
+            <a:pPr>
+              <a:defRPr sz="2025">
+                <a:solidFill>
+                  <a:srgbClr val="B23C50"/>
+                </a:solidFill>
+                <a:latin typeface="Ubuntu Condensed"/>
+                <a:ea typeface="Ubuntu Condensed"/>
+                <a:cs typeface="Ubuntu Condensed"/>
+              </a:defRPr>
+            </a:pPr>
+            <a:r>
+              <a:rPr sz="2025">
+                <a:solidFill>
+                  <a:srgbClr val="B23C50"/>
+                </a:solidFill>
+                <a:latin typeface="Ubuntu Condensed"/>
+                <a:ea typeface="Ubuntu Condensed"/>
+                <a:cs typeface="Ubuntu Condensed"/>
+              </a:rPr>
+              <a:t>Build the rows</a:t>
+            </a:r>
+          </a:p>
+        </p:txBody>
+      </p:sp>
+      <p:sp>
+        <p:nvSpPr>
+          <p:cNvPr id="14" name="">
+            <a:extLst xmlns:a="http://schemas.openxmlformats.org/drawingml/2006/main">
+              <a:ext uri="{FF2B5EF4-FFF2-40B4-BE49-F238E27FC236}">
+                <a16:creationId xmlns:a16="http://schemas.microsoft.com/office/drawing/2014/main" id="{D91B40B4-70E3-4A3E-BAD2-62B8E2523DBA}"/>
+              </a:ext>
+            </a:extLst>
+          </p:cNvPr>
+          <p:cNvSpPr>
+            <a:spLocks xmlns:a="http://schemas.openxmlformats.org/drawingml/2006/main" noGrp="1"/>
+          </p:cNvSpPr>
+          <p:nvPr/>
+        </p:nvSpPr>
+        <p:spPr>
+          <a:xfrm xmlns:a="http://schemas.openxmlformats.org/drawingml/2006/main">
+            <a:off x="942975" y="4038600"/>
+            <a:ext cx="4857750" cy="457200"/>
+          </a:xfrm>
+          <a:prstGeom xmlns:a="http://schemas.openxmlformats.org/drawingml/2006/main" prst="rect">
+            <a:avLst/>
+          </a:prstGeom>
+          <a:noFill xmlns:a="http://schemas.openxmlformats.org/drawingml/2006/main"/>
+          <a:ln xmlns:a="http://schemas.openxmlformats.org/drawingml/2006/main" w="0">
+            <a:noFill/>
+          </a:ln>
+        </p:spPr>
+        <p:txBody>
+          <a:bodyPr xmlns:a="http://schemas.openxmlformats.org/drawingml/2006/main" lIns="0" tIns="0" rIns="0" bIns="0"/>
+          <a:lstStyle xmlns:a="http://schemas.openxmlformats.org/drawingml/2006/main">
+            <a:defPPr>
+              <a:defRPr sz="1575">
+                <a:solidFill>
+                  <a:srgbClr val="38332E"/>
+                </a:solidFill>
+                <a:latin typeface="Ubuntu Condensed"/>
+                <a:ea typeface="Ubuntu Condensed"/>
+                <a:cs typeface="Ubuntu Condensed"/>
+              </a:defRPr>
+            </a:defPPr>
+          </a:lstStyle>
+          <a:p xmlns:a="http://schemas.openxmlformats.org/drawingml/2006/main">
+            <a:pPr>
+              <a:defRPr sz="1575">
+                <a:solidFill>
+                  <a:srgbClr val="38332E"/>
+                </a:solidFill>
+                <a:latin typeface="Ubuntu Condensed"/>
+                <a:ea typeface="Ubuntu Condensed"/>
+                <a:cs typeface="Ubuntu Condensed"/>
+              </a:defRPr>
+            </a:pPr>
+            <a:r>
+              <a:rPr sz="1575">
+                <a:solidFill>
+                  <a:srgbClr val="38332E"/>
+                </a:solidFill>
+                <a:latin typeface="Ubuntu Condensed"/>
+                <a:ea typeface="Ubuntu Condensed"/>
+                <a:cs typeface="Ubuntu Condensed"/>
+              </a:rPr>
+              <a:t>Rows: Image_URL first, then Name to its right.</a:t>
+            </a:r>
+          </a:p>
+        </p:txBody>
+      </p:sp>
+      <p:sp>
+        <p:nvSpPr>
+          <p:cNvPr id="15" name="">
+            <a:extLst xmlns:a="http://schemas.openxmlformats.org/drawingml/2006/main">
+              <a:ext uri="{FF2B5EF4-FFF2-40B4-BE49-F238E27FC236}">
+                <a16:creationId xmlns:a16="http://schemas.microsoft.com/office/drawing/2014/main" id="{233A4525-E5F0-4305-A5D6-9E032E3FC4FC}"/>
+              </a:ext>
+            </a:extLst>
+          </p:cNvPr>
+          <p:cNvSpPr>
+            <a:spLocks xmlns:a="http://schemas.openxmlformats.org/drawingml/2006/main" noGrp="1"/>
+          </p:cNvSpPr>
+          <p:nvPr/>
+        </p:nvSpPr>
+        <p:spPr>
+          <a:xfrm xmlns:a="http://schemas.openxmlformats.org/drawingml/2006/main">
+            <a:off x="457200" y="4467225"/>
+            <a:ext cx="361950" cy="304800"/>
+          </a:xfrm>
+          <a:prstGeom xmlns:a="http://schemas.openxmlformats.org/drawingml/2006/main" prst="rect">
+            <a:avLst/>
+          </a:prstGeom>
+          <a:noFill xmlns:a="http://schemas.openxmlformats.org/drawingml/2006/main"/>
+          <a:ln xmlns:a="http://schemas.openxmlformats.org/drawingml/2006/main" w="0">
+            <a:noFill/>
+          </a:ln>
+        </p:spPr>
+        <p:txBody>
+          <a:bodyPr xmlns:a="http://schemas.openxmlformats.org/drawingml/2006/main" lIns="0" tIns="0" rIns="0" bIns="0"/>
+          <a:lstStyle xmlns:a="http://schemas.openxmlformats.org/drawingml/2006/main">
+            <a:defPPr>
+              <a:defRPr sz="2025">
+                <a:solidFill>
+                  <a:srgbClr val="B23C50"/>
+                </a:solidFill>
+                <a:latin typeface="Ubuntu Condensed"/>
+                <a:ea typeface="Ubuntu Condensed"/>
+                <a:cs typeface="Ubuntu Condensed"/>
+              </a:defRPr>
+            </a:defPPr>
+          </a:lstStyle>
+          <a:p xmlns:a="http://schemas.openxmlformats.org/drawingml/2006/main">
+            <a:pPr>
+              <a:defRPr sz="2025">
+                <a:solidFill>
+                  <a:srgbClr val="B23C50"/>
+                </a:solidFill>
+                <a:latin typeface="Ubuntu Condensed"/>
+                <a:ea typeface="Ubuntu Condensed"/>
+                <a:cs typeface="Ubuntu Condensed"/>
+              </a:defRPr>
+            </a:pPr>
+            <a:r>
+              <a:rPr sz="2025">
+                <a:solidFill>
+                  <a:srgbClr val="B23C50"/>
+                </a:solidFill>
+                <a:latin typeface="Ubuntu Condensed"/>
+                <a:ea typeface="Ubuntu Condensed"/>
+                <a:cs typeface="Ubuntu Condensed"/>
+              </a:rPr>
+              <a:t>05</a:t>
+            </a:r>
+          </a:p>
+        </p:txBody>
+      </p:sp>
+      <p:sp>
+        <p:nvSpPr>
+          <p:cNvPr id="16" name="">
+            <a:extLst xmlns:a="http://schemas.openxmlformats.org/drawingml/2006/main">
+              <a:ext uri="{FF2B5EF4-FFF2-40B4-BE49-F238E27FC236}">
+                <a16:creationId xmlns:a16="http://schemas.microsoft.com/office/drawing/2014/main" id="{CE0800E8-E3ED-46E7-A436-0EF0464E9107}"/>
+              </a:ext>
+            </a:extLst>
+          </p:cNvPr>
+          <p:cNvSpPr>
+            <a:spLocks xmlns:a="http://schemas.openxmlformats.org/drawingml/2006/main" noGrp="1"/>
+          </p:cNvSpPr>
+          <p:nvPr/>
+        </p:nvSpPr>
+        <p:spPr>
+          <a:xfrm xmlns:a="http://schemas.openxmlformats.org/drawingml/2006/main">
+            <a:off x="942975" y="4467225"/>
+            <a:ext cx="4667250" cy="304800"/>
+          </a:xfrm>
+          <a:prstGeom xmlns:a="http://schemas.openxmlformats.org/drawingml/2006/main" prst="rect">
+            <a:avLst/>
+          </a:prstGeom>
+          <a:noFill xmlns:a="http://schemas.openxmlformats.org/drawingml/2006/main"/>
+          <a:ln xmlns:a="http://schemas.openxmlformats.org/drawingml/2006/main" w="0">
+            <a:noFill/>
+          </a:ln>
+        </p:spPr>
+        <p:txBody>
+          <a:bodyPr xmlns:a="http://schemas.openxmlformats.org/drawingml/2006/main" lIns="0" tIns="0" rIns="0" bIns="0"/>
+          <a:lstStyle xmlns:a="http://schemas.openxmlformats.org/drawingml/2006/main">
+            <a:defPPr>
+              <a:defRPr sz="2025">
+                <a:solidFill>
+                  <a:srgbClr val="B23C50"/>
+                </a:solidFill>
+                <a:latin typeface="Ubuntu Condensed"/>
+                <a:ea typeface="Ubuntu Condensed"/>
+                <a:cs typeface="Ubuntu Condensed"/>
+              </a:defRPr>
+            </a:defPPr>
+          </a:lstStyle>
+          <a:p xmlns:a="http://schemas.openxmlformats.org/drawingml/2006/main">
+            <a:pPr>
+              <a:defRPr sz="2025">
+                <a:solidFill>
+                  <a:srgbClr val="B23C50"/>
+                </a:solidFill>
+                <a:latin typeface="Ubuntu Condensed"/>
+                <a:ea typeface="Ubuntu Condensed"/>
+                <a:cs typeface="Ubuntu Condensed"/>
+              </a:defRPr>
+            </a:pPr>
+            <a:r>
+              <a:rPr sz="2025">
+                <a:solidFill>
+                  <a:srgbClr val="B23C50"/>
+                </a:solidFill>
+                <a:latin typeface="Ubuntu Condensed"/>
+                <a:ea typeface="Ubuntu Condensed"/>
+                <a:cs typeface="Ubuntu Condensed"/>
+              </a:rPr>
+              <a:t>Build the bars</a:t>
+            </a:r>
+          </a:p>
+        </p:txBody>
+      </p:sp>
+      <p:sp>
+        <p:nvSpPr>
+          <p:cNvPr id="17" name="">
+            <a:extLst xmlns:a="http://schemas.openxmlformats.org/drawingml/2006/main">
+              <a:ext uri="{FF2B5EF4-FFF2-40B4-BE49-F238E27FC236}">
+                <a16:creationId xmlns:a16="http://schemas.microsoft.com/office/drawing/2014/main" id="{D795E5B3-DE4B-4C84-A205-CC45C7129B6F}"/>
+              </a:ext>
+            </a:extLst>
+          </p:cNvPr>
+          <p:cNvSpPr>
+            <a:spLocks xmlns:a="http://schemas.openxmlformats.org/drawingml/2006/main" noGrp="1"/>
+          </p:cNvSpPr>
+          <p:nvPr/>
+        </p:nvSpPr>
+        <p:spPr>
+          <a:xfrm xmlns:a="http://schemas.openxmlformats.org/drawingml/2006/main">
+            <a:off x="942975" y="4762500"/>
+            <a:ext cx="4857750" cy="457200"/>
+          </a:xfrm>
+          <a:prstGeom xmlns:a="http://schemas.openxmlformats.org/drawingml/2006/main" prst="rect">
+            <a:avLst/>
+          </a:prstGeom>
+          <a:noFill xmlns:a="http://schemas.openxmlformats.org/drawingml/2006/main"/>
+          <a:ln xmlns:a="http://schemas.openxmlformats.org/drawingml/2006/main" w="0">
+            <a:noFill/>
+          </a:ln>
+        </p:spPr>
+        <p:txBody>
+          <a:bodyPr xmlns:a="http://schemas.openxmlformats.org/drawingml/2006/main" lIns="0" tIns="0" rIns="0" bIns="0"/>
+          <a:lstStyle xmlns:a="http://schemas.openxmlformats.org/drawingml/2006/main">
+            <a:defPPr>
+              <a:defRPr sz="1575">
+                <a:solidFill>
+                  <a:srgbClr val="38332E"/>
+                </a:solidFill>
+                <a:latin typeface="Ubuntu Condensed"/>
+                <a:ea typeface="Ubuntu Condensed"/>
+                <a:cs typeface="Ubuntu Condensed"/>
+              </a:defRPr>
+            </a:defPPr>
+          </a:lstStyle>
+          <a:p xmlns:a="http://schemas.openxmlformats.org/drawingml/2006/main">
+            <a:pPr>
+              <a:defRPr sz="1575">
+                <a:solidFill>
+                  <a:srgbClr val="38332E"/>
+                </a:solidFill>
+                <a:latin typeface="Ubuntu Condensed"/>
+                <a:ea typeface="Ubuntu Condensed"/>
+                <a:cs typeface="Ubuntu Condensed"/>
+              </a:defRPr>
+            </a:pPr>
+            <a:r>
+              <a:rPr sz="1575">
+                <a:solidFill>
+                  <a:srgbClr val="38332E"/>
+                </a:solidFill>
+                <a:latin typeface="Ubuntu Condensed"/>
+                <a:ea typeface="Ubuntu Condensed"/>
+                <a:cs typeface="Ubuntu Condensed"/>
+              </a:rPr>
+              <a:t>Attack to Columns. Pill menu: Measure &gt; Average.</a:t>
+            </a:r>
+          </a:p>
+          <a:p xmlns:a="http://schemas.openxmlformats.org/drawingml/2006/main">
+            <a:pPr>
+              <a:defRPr sz="1575">
+                <a:solidFill>
+                  <a:srgbClr val="38332E"/>
+                </a:solidFill>
+                <a:latin typeface="Ubuntu Condensed"/>
+                <a:ea typeface="Ubuntu Condensed"/>
+                <a:cs typeface="Ubuntu Condensed"/>
+              </a:defRPr>
+            </a:pPr>
+            <a:r>
+              <a:rPr sz="1575">
+                <a:solidFill>
+                  <a:srgbClr val="38332E"/>
+                </a:solidFill>
+                <a:latin typeface="Ubuntu Condensed"/>
+                <a:ea typeface="Ubuntu Condensed"/>
+                <a:cs typeface="Ubuntu Condensed"/>
+              </a:rPr>
+              <a:t>On the Marks card, choose Bar.</a:t>
+            </a:r>
+          </a:p>
+        </p:txBody>
+      </p:sp>
+      <p:sp>
+        <p:nvSpPr>
+          <p:cNvPr id="18" name="">
+            <a:extLst xmlns:a="http://schemas.openxmlformats.org/drawingml/2006/main">
+              <a:ext uri="{FF2B5EF4-FFF2-40B4-BE49-F238E27FC236}">
+                <a16:creationId xmlns:a16="http://schemas.microsoft.com/office/drawing/2014/main" id="{432815D9-F21C-4064-AC1C-446EECD0844F}"/>
+              </a:ext>
+            </a:extLst>
+          </p:cNvPr>
+          <p:cNvSpPr>
+            <a:spLocks xmlns:a="http://schemas.openxmlformats.org/drawingml/2006/main" noGrp="1"/>
+          </p:cNvSpPr>
+          <p:nvPr/>
+        </p:nvSpPr>
+        <p:spPr>
+          <a:xfrm xmlns:a="http://schemas.openxmlformats.org/drawingml/2006/main">
+            <a:off x="457200" y="5191125"/>
+            <a:ext cx="361950" cy="304800"/>
+          </a:xfrm>
+          <a:prstGeom xmlns:a="http://schemas.openxmlformats.org/drawingml/2006/main" prst="rect">
+            <a:avLst/>
+          </a:prstGeom>
+          <a:noFill xmlns:a="http://schemas.openxmlformats.org/drawingml/2006/main"/>
+          <a:ln xmlns:a="http://schemas.openxmlformats.org/drawingml/2006/main" w="0">
+            <a:noFill/>
+          </a:ln>
+        </p:spPr>
+        <p:txBody>
+          <a:bodyPr xmlns:a="http://schemas.openxmlformats.org/drawingml/2006/main" lIns="0" tIns="0" rIns="0" bIns="0"/>
+          <a:lstStyle xmlns:a="http://schemas.openxmlformats.org/drawingml/2006/main">
+            <a:defPPr>
+              <a:defRPr sz="2025">
+                <a:solidFill>
+                  <a:srgbClr val="B23C50"/>
+                </a:solidFill>
+                <a:latin typeface="Ubuntu Condensed"/>
+                <a:ea typeface="Ubuntu Condensed"/>
+                <a:cs typeface="Ubuntu Condensed"/>
+              </a:defRPr>
+            </a:defPPr>
+          </a:lstStyle>
+          <a:p xmlns:a="http://schemas.openxmlformats.org/drawingml/2006/main">
+            <a:pPr>
+              <a:defRPr sz="2025">
+                <a:solidFill>
+                  <a:srgbClr val="B23C50"/>
+                </a:solidFill>
+                <a:latin typeface="Ubuntu Condensed"/>
+                <a:ea typeface="Ubuntu Condensed"/>
+                <a:cs typeface="Ubuntu Condensed"/>
+              </a:defRPr>
+            </a:pPr>
+            <a:r>
+              <a:rPr sz="2025">
+                <a:solidFill>
+                  <a:srgbClr val="B23C50"/>
+                </a:solidFill>
+                <a:latin typeface="Ubuntu Condensed"/>
+                <a:ea typeface="Ubuntu Condensed"/>
+                <a:cs typeface="Ubuntu Condensed"/>
+              </a:rPr>
+              <a:t>06</a:t>
+            </a:r>
+          </a:p>
+        </p:txBody>
+      </p:sp>
+      <p:sp>
+        <p:nvSpPr>
+          <p:cNvPr id="19" name="">
+            <a:extLst xmlns:a="http://schemas.openxmlformats.org/drawingml/2006/main">
+              <a:ext uri="{FF2B5EF4-FFF2-40B4-BE49-F238E27FC236}">
+                <a16:creationId xmlns:a16="http://schemas.microsoft.com/office/drawing/2014/main" id="{C8DA61B2-76BA-48D3-948B-3AB9D776004D}"/>
+              </a:ext>
+            </a:extLst>
+          </p:cNvPr>
+          <p:cNvSpPr>
+            <a:spLocks xmlns:a="http://schemas.openxmlformats.org/drawingml/2006/main" noGrp="1"/>
+          </p:cNvSpPr>
+          <p:nvPr/>
+        </p:nvSpPr>
+        <p:spPr>
+          <a:xfrm xmlns:a="http://schemas.openxmlformats.org/drawingml/2006/main">
+            <a:off x="942975" y="5191125"/>
+            <a:ext cx="4667250" cy="304800"/>
+          </a:xfrm>
+          <a:prstGeom xmlns:a="http://schemas.openxmlformats.org/drawingml/2006/main" prst="rect">
+            <a:avLst/>
+          </a:prstGeom>
+          <a:noFill xmlns:a="http://schemas.openxmlformats.org/drawingml/2006/main"/>
+          <a:ln xmlns:a="http://schemas.openxmlformats.org/drawingml/2006/main" w="0">
+            <a:noFill/>
+          </a:ln>
+        </p:spPr>
+        <p:txBody>
+          <a:bodyPr xmlns:a="http://schemas.openxmlformats.org/drawingml/2006/main" lIns="0" tIns="0" rIns="0" bIns="0"/>
+          <a:lstStyle xmlns:a="http://schemas.openxmlformats.org/drawingml/2006/main">
+            <a:defPPr>
+              <a:defRPr sz="2025">
+                <a:solidFill>
+                  <a:srgbClr val="B23C50"/>
+                </a:solidFill>
+                <a:latin typeface="Ubuntu Condensed"/>
+                <a:ea typeface="Ubuntu Condensed"/>
+                <a:cs typeface="Ubuntu Condensed"/>
+              </a:defRPr>
+            </a:defPPr>
+          </a:lstStyle>
+          <a:p xmlns:a="http://schemas.openxmlformats.org/drawingml/2006/main">
+            <a:pPr>
+              <a:defRPr sz="2025">
+                <a:solidFill>
+                  <a:srgbClr val="B23C50"/>
+                </a:solidFill>
+                <a:latin typeface="Ubuntu Condensed"/>
+                <a:ea typeface="Ubuntu Condensed"/>
+                <a:cs typeface="Ubuntu Condensed"/>
+              </a:defRPr>
+            </a:pPr>
+            <a:r>
+              <a:rPr sz="2025">
+                <a:solidFill>
+                  <a:srgbClr val="B23C50"/>
+                </a:solidFill>
+                <a:latin typeface="Ubuntu Condensed"/>
+                <a:ea typeface="Ubuntu Condensed"/>
+                <a:cs typeface="Ubuntu Condensed"/>
+              </a:rPr>
+              <a:t>Sort and label</a:t>
+            </a:r>
+          </a:p>
+        </p:txBody>
+      </p:sp>
+      <p:sp>
+        <p:nvSpPr>
+          <p:cNvPr id="20" name="">
+            <a:extLst xmlns:a="http://schemas.openxmlformats.org/drawingml/2006/main">
+              <a:ext uri="{FF2B5EF4-FFF2-40B4-BE49-F238E27FC236}">
+                <a16:creationId xmlns:a16="http://schemas.microsoft.com/office/drawing/2014/main" id="{596A10C9-B80D-413F-8932-A9050E912DCB}"/>
+              </a:ext>
+            </a:extLst>
+          </p:cNvPr>
+          <p:cNvSpPr>
+            <a:spLocks xmlns:a="http://schemas.openxmlformats.org/drawingml/2006/main" noGrp="1"/>
+          </p:cNvSpPr>
+          <p:nvPr/>
+        </p:nvSpPr>
+        <p:spPr>
+          <a:xfrm xmlns:a="http://schemas.openxmlformats.org/drawingml/2006/main">
+            <a:off x="942975" y="5486400"/>
+            <a:ext cx="4857750" cy="457200"/>
+          </a:xfrm>
+          <a:prstGeom xmlns:a="http://schemas.openxmlformats.org/drawingml/2006/main" prst="rect">
+            <a:avLst/>
+          </a:prstGeom>
+          <a:noFill xmlns:a="http://schemas.openxmlformats.org/drawingml/2006/main"/>
+          <a:ln xmlns:a="http://schemas.openxmlformats.org/drawingml/2006/main" w="0">
+            <a:noFill/>
+          </a:ln>
+        </p:spPr>
+        <p:txBody>
+          <a:bodyPr xmlns:a="http://schemas.openxmlformats.org/drawingml/2006/main" lIns="0" tIns="0" rIns="0" bIns="0"/>
+          <a:lstStyle xmlns:a="http://schemas.openxmlformats.org/drawingml/2006/main">
+            <a:defPPr>
+              <a:defRPr sz="1575">
+                <a:solidFill>
+                  <a:srgbClr val="38332E"/>
+                </a:solidFill>
+                <a:latin typeface="Ubuntu Condensed"/>
+                <a:ea typeface="Ubuntu Condensed"/>
+                <a:cs typeface="Ubuntu Condensed"/>
+              </a:defRPr>
+            </a:defPPr>
+          </a:lstStyle>
+          <a:p xmlns:a="http://schemas.openxmlformats.org/drawingml/2006/main">
+            <a:pPr>
+              <a:defRPr sz="1575">
+                <a:solidFill>
+                  <a:srgbClr val="38332E"/>
+                </a:solidFill>
+                <a:latin typeface="Ubuntu Condensed"/>
+                <a:ea typeface="Ubuntu Condensed"/>
+                <a:cs typeface="Ubuntu Condensed"/>
+              </a:defRPr>
+            </a:pPr>
+            <a:r>
+              <a:rPr sz="1575">
+                <a:solidFill>
+                  <a:srgbClr val="38332E"/>
+                </a:solidFill>
+                <a:latin typeface="Ubuntu Condensed"/>
+                <a:ea typeface="Ubuntu Condensed"/>
+                <a:cs typeface="Ubuntu Condensed"/>
+              </a:rPr>
+              <a:t>Image_URL &gt; Sort: Field, Attack, Average.</a:t>
+            </a:r>
+          </a:p>
+          <a:p xmlns:a="http://schemas.openxmlformats.org/drawingml/2006/main">
+            <a:pPr>
+              <a:defRPr sz="1575">
+                <a:solidFill>
+                  <a:srgbClr val="38332E"/>
+                </a:solidFill>
+                <a:latin typeface="Ubuntu Condensed"/>
+                <a:ea typeface="Ubuntu Condensed"/>
+                <a:cs typeface="Ubuntu Condensed"/>
+              </a:defRPr>
+            </a:pPr>
+            <a:r>
+              <a:rPr sz="1575">
+                <a:solidFill>
+                  <a:srgbClr val="38332E"/>
+                </a:solidFill>
+                <a:latin typeface="Ubuntu Condensed"/>
+                <a:ea typeface="Ubuntu Condensed"/>
+                <a:cs typeface="Ubuntu Condensed"/>
+              </a:rPr>
+              <a:t>Descending. Marks &gt; Label: show mark labels.</a:t>
+            </a:r>
+          </a:p>
+        </p:txBody>
+      </p:sp>
+      <p:sp>
+        <p:nvSpPr>
+          <p:cNvPr id="21" name="">
+            <a:extLst xmlns:a="http://schemas.openxmlformats.org/drawingml/2006/main">
+              <a:ext uri="{FF2B5EF4-FFF2-40B4-BE49-F238E27FC236}">
+                <a16:creationId xmlns:a16="http://schemas.microsoft.com/office/drawing/2014/main" id="{A3ABA3A7-A1EC-43F4-B9B2-7DF604C92DD8}"/>
+              </a:ext>
+            </a:extLst>
+          </p:cNvPr>
+          <p:cNvSpPr>
+            <a:spLocks xmlns:a="http://schemas.openxmlformats.org/drawingml/2006/main" noGrp="1"/>
+          </p:cNvSpPr>
+          <p:nvPr/>
+        </p:nvSpPr>
+        <p:spPr>
+          <a:xfrm xmlns:a="http://schemas.openxmlformats.org/drawingml/2006/main">
+            <a:off x="457200" y="5915025"/>
+            <a:ext cx="361950" cy="304800"/>
+          </a:xfrm>
+          <a:prstGeom xmlns:a="http://schemas.openxmlformats.org/drawingml/2006/main" prst="rect">
+            <a:avLst/>
+          </a:prstGeom>
+          <a:noFill xmlns:a="http://schemas.openxmlformats.org/drawingml/2006/main"/>
+          <a:ln xmlns:a="http://schemas.openxmlformats.org/drawingml/2006/main" w="0">
+            <a:noFill/>
+          </a:ln>
+        </p:spPr>
+        <p:txBody>
+          <a:bodyPr xmlns:a="http://schemas.openxmlformats.org/drawingml/2006/main" lIns="0" tIns="0" rIns="0" bIns="0"/>
+          <a:lstStyle xmlns:a="http://schemas.openxmlformats.org/drawingml/2006/main">
+            <a:defPPr>
+              <a:defRPr sz="2025">
+                <a:solidFill>
+                  <a:srgbClr val="B23C50"/>
+                </a:solidFill>
+                <a:latin typeface="Ubuntu Condensed"/>
+                <a:ea typeface="Ubuntu Condensed"/>
+                <a:cs typeface="Ubuntu Condensed"/>
+              </a:defRPr>
+            </a:defPPr>
+          </a:lstStyle>
+          <a:p xmlns:a="http://schemas.openxmlformats.org/drawingml/2006/main">
+            <a:pPr>
+              <a:defRPr sz="2025">
+                <a:solidFill>
+                  <a:srgbClr val="B23C50"/>
+                </a:solidFill>
+                <a:latin typeface="Ubuntu Condensed"/>
+                <a:ea typeface="Ubuntu Condensed"/>
+                <a:cs typeface="Ubuntu Condensed"/>
+              </a:defRPr>
+            </a:pPr>
+            <a:r>
+              <a:rPr sz="2025">
+                <a:solidFill>
+                  <a:srgbClr val="B23C50"/>
+                </a:solidFill>
+                <a:latin typeface="Ubuntu Condensed"/>
+                <a:ea typeface="Ubuntu Condensed"/>
+                <a:cs typeface="Ubuntu Condensed"/>
+              </a:rPr>
+              <a:t>07</a:t>
+            </a:r>
+          </a:p>
+        </p:txBody>
+      </p:sp>
+      <p:sp>
+        <p:nvSpPr>
+          <p:cNvPr id="22" name="">
+            <a:extLst xmlns:a="http://schemas.openxmlformats.org/drawingml/2006/main">
+              <a:ext uri="{FF2B5EF4-FFF2-40B4-BE49-F238E27FC236}">
+                <a16:creationId xmlns:a16="http://schemas.microsoft.com/office/drawing/2014/main" id="{6BD190D0-3237-48B0-B503-C9B7C1AAAE8F}"/>
+              </a:ext>
+            </a:extLst>
+          </p:cNvPr>
+          <p:cNvSpPr>
+            <a:spLocks xmlns:a="http://schemas.openxmlformats.org/drawingml/2006/main" noGrp="1"/>
+          </p:cNvSpPr>
+          <p:nvPr/>
+        </p:nvSpPr>
+        <p:spPr>
+          <a:xfrm xmlns:a="http://schemas.openxmlformats.org/drawingml/2006/main">
+            <a:off x="942975" y="5915025"/>
+            <a:ext cx="4667250" cy="304800"/>
+          </a:xfrm>
+          <a:prstGeom xmlns:a="http://schemas.openxmlformats.org/drawingml/2006/main" prst="rect">
+            <a:avLst/>
+          </a:prstGeom>
+          <a:noFill xmlns:a="http://schemas.openxmlformats.org/drawingml/2006/main"/>
+          <a:ln xmlns:a="http://schemas.openxmlformats.org/drawingml/2006/main" w="0">
+            <a:noFill/>
+          </a:ln>
+        </p:spPr>
+        <p:txBody>
+          <a:bodyPr xmlns:a="http://schemas.openxmlformats.org/drawingml/2006/main" lIns="0" tIns="0" rIns="0" bIns="0"/>
+          <a:lstStyle xmlns:a="http://schemas.openxmlformats.org/drawingml/2006/main">
+            <a:defPPr>
+              <a:defRPr sz="2025">
+                <a:solidFill>
+                  <a:srgbClr val="B23C50"/>
+                </a:solidFill>
+                <a:latin typeface="Ubuntu Condensed"/>
+                <a:ea typeface="Ubuntu Condensed"/>
+                <a:cs typeface="Ubuntu Condensed"/>
+              </a:defRPr>
+            </a:defPPr>
+          </a:lstStyle>
+          <a:p xmlns:a="http://schemas.openxmlformats.org/drawingml/2006/main">
+            <a:pPr>
+              <a:defRPr sz="2025">
+                <a:solidFill>
+                  <a:srgbClr val="B23C50"/>
+                </a:solidFill>
+                <a:latin typeface="Ubuntu Condensed"/>
+                <a:ea typeface="Ubuntu Condensed"/>
+                <a:cs typeface="Ubuntu Condensed"/>
+              </a:defRPr>
+            </a:pPr>
+            <a:r>
+              <a:rPr sz="2025">
+                <a:solidFill>
+                  <a:srgbClr val="B23C50"/>
+                </a:solidFill>
+                <a:latin typeface="Ubuntu Condensed"/>
+                <a:ea typeface="Ubuntu Condensed"/>
+                <a:cs typeface="Ubuntu Condensed"/>
+              </a:rPr>
+              <a:t>Make the images larger</a:t>
+            </a:r>
+          </a:p>
+        </p:txBody>
+      </p:sp>
+      <p:sp>
+        <p:nvSpPr>
+          <p:cNvPr id="23" name="">
+            <a:extLst xmlns:a="http://schemas.openxmlformats.org/drawingml/2006/main">
+              <a:ext uri="{FF2B5EF4-FFF2-40B4-BE49-F238E27FC236}">
+                <a16:creationId xmlns:a16="http://schemas.microsoft.com/office/drawing/2014/main" id="{2A3F6483-D283-48AB-91AB-0271FFAD708E}"/>
+              </a:ext>
+            </a:extLst>
+          </p:cNvPr>
+          <p:cNvSpPr>
+            <a:spLocks xmlns:a="http://schemas.openxmlformats.org/drawingml/2006/main" noGrp="1"/>
+          </p:cNvSpPr>
+          <p:nvPr/>
+        </p:nvSpPr>
+        <p:spPr>
+          <a:xfrm xmlns:a="http://schemas.openxmlformats.org/drawingml/2006/main">
+            <a:off x="942975" y="6210300"/>
+            <a:ext cx="4857750" cy="457200"/>
+          </a:xfrm>
+          <a:prstGeom xmlns:a="http://schemas.openxmlformats.org/drawingml/2006/main" prst="rect">
+            <a:avLst/>
+          </a:prstGeom>
+          <a:noFill xmlns:a="http://schemas.openxmlformats.org/drawingml/2006/main"/>
+          <a:ln xmlns:a="http://schemas.openxmlformats.org/drawingml/2006/main" w="0">
+            <a:noFill/>
+          </a:ln>
+        </p:spPr>
+        <p:txBody>
+          <a:bodyPr xmlns:a="http://schemas.openxmlformats.org/drawingml/2006/main" lIns="0" tIns="0" rIns="0" bIns="0"/>
+          <a:lstStyle xmlns:a="http://schemas.openxmlformats.org/drawingml/2006/main">
+            <a:defPPr>
+              <a:defRPr sz="1575">
+                <a:solidFill>
+                  <a:srgbClr val="38332E"/>
+                </a:solidFill>
+                <a:latin typeface="Ubuntu Condensed"/>
+                <a:ea typeface="Ubuntu Condensed"/>
+                <a:cs typeface="Ubuntu Condensed"/>
+              </a:defRPr>
+            </a:defPPr>
+          </a:lstStyle>
+          <a:p xmlns:a="http://schemas.openxmlformats.org/drawingml/2006/main">
+            <a:pPr>
+              <a:defRPr sz="1575">
+                <a:solidFill>
+                  <a:srgbClr val="38332E"/>
+                </a:solidFill>
+                <a:latin typeface="Ubuntu Condensed"/>
+                <a:ea typeface="Ubuntu Condensed"/>
+                <a:cs typeface="Ubuntu Condensed"/>
+              </a:defRPr>
+            </a:pPr>
+            <a:r>
+              <a:rPr sz="1575">
+                <a:solidFill>
+                  <a:srgbClr val="38332E"/>
+                </a:solidFill>
+                <a:latin typeface="Ubuntu Condensed"/>
+                <a:ea typeface="Ubuntu Condensed"/>
+                <a:cs typeface="Ubuntu Condensed"/>
+              </a:rPr>
+              <a:t>Widen the image column. Make rows about 80px tall.</a:t>
+            </a:r>
+          </a:p>
+          <a:p xmlns:a="http://schemas.openxmlformats.org/drawingml/2006/main">
+            <a:pPr>
+              <a:defRPr sz="1575">
+                <a:solidFill>
+                  <a:srgbClr val="38332E"/>
+                </a:solidFill>
+                <a:latin typeface="Ubuntu Condensed"/>
+                <a:ea typeface="Ubuntu Condensed"/>
+                <a:cs typeface="Ubuntu Condensed"/>
+              </a:defRPr>
+            </a:pPr>
+            <a:r>
+              <a:rPr sz="1575">
+                <a:solidFill>
+                  <a:srgbClr val="38332E"/>
+                </a:solidFill>
+                <a:latin typeface="Ubuntu Condensed"/>
+                <a:ea typeface="Ubuntu Condensed"/>
+                <a:cs typeface="Ubuntu Condensed"/>
+              </a:rPr>
+              <a:t>View: Standard. Attack axis starts at 0.</a:t>
             </a:r>
           </a:p>
         </p:txBody>
       </p:sp>
       <p:graphicFrame>
         <p:nvGraphicFramePr>
-          <p:cNvPr id="9" name="Chart">
+          <p:cNvPr id="24" name="Chart">
             <a:extLst xmlns:a="http://schemas.openxmlformats.org/drawingml/2006/main">
               <a:ext uri="{FF2B5EF4-FFF2-40B4-BE49-F238E27FC236}">
-                <a16:creationId xmlns:a16="http://schemas.microsoft.com/office/drawing/2014/main" id="{DEB6AC59-8253-48F0-A7F3-8047226B784F}"/>
+                <a16:creationId xmlns:a16="http://schemas.microsoft.com/office/drawing/2014/main" id="{5266D5E8-3B73-4057-B347-21CBF9CB280D}"/>
               </a:ext>
             </a:extLst>
           </p:cNvPr>
@@ -4638,16 +5628,16 @@
         </p:xfrm>
         <a:graphic xmlns:a="http://schemas.openxmlformats.org/drawingml/2006/main">
           <a:graphicData uri="http://schemas.openxmlformats.org/drawingml/2006/chart">
-            <c:chart xmlns:r="http://schemas.openxmlformats.org/officeDocument/2006/relationships" xmlns:c="http://schemas.openxmlformats.org/drawingml/2006/chart" r:id="R99eefdff61c34949"/>
+            <c:chart xmlns:r="http://schemas.openxmlformats.org/officeDocument/2006/relationships" xmlns:c="http://schemas.openxmlformats.org/drawingml/2006/chart" r:id="Rbd35ded1622645bc"/>
           </a:graphicData>
         </a:graphic>
       </p:graphicFrame>
       <p:pic>
         <p:nvPicPr>
-          <p:cNvPr id="10" name="">
+          <p:cNvPr id="25" name="">
             <a:extLst xmlns:a="http://schemas.openxmlformats.org/drawingml/2006/main">
               <a:ext uri="{FF2B5EF4-FFF2-40B4-BE49-F238E27FC236}">
-                <a16:creationId xmlns:a16="http://schemas.microsoft.com/office/drawing/2014/main" id="{66B41D22-2385-4D72-8BE6-19849394E6A8}"/>
+                <a16:creationId xmlns:a16="http://schemas.microsoft.com/office/drawing/2014/main" id="{53744288-78C1-420D-80DF-41CF6E7B1D78}"/>
               </a:ext>
             </a:extLst>
           </p:cNvPr>
@@ -4657,7 +5647,7 @@
           <p:nvPr/>
         </p:nvPicPr>
         <p:blipFill>
-          <a:blip xmlns:r="http://schemas.openxmlformats.org/officeDocument/2006/relationships" xmlns:a="http://schemas.openxmlformats.org/drawingml/2006/main" r:embed="R076b0b1f2aca40a5"/>
+          <a:blip xmlns:r="http://schemas.openxmlformats.org/officeDocument/2006/relationships" xmlns:a="http://schemas.openxmlformats.org/drawingml/2006/main" r:embed="Ra0e3554614d44a4b"/>
           <a:stretch xmlns:a="http://schemas.openxmlformats.org/drawingml/2006/main"/>
         </p:blipFill>
         <p:spPr>
@@ -4672,10 +5662,10 @@
       </p:pic>
       <p:pic>
         <p:nvPicPr>
-          <p:cNvPr id="11" name="">
+          <p:cNvPr id="26" name="">
             <a:extLst xmlns:a="http://schemas.openxmlformats.org/drawingml/2006/main">
               <a:ext uri="{FF2B5EF4-FFF2-40B4-BE49-F238E27FC236}">
-                <a16:creationId xmlns:a16="http://schemas.microsoft.com/office/drawing/2014/main" id="{D0FBBB19-6837-4957-B514-10559470B6F0}"/>
+                <a16:creationId xmlns:a16="http://schemas.microsoft.com/office/drawing/2014/main" id="{353506BB-9D6F-4423-AAF6-3091D23A0DEA}"/>
               </a:ext>
             </a:extLst>
           </p:cNvPr>
@@ -4685,7 +5675,7 @@
           <p:nvPr/>
         </p:nvPicPr>
         <p:blipFill>
-          <a:blip xmlns:r="http://schemas.openxmlformats.org/officeDocument/2006/relationships" xmlns:a="http://schemas.openxmlformats.org/drawingml/2006/main" r:embed="R5d7bec33ce254510"/>
+          <a:blip xmlns:r="http://schemas.openxmlformats.org/officeDocument/2006/relationships" xmlns:a="http://schemas.openxmlformats.org/drawingml/2006/main" r:embed="R2be998b2b64d445f"/>
           <a:stretch xmlns:a="http://schemas.openxmlformats.org/drawingml/2006/main"/>
         </p:blipFill>
         <p:spPr>
@@ -4700,10 +5690,10 @@
       </p:pic>
       <p:pic>
         <p:nvPicPr>
-          <p:cNvPr id="12" name="">
+          <p:cNvPr id="27" name="">
             <a:extLst xmlns:a="http://schemas.openxmlformats.org/drawingml/2006/main">
               <a:ext uri="{FF2B5EF4-FFF2-40B4-BE49-F238E27FC236}">
-                <a16:creationId xmlns:a16="http://schemas.microsoft.com/office/drawing/2014/main" id="{1DC4DE74-A139-4728-A80C-248D53350D2B}"/>
+                <a16:creationId xmlns:a16="http://schemas.microsoft.com/office/drawing/2014/main" id="{99F7ACFA-EF8E-4760-8AB1-A5005C56A1FF}"/>
               </a:ext>
             </a:extLst>
           </p:cNvPr>
@@ -4713,7 +5703,7 @@
           <p:nvPr/>
         </p:nvPicPr>
         <p:blipFill>
-          <a:blip xmlns:r="http://schemas.openxmlformats.org/officeDocument/2006/relationships" xmlns:a="http://schemas.openxmlformats.org/drawingml/2006/main" r:embed="Rbd6ef7c14f384054"/>
+          <a:blip xmlns:r="http://schemas.openxmlformats.org/officeDocument/2006/relationships" xmlns:a="http://schemas.openxmlformats.org/drawingml/2006/main" r:embed="Reb463f4bbf00482e"/>
           <a:stretch xmlns:a="http://schemas.openxmlformats.org/drawingml/2006/main"/>
         </p:blipFill>
         <p:spPr>
@@ -4728,10 +5718,10 @@
       </p:pic>
       <p:pic>
         <p:nvPicPr>
-          <p:cNvPr id="13" name="">
+          <p:cNvPr id="28" name="">
             <a:extLst xmlns:a="http://schemas.openxmlformats.org/drawingml/2006/main">
               <a:ext uri="{FF2B5EF4-FFF2-40B4-BE49-F238E27FC236}">
-                <a16:creationId xmlns:a16="http://schemas.microsoft.com/office/drawing/2014/main" id="{37668EE8-49B8-4283-A4B9-1296E4F481EC}"/>
+                <a16:creationId xmlns:a16="http://schemas.microsoft.com/office/drawing/2014/main" id="{2AF28EFF-F56F-419A-8F44-050B4F6161A9}"/>
               </a:ext>
             </a:extLst>
           </p:cNvPr>
@@ -4741,7 +5731,7 @@
           <p:nvPr/>
         </p:nvPicPr>
         <p:blipFill>
-          <a:blip xmlns:r="http://schemas.openxmlformats.org/officeDocument/2006/relationships" xmlns:a="http://schemas.openxmlformats.org/drawingml/2006/main" r:embed="Rfc5c9232a452436e"/>
+          <a:blip xmlns:r="http://schemas.openxmlformats.org/officeDocument/2006/relationships" xmlns:a="http://schemas.openxmlformats.org/drawingml/2006/main" r:embed="Rf101016f816e4b77"/>
           <a:stretch xmlns:a="http://schemas.openxmlformats.org/drawingml/2006/main"/>
         </p:blipFill>
         <p:spPr>
@@ -4756,10 +5746,10 @@
       </p:pic>
       <p:pic>
         <p:nvPicPr>
-          <p:cNvPr id="14" name="">
+          <p:cNvPr id="29" name="">
             <a:extLst xmlns:a="http://schemas.openxmlformats.org/drawingml/2006/main">
               <a:ext uri="{FF2B5EF4-FFF2-40B4-BE49-F238E27FC236}">
-                <a16:creationId xmlns:a16="http://schemas.microsoft.com/office/drawing/2014/main" id="{3C6E59B5-1528-43D6-A222-5B637B1197E3}"/>
+                <a16:creationId xmlns:a16="http://schemas.microsoft.com/office/drawing/2014/main" id="{13E9A050-19D0-472E-A760-EAD2197AD112}"/>
               </a:ext>
             </a:extLst>
           </p:cNvPr>
@@ -4769,7 +5759,7 @@
           <p:nvPr/>
         </p:nvPicPr>
         <p:blipFill>
-          <a:blip xmlns:r="http://schemas.openxmlformats.org/officeDocument/2006/relationships" xmlns:a="http://schemas.openxmlformats.org/drawingml/2006/main" r:embed="Rbc5276746c444788"/>
+          <a:blip xmlns:r="http://schemas.openxmlformats.org/officeDocument/2006/relationships" xmlns:a="http://schemas.openxmlformats.org/drawingml/2006/main" r:embed="Rfbe13734c9224428"/>
           <a:stretch xmlns:a="http://schemas.openxmlformats.org/drawingml/2006/main"/>
         </p:blipFill>
         <p:spPr>
@@ -4784,10 +5774,10 @@
       </p:pic>
       <p:sp>
         <p:nvSpPr>
-          <p:cNvPr id="15" name="">
+          <p:cNvPr id="30" name="">
             <a:extLst xmlns:a="http://schemas.openxmlformats.org/drawingml/2006/main">
               <a:ext uri="{FF2B5EF4-FFF2-40B4-BE49-F238E27FC236}">
-                <a16:creationId xmlns:a16="http://schemas.microsoft.com/office/drawing/2014/main" id="{4588C76F-3248-4480-9C9E-EEFBFF31A6E6}"/>
+                <a16:creationId xmlns:a16="http://schemas.microsoft.com/office/drawing/2014/main" id="{56FFFFC0-3210-4EC2-A4A7-0FD85110E108}"/>
               </a:ext>
             </a:extLst>
           </p:cNvPr>
@@ -4813,7 +5803,7 @@
           <a:bodyPr xmlns:a="http://schemas.openxmlformats.org/drawingml/2006/main" lIns="0" tIns="0" rIns="0" bIns="0"/>
           <a:lstStyle xmlns:a="http://schemas.openxmlformats.org/drawingml/2006/main">
             <a:defPPr>
-              <a:defRPr sz="1725">
+              <a:defRPr sz="1650">
                 <a:solidFill>
                   <a:srgbClr val="81796F"/>
                 </a:solidFill>
@@ -4825,7 +5815,7 @@
           </a:lstStyle>
           <a:p xmlns:a="http://schemas.openxmlformats.org/drawingml/2006/main">
             <a:pPr>
-              <a:defRPr sz="1725">
+              <a:defRPr sz="1650">
                 <a:solidFill>
                   <a:srgbClr val="81796F"/>
                 </a:solidFill>
@@ -4835,7 +5825,7 @@
               </a:defRPr>
             </a:pPr>
             <a:r>
-              <a:rPr sz="1725">
+              <a:rPr sz="1650">
                 <a:solidFill>
                   <a:srgbClr val="81796F"/>
                 </a:solidFill>
@@ -4843,7 +5833,7 @@
                 <a:ea typeface="Ubuntu Condensed"/>
                 <a:cs typeface="Ubuntu Condensed"/>
               </a:rPr>
-              <a:t>Rows hold one name and one image per Pokémon.</a:t>
+              <a:t>Images appear in row headers. Bars show average Attack.</a:t>
             </a:r>
           </a:p>
         </p:txBody>
@@ -4851,7 +5841,7 @@
     </p:spTree>
     <p:extLst>
       <p:ext uri="{BB962C8B-B14F-4D97-AF65-F5344CB8AC3E}">
-        <p14:creationId xmlns:p14="http://schemas.microsoft.com/office/powerpoint/2010/main" val="459308524"/>
+        <p14:creationId xmlns:p14="http://schemas.microsoft.com/office/powerpoint/2010/main" val="1279685801"/>
       </p:ext>
     </p:extLst>
   </p:cSld>

</xml_diff>

<commit_message>
Simplify slide 42 while preserving all Tableau steps
</commit_message>
<xml_diff>
--- a/lectures/w04-pokemon-challenge.pptx
+++ b/lectures/w04-pokemon-challenge.pptx
@@ -2,15 +2,15 @@
 <file path=ppt/presentation.xml><?xml version="1.0" encoding="utf-8"?>
 <p:presentation xmlns:p="http://schemas.openxmlformats.org/presentationml/2006/main">
   <p:sldMasterIdLst>
-    <p:sldMasterId xmlns:r="http://schemas.openxmlformats.org/officeDocument/2006/relationships" id="2147483648" r:id="R42b85e33e1e54779"/>
+    <p:sldMasterId xmlns:r="http://schemas.openxmlformats.org/officeDocument/2006/relationships" id="2147483648" r:id="R5269064303e44ccd"/>
   </p:sldMasterIdLst>
   <p:notesMasterIdLst>
-    <p:notesMasterId xmlns:r="http://schemas.openxmlformats.org/officeDocument/2006/relationships" r:id="Reac203914dfe4fc1"/>
+    <p:notesMasterId xmlns:r="http://schemas.openxmlformats.org/officeDocument/2006/relationships" r:id="Rd4e700e275ce48e7"/>
   </p:notesMasterIdLst>
   <p:sldIdLst>
-    <p:sldId xmlns:r="http://schemas.openxmlformats.org/officeDocument/2006/relationships" id="256" r:id="Rbc09dc49d740467a"/>
-    <p:sldId xmlns:r="http://schemas.openxmlformats.org/officeDocument/2006/relationships" id="257" r:id="Rb7df2abb5bcc4bfa"/>
-    <p:sldId xmlns:r="http://schemas.openxmlformats.org/officeDocument/2006/relationships" id="258" r:id="Rda0051ce054b483c"/>
+    <p:sldId xmlns:r="http://schemas.openxmlformats.org/officeDocument/2006/relationships" id="256" r:id="R64f3f068f31542e1"/>
+    <p:sldId xmlns:r="http://schemas.openxmlformats.org/officeDocument/2006/relationships" id="257" r:id="R4a35876e21304d9f"/>
+    <p:sldId xmlns:r="http://schemas.openxmlformats.org/officeDocument/2006/relationships" id="258" r:id="R2f1d62d62f3848fd"/>
   </p:sldIdLst>
   <p:sldSz cx="12192000" cy="6858000"/>
   <p:notesSz cx="6858000" cy="9144000"/>
@@ -631,7 +631,7 @@
           <p:cNvPr id="3" name="Title">
             <a:extLst xmlns:a="http://schemas.openxmlformats.org/drawingml/2006/main">
               <a:ext uri="{FF2B5EF4-FFF2-40B4-BE49-F238E27FC236}">
-                <a16:creationId xmlns:a16="http://schemas.microsoft.com/office/drawing/2014/main" id="{9E6A16A5-1EA1-422D-9EBC-2B452E401705}"/>
+                <a16:creationId xmlns:a16="http://schemas.microsoft.com/office/drawing/2014/main" id="{DD4C4C7E-63F4-4913-A0C5-76F36601748C}"/>
               </a:ext>
             </a:extLst>
           </p:cNvPr>
@@ -788,7 +788,7 @@
           <p:cNvPr id="2" name="Subtitle">
             <a:extLst xmlns:a="http://schemas.openxmlformats.org/drawingml/2006/main">
               <a:ext uri="{FF2B5EF4-FFF2-40B4-BE49-F238E27FC236}">
-                <a16:creationId xmlns:a16="http://schemas.microsoft.com/office/drawing/2014/main" id="{7B972DD4-C0BA-47C4-AEB7-3FC23A08354A}"/>
+                <a16:creationId xmlns:a16="http://schemas.microsoft.com/office/drawing/2014/main" id="{4174DAAB-42BA-42E9-8FBB-EACBFAAFAC9C}"/>
               </a:ext>
             </a:extLst>
           </p:cNvPr>
@@ -962,7 +962,7 @@
           <p:cNvPr id="2" name="Section title">
             <a:extLst xmlns:a="http://schemas.openxmlformats.org/drawingml/2006/main">
               <a:ext uri="{FF2B5EF4-FFF2-40B4-BE49-F238E27FC236}">
-                <a16:creationId xmlns:a16="http://schemas.microsoft.com/office/drawing/2014/main" id="{03C8890A-4590-4797-905D-80A57F60AA62}"/>
+                <a16:creationId xmlns:a16="http://schemas.microsoft.com/office/drawing/2014/main" id="{93870D91-03C6-4148-A009-219D5E0AF534}"/>
               </a:ext>
             </a:extLst>
           </p:cNvPr>
@@ -1136,7 +1136,7 @@
           <p:cNvPr id="3" name="Title">
             <a:extLst xmlns:a="http://schemas.openxmlformats.org/drawingml/2006/main">
               <a:ext uri="{FF2B5EF4-FFF2-40B4-BE49-F238E27FC236}">
-                <a16:creationId xmlns:a16="http://schemas.microsoft.com/office/drawing/2014/main" id="{81FA3425-36BF-4889-B987-F8B3E35772BD}"/>
+                <a16:creationId xmlns:a16="http://schemas.microsoft.com/office/drawing/2014/main" id="{6D90DE9F-BEFD-47E7-B971-FD5A0240F301}"/>
               </a:ext>
             </a:extLst>
           </p:cNvPr>
@@ -1293,7 +1293,7 @@
           <p:cNvPr id="2" name="Body">
             <a:extLst xmlns:a="http://schemas.openxmlformats.org/drawingml/2006/main">
               <a:ext uri="{FF2B5EF4-FFF2-40B4-BE49-F238E27FC236}">
-                <a16:creationId xmlns:a16="http://schemas.microsoft.com/office/drawing/2014/main" id="{38F52B01-F568-4A2C-8936-E974507DB71D}"/>
+                <a16:creationId xmlns:a16="http://schemas.microsoft.com/office/drawing/2014/main" id="{204A587C-1B2A-4DB6-982A-46D114925BCE}"/>
               </a:ext>
             </a:extLst>
           </p:cNvPr>
@@ -1467,7 +1467,7 @@
           <p:cNvPr id="4" name="Title">
             <a:extLst xmlns:a="http://schemas.openxmlformats.org/drawingml/2006/main">
               <a:ext uri="{FF2B5EF4-FFF2-40B4-BE49-F238E27FC236}">
-                <a16:creationId xmlns:a16="http://schemas.microsoft.com/office/drawing/2014/main" id="{4E18C594-2A00-4125-90CC-39270134D46A}"/>
+                <a16:creationId xmlns:a16="http://schemas.microsoft.com/office/drawing/2014/main" id="{14534081-7929-431B-8DB4-FCD97DCEA364}"/>
               </a:ext>
             </a:extLst>
           </p:cNvPr>
@@ -1624,7 +1624,7 @@
           <p:cNvPr id="2" name="Left column">
             <a:extLst xmlns:a="http://schemas.openxmlformats.org/drawingml/2006/main">
               <a:ext uri="{FF2B5EF4-FFF2-40B4-BE49-F238E27FC236}">
-                <a16:creationId xmlns:a16="http://schemas.microsoft.com/office/drawing/2014/main" id="{77EE469F-8D5E-4B96-9650-354FC03A7020}"/>
+                <a16:creationId xmlns:a16="http://schemas.microsoft.com/office/drawing/2014/main" id="{3C009619-6578-4175-A144-B2591503DCB3}"/>
               </a:ext>
             </a:extLst>
           </p:cNvPr>
@@ -1781,7 +1781,7 @@
           <p:cNvPr id="3" name="Right column">
             <a:extLst xmlns:a="http://schemas.openxmlformats.org/drawingml/2006/main">
               <a:ext uri="{FF2B5EF4-FFF2-40B4-BE49-F238E27FC236}">
-                <a16:creationId xmlns:a16="http://schemas.microsoft.com/office/drawing/2014/main" id="{159CB76F-83A3-4A06-81B9-9166C3DF32A1}"/>
+                <a16:creationId xmlns:a16="http://schemas.microsoft.com/office/drawing/2014/main" id="{6BC121B0-F305-4461-B0C2-A2BB0EB55157}"/>
               </a:ext>
             </a:extLst>
           </p:cNvPr>
@@ -1955,7 +1955,7 @@
           <p:cNvPr id="3" name="Title">
             <a:extLst xmlns:a="http://schemas.openxmlformats.org/drawingml/2006/main">
               <a:ext uri="{FF2B5EF4-FFF2-40B4-BE49-F238E27FC236}">
-                <a16:creationId xmlns:a16="http://schemas.microsoft.com/office/drawing/2014/main" id="{B2AC331E-73DD-401E-93E9-96022C277CCE}"/>
+                <a16:creationId xmlns:a16="http://schemas.microsoft.com/office/drawing/2014/main" id="{0459A102-00B2-435A-994C-3B1E07636BC6}"/>
               </a:ext>
             </a:extLst>
           </p:cNvPr>
@@ -2112,7 +2112,7 @@
           <p:cNvPr id="2" name="Left column">
             <a:extLst xmlns:a="http://schemas.openxmlformats.org/drawingml/2006/main">
               <a:ext uri="{FF2B5EF4-FFF2-40B4-BE49-F238E27FC236}">
-                <a16:creationId xmlns:a16="http://schemas.microsoft.com/office/drawing/2014/main" id="{809373CC-24FC-47A3-9C11-6F676DFB6496}"/>
+                <a16:creationId xmlns:a16="http://schemas.microsoft.com/office/drawing/2014/main" id="{E0D207C5-09C4-4342-B708-20E844FE3982}"/>
               </a:ext>
             </a:extLst>
           </p:cNvPr>
@@ -2307,12 +2307,12 @@
   </p:cSld>
   <p:clrMap bg1="lt1" tx1="dk1" bg2="lt2" tx2="dk2" accent1="accent1" accent2="accent2" accent3="accent3" accent4="accent4" accent5="accent5" accent6="accent6" hlink="hlink" folHlink="folHlink"/>
   <p:sldLayoutIdLst>
-    <p:sldLayoutId xmlns:r="http://schemas.openxmlformats.org/officeDocument/2006/relationships" id="2147483649" r:id="Rd628f78650134955"/>
-    <p:sldLayoutId xmlns:r="http://schemas.openxmlformats.org/officeDocument/2006/relationships" id="2147483650" r:id="R11c962e8c84b4f8f"/>
-    <p:sldLayoutId xmlns:r="http://schemas.openxmlformats.org/officeDocument/2006/relationships" id="2147483651" r:id="R0fe36e1a58184747"/>
-    <p:sldLayoutId xmlns:r="http://schemas.openxmlformats.org/officeDocument/2006/relationships" id="2147483652" r:id="Rc6c893cef72e409e"/>
-    <p:sldLayoutId xmlns:r="http://schemas.openxmlformats.org/officeDocument/2006/relationships" id="2147483653" r:id="Ra67651ab1e9540ea"/>
-    <p:sldLayoutId xmlns:r="http://schemas.openxmlformats.org/officeDocument/2006/relationships" id="2147483654" r:id="R933733d7686442af"/>
+    <p:sldLayoutId xmlns:r="http://schemas.openxmlformats.org/officeDocument/2006/relationships" id="2147483649" r:id="Rd44e9dcfbdc94f64"/>
+    <p:sldLayoutId xmlns:r="http://schemas.openxmlformats.org/officeDocument/2006/relationships" id="2147483650" r:id="R282edd2550724f71"/>
+    <p:sldLayoutId xmlns:r="http://schemas.openxmlformats.org/officeDocument/2006/relationships" id="2147483651" r:id="R13a55bb4596d4d23"/>
+    <p:sldLayoutId xmlns:r="http://schemas.openxmlformats.org/officeDocument/2006/relationships" id="2147483652" r:id="Rdef9bcc651d54042"/>
+    <p:sldLayoutId xmlns:r="http://schemas.openxmlformats.org/officeDocument/2006/relationships" id="2147483653" r:id="R4bca7f9be7504155"/>
+    <p:sldLayoutId xmlns:r="http://schemas.openxmlformats.org/officeDocument/2006/relationships" id="2147483654" r:id="R3d78cc7ae1e24d01"/>
   </p:sldLayoutIdLst>
   <p:txStyles>
     <p:titleStyle>
@@ -3101,7 +3101,7 @@
           <p:cNvPr id="2" name="">
             <a:extLst xmlns:a="http://schemas.openxmlformats.org/drawingml/2006/main">
               <a:ext uri="{FF2B5EF4-FFF2-40B4-BE49-F238E27FC236}">
-                <a16:creationId xmlns:a16="http://schemas.microsoft.com/office/drawing/2014/main" id="{3F0200C2-4D25-456B-BFAE-5199D8B06493}"/>
+                <a16:creationId xmlns:a16="http://schemas.microsoft.com/office/drawing/2014/main" id="{F3692E1D-7E10-4BB9-875D-461EE745E8C9}"/>
               </a:ext>
             </a:extLst>
           </p:cNvPr>
@@ -3111,7 +3111,7 @@
           <p:nvPr/>
         </p:nvPicPr>
         <p:blipFill>
-          <a:blip xmlns:r="http://schemas.openxmlformats.org/officeDocument/2006/relationships" xmlns:a="http://schemas.openxmlformats.org/drawingml/2006/main" r:embed="R160a02902aca44de"/>
+          <a:blip xmlns:r="http://schemas.openxmlformats.org/officeDocument/2006/relationships" xmlns:a="http://schemas.openxmlformats.org/drawingml/2006/main" r:embed="R0ad0e7c2312341f5"/>
           <a:stretch xmlns:a="http://schemas.openxmlformats.org/drawingml/2006/main"/>
         </p:blipFill>
         <p:spPr>
@@ -3127,7 +3127,7 @@
     </p:spTree>
     <p:extLst>
       <p:ext uri="{BB962C8B-B14F-4D97-AF65-F5344CB8AC3E}">
-        <p14:creationId xmlns:p14="http://schemas.microsoft.com/office/powerpoint/2010/main" val="1505657211"/>
+        <p14:creationId xmlns:p14="http://schemas.microsoft.com/office/powerpoint/2010/main" val="408670807"/>
       </p:ext>
     </p:extLst>
   </p:cSld>
@@ -3158,7 +3158,7 @@
           <p:cNvPr id="12" name="">
             <a:extLst xmlns:a="http://schemas.openxmlformats.org/drawingml/2006/main">
               <a:ext uri="{FF2B5EF4-FFF2-40B4-BE49-F238E27FC236}">
-                <a16:creationId xmlns:a16="http://schemas.microsoft.com/office/drawing/2014/main" id="{699EC380-0FA9-4B01-9CBE-09442B2F48FC}"/>
+                <a16:creationId xmlns:a16="http://schemas.microsoft.com/office/drawing/2014/main" id="{1936840F-9A59-4936-8658-A7759330AAA8}"/>
               </a:ext>
             </a:extLst>
           </p:cNvPr>
@@ -3224,7 +3224,7 @@
           <p:cNvPr id="2" name="">
             <a:extLst xmlns:a="http://schemas.openxmlformats.org/drawingml/2006/main">
               <a:ext uri="{FF2B5EF4-FFF2-40B4-BE49-F238E27FC236}">
-                <a16:creationId xmlns:a16="http://schemas.microsoft.com/office/drawing/2014/main" id="{220E1D04-947B-4E2C-BE9C-D8620B79215A}"/>
+                <a16:creationId xmlns:a16="http://schemas.microsoft.com/office/drawing/2014/main" id="{CD118E36-98B4-48AD-9548-F333865AAED0}"/>
               </a:ext>
             </a:extLst>
           </p:cNvPr>
@@ -3290,7 +3290,7 @@
           <p:cNvPr id="3" name="">
             <a:extLst xmlns:a="http://schemas.openxmlformats.org/drawingml/2006/main">
               <a:ext uri="{FF2B5EF4-FFF2-40B4-BE49-F238E27FC236}">
-                <a16:creationId xmlns:a16="http://schemas.microsoft.com/office/drawing/2014/main" id="{8A3DFEF7-6D99-453C-B4E9-22C32072162D}"/>
+                <a16:creationId xmlns:a16="http://schemas.microsoft.com/office/drawing/2014/main" id="{36601DAB-3E25-46BC-9169-47E7DC5D5AAC}"/>
               </a:ext>
             </a:extLst>
           </p:cNvPr>
@@ -3356,7 +3356,7 @@
           <p:cNvPr id="4" name="">
             <a:extLst xmlns:a="http://schemas.openxmlformats.org/drawingml/2006/main">
               <a:ext uri="{FF2B5EF4-FFF2-40B4-BE49-F238E27FC236}">
-                <a16:creationId xmlns:a16="http://schemas.microsoft.com/office/drawing/2014/main" id="{739FB109-EB92-46FF-B9F3-3CFE89B0270F}"/>
+                <a16:creationId xmlns:a16="http://schemas.microsoft.com/office/drawing/2014/main" id="{32E2EE68-1F58-49D1-BBF1-9253DA317709}"/>
               </a:ext>
             </a:extLst>
           </p:cNvPr>
@@ -3445,7 +3445,7 @@
           <p:cNvPr id="5" name="">
             <a:extLst xmlns:a="http://schemas.openxmlformats.org/drawingml/2006/main">
               <a:ext uri="{FF2B5EF4-FFF2-40B4-BE49-F238E27FC236}">
-                <a16:creationId xmlns:a16="http://schemas.microsoft.com/office/drawing/2014/main" id="{95E9BAD4-1906-44CB-B589-D9F6357602FA}"/>
+                <a16:creationId xmlns:a16="http://schemas.microsoft.com/office/drawing/2014/main" id="{81130994-5C24-4B7A-BF31-36379D51F8A7}"/>
               </a:ext>
             </a:extLst>
           </p:cNvPr>
@@ -3511,7 +3511,7 @@
           <p:cNvPr id="6" name="">
             <a:extLst xmlns:a="http://schemas.openxmlformats.org/drawingml/2006/main">
               <a:ext uri="{FF2B5EF4-FFF2-40B4-BE49-F238E27FC236}">
-                <a16:creationId xmlns:a16="http://schemas.microsoft.com/office/drawing/2014/main" id="{DA4EFA99-4874-4014-B787-233FAEB276B9}"/>
+                <a16:creationId xmlns:a16="http://schemas.microsoft.com/office/drawing/2014/main" id="{32AA3951-F338-46F7-891B-7C1314ECE663}"/>
               </a:ext>
             </a:extLst>
           </p:cNvPr>
@@ -3600,7 +3600,7 @@
           <p:cNvPr id="7" name="">
             <a:extLst xmlns:a="http://schemas.openxmlformats.org/drawingml/2006/main">
               <a:ext uri="{FF2B5EF4-FFF2-40B4-BE49-F238E27FC236}">
-                <a16:creationId xmlns:a16="http://schemas.microsoft.com/office/drawing/2014/main" id="{C62AC0DF-DB02-41DE-B4FD-BE3948CA9A03}"/>
+                <a16:creationId xmlns:a16="http://schemas.microsoft.com/office/drawing/2014/main" id="{F84CA809-3B41-4727-A679-0216D354CD7A}"/>
               </a:ext>
             </a:extLst>
           </p:cNvPr>
@@ -3666,7 +3666,7 @@
           <p:cNvPr id="8" name="">
             <a:extLst xmlns:a="http://schemas.openxmlformats.org/drawingml/2006/main">
               <a:ext uri="{FF2B5EF4-FFF2-40B4-BE49-F238E27FC236}">
-                <a16:creationId xmlns:a16="http://schemas.microsoft.com/office/drawing/2014/main" id="{2333FEC7-AD6D-4E37-B12F-7313364FD0C8}"/>
+                <a16:creationId xmlns:a16="http://schemas.microsoft.com/office/drawing/2014/main" id="{FD422A66-37B3-4C99-AE76-5E165883D8FC}"/>
               </a:ext>
             </a:extLst>
           </p:cNvPr>
@@ -3755,7 +3755,7 @@
           <p:cNvPr id="9" name="">
             <a:extLst xmlns:a="http://schemas.openxmlformats.org/drawingml/2006/main">
               <a:ext uri="{FF2B5EF4-FFF2-40B4-BE49-F238E27FC236}">
-                <a16:creationId xmlns:a16="http://schemas.microsoft.com/office/drawing/2014/main" id="{1E22F48E-76A5-46D3-A3B4-C2224B1AB2E3}"/>
+                <a16:creationId xmlns:a16="http://schemas.microsoft.com/office/drawing/2014/main" id="{FD445B72-190B-4958-876C-02EDC5530AE1}"/>
               </a:ext>
             </a:extLst>
           </p:cNvPr>
@@ -3821,7 +3821,7 @@
           <p:cNvPr id="10" name="">
             <a:extLst xmlns:a="http://schemas.openxmlformats.org/drawingml/2006/main">
               <a:ext uri="{FF2B5EF4-FFF2-40B4-BE49-F238E27FC236}">
-                <a16:creationId xmlns:a16="http://schemas.microsoft.com/office/drawing/2014/main" id="{E64D690C-EC5A-4E31-8081-32A46D8E8003}"/>
+                <a16:creationId xmlns:a16="http://schemas.microsoft.com/office/drawing/2014/main" id="{CE3C074D-8162-45F5-9FEA-75DB3303303A}"/>
               </a:ext>
             </a:extLst>
           </p:cNvPr>
@@ -3887,7 +3887,7 @@
           <p:cNvPr id="11" name="">
             <a:extLst xmlns:a="http://schemas.openxmlformats.org/drawingml/2006/main">
               <a:ext uri="{FF2B5EF4-FFF2-40B4-BE49-F238E27FC236}">
-                <a16:creationId xmlns:a16="http://schemas.microsoft.com/office/drawing/2014/main" id="{BB3441EC-757B-4EE4-B92C-414577688F96}"/>
+                <a16:creationId xmlns:a16="http://schemas.microsoft.com/office/drawing/2014/main" id="{04A725AC-2C72-4EA3-8668-2B7285F93C31}"/>
               </a:ext>
             </a:extLst>
           </p:cNvPr>
@@ -3951,7 +3951,7 @@
     </p:spTree>
     <p:extLst>
       <p:ext uri="{BB962C8B-B14F-4D97-AF65-F5344CB8AC3E}">
-        <p14:creationId xmlns:p14="http://schemas.microsoft.com/office/powerpoint/2010/main" val="1086971844"/>
+        <p14:creationId xmlns:p14="http://schemas.microsoft.com/office/powerpoint/2010/main" val="95925988"/>
       </p:ext>
     </p:extLst>
   </p:cSld>
@@ -3979,10 +3979,10 @@
       </p:grpSpPr>
       <p:sp>
         <p:nvSpPr>
-          <p:cNvPr id="31" name="">
+          <p:cNvPr id="24" name="">
             <a:extLst xmlns:a="http://schemas.openxmlformats.org/drawingml/2006/main">
               <a:ext uri="{FF2B5EF4-FFF2-40B4-BE49-F238E27FC236}">
-                <a16:creationId xmlns:a16="http://schemas.microsoft.com/office/drawing/2014/main" id="{85D0F02B-8D44-4595-856E-368D51DF2676}"/>
+                <a16:creationId xmlns:a16="http://schemas.microsoft.com/office/drawing/2014/main" id="{D611942D-C525-4D08-8854-155564633EFD}"/>
               </a:ext>
             </a:extLst>
           </p:cNvPr>
@@ -4048,7 +4048,7 @@
           <p:cNvPr id="2" name="">
             <a:extLst xmlns:a="http://schemas.openxmlformats.org/drawingml/2006/main">
               <a:ext uri="{FF2B5EF4-FFF2-40B4-BE49-F238E27FC236}">
-                <a16:creationId xmlns:a16="http://schemas.microsoft.com/office/drawing/2014/main" id="{3E7D0452-74A2-43C1-8009-F6D72B2C53D5}"/>
+                <a16:creationId xmlns:a16="http://schemas.microsoft.com/office/drawing/2014/main" id="{DF764D7B-094C-4DC9-B640-7C871F9EDF8C}"/>
               </a:ext>
             </a:extLst>
           </p:cNvPr>
@@ -4114,7 +4114,7 @@
           <p:cNvPr id="3" name="">
             <a:extLst xmlns:a="http://schemas.openxmlformats.org/drawingml/2006/main">
               <a:ext uri="{FF2B5EF4-FFF2-40B4-BE49-F238E27FC236}">
-                <a16:creationId xmlns:a16="http://schemas.microsoft.com/office/drawing/2014/main" id="{886E40D7-ACC5-4EDE-8450-01084D764096}"/>
+                <a16:creationId xmlns:a16="http://schemas.microsoft.com/office/drawing/2014/main" id="{AD31CBA2-F855-45EE-B554-168408BCABC6}"/>
               </a:ext>
             </a:extLst>
           </p:cNvPr>
@@ -4125,7 +4125,7 @@
         </p:nvSpPr>
         <p:spPr>
           <a:xfrm xmlns:a="http://schemas.openxmlformats.org/drawingml/2006/main">
-            <a:off x="457200" y="1571625"/>
+            <a:off x="457200" y="1685925"/>
             <a:ext cx="361950" cy="304800"/>
           </a:xfrm>
           <a:prstGeom xmlns:a="http://schemas.openxmlformats.org/drawingml/2006/main" prst="rect">
@@ -4140,7 +4140,7 @@
           <a:bodyPr xmlns:a="http://schemas.openxmlformats.org/drawingml/2006/main" lIns="0" tIns="0" rIns="0" bIns="0"/>
           <a:lstStyle xmlns:a="http://schemas.openxmlformats.org/drawingml/2006/main">
             <a:defPPr>
-              <a:defRPr sz="2025">
+              <a:defRPr sz="1875">
                 <a:solidFill>
                   <a:srgbClr val="B23C50"/>
                 </a:solidFill>
@@ -4152,7 +4152,7 @@
           </a:lstStyle>
           <a:p xmlns:a="http://schemas.openxmlformats.org/drawingml/2006/main">
             <a:pPr>
-              <a:defRPr sz="2025">
+              <a:defRPr sz="1875">
                 <a:solidFill>
                   <a:srgbClr val="B23C50"/>
                 </a:solidFill>
@@ -4162,7 +4162,7 @@
               </a:defRPr>
             </a:pPr>
             <a:r>
-              <a:rPr sz="2025">
+              <a:rPr sz="1875">
                 <a:solidFill>
                   <a:srgbClr val="B23C50"/>
                 </a:solidFill>
@@ -4180,7 +4180,7 @@
           <p:cNvPr id="4" name="">
             <a:extLst xmlns:a="http://schemas.openxmlformats.org/drawingml/2006/main">
               <a:ext uri="{FF2B5EF4-FFF2-40B4-BE49-F238E27FC236}">
-                <a16:creationId xmlns:a16="http://schemas.microsoft.com/office/drawing/2014/main" id="{A8613F02-1E55-4280-A34D-EA5678931693}"/>
+                <a16:creationId xmlns:a16="http://schemas.microsoft.com/office/drawing/2014/main" id="{34824E9B-E983-4385-A029-95BBA792A7EE}"/>
               </a:ext>
             </a:extLst>
           </p:cNvPr>
@@ -4191,8 +4191,8 @@
         </p:nvSpPr>
         <p:spPr>
           <a:xfrm xmlns:a="http://schemas.openxmlformats.org/drawingml/2006/main">
-            <a:off x="942975" y="1571625"/>
-            <a:ext cx="4667250" cy="304800"/>
+            <a:off x="942975" y="1685925"/>
+            <a:ext cx="5048250" cy="581025"/>
           </a:xfrm>
           <a:prstGeom xmlns:a="http://schemas.openxmlformats.org/drawingml/2006/main" prst="rect">
             <a:avLst/>
@@ -4206,9 +4206,9 @@
           <a:bodyPr xmlns:a="http://schemas.openxmlformats.org/drawingml/2006/main" lIns="0" tIns="0" rIns="0" bIns="0"/>
           <a:lstStyle xmlns:a="http://schemas.openxmlformats.org/drawingml/2006/main">
             <a:defPPr>
-              <a:defRPr sz="2025">
-                <a:solidFill>
-                  <a:srgbClr val="B23C50"/>
+              <a:defRPr sz="1800">
+                <a:solidFill>
+                  <a:srgbClr val="38332E"/>
                 </a:solidFill>
                 <a:latin typeface="Ubuntu Condensed"/>
                 <a:ea typeface="Ubuntu Condensed"/>
@@ -4218,9 +4218,9 @@
           </a:lstStyle>
           <a:p xmlns:a="http://schemas.openxmlformats.org/drawingml/2006/main">
             <a:pPr>
-              <a:defRPr sz="2025">
-                <a:solidFill>
-                  <a:srgbClr val="B23C50"/>
+              <a:defRPr sz="1800">
+                <a:solidFill>
+                  <a:srgbClr val="38332E"/>
                 </a:solidFill>
                 <a:latin typeface="Ubuntu Condensed"/>
                 <a:ea typeface="Ubuntu Condensed"/>
@@ -4228,15 +4228,38 @@
               </a:defRPr>
             </a:pPr>
             <a:r>
-              <a:rPr sz="2025">
-                <a:solidFill>
-                  <a:srgbClr val="B23C50"/>
+              <a:rPr sz="1800">
+                <a:solidFill>
+                  <a:srgbClr val="38332E"/>
                 </a:solidFill>
                 <a:latin typeface="Ubuntu Condensed"/>
                 <a:ea typeface="Ubuntu Condensed"/>
                 <a:cs typeface="Ubuntu Condensed"/>
               </a:rPr>
-              <a:t>Open the updated CSV</a:t>
+              <a:t>Open updated pokemon-review.csv.</a:t>
+            </a:r>
+          </a:p>
+          <a:p xmlns:a="http://schemas.openxmlformats.org/drawingml/2006/main">
+            <a:pPr>
+              <a:defRPr sz="1800">
+                <a:solidFill>
+                  <a:srgbClr val="38332E"/>
+                </a:solidFill>
+                <a:latin typeface="Ubuntu Condensed"/>
+                <a:ea typeface="Ubuntu Condensed"/>
+                <a:cs typeface="Ubuntu Condensed"/>
+              </a:defRPr>
+            </a:pPr>
+            <a:r>
+              <a:rPr sz="1800">
+                <a:solidFill>
+                  <a:srgbClr val="38332E"/>
+                </a:solidFill>
+                <a:latin typeface="Ubuntu Condensed"/>
+                <a:ea typeface="Ubuntu Condensed"/>
+                <a:cs typeface="Ubuntu Condensed"/>
+              </a:rPr>
+              <a:t>Open a new worksheet.</a:t>
             </a:r>
           </a:p>
         </p:txBody>
@@ -4246,7 +4269,7 @@
           <p:cNvPr id="5" name="">
             <a:extLst xmlns:a="http://schemas.openxmlformats.org/drawingml/2006/main">
               <a:ext uri="{FF2B5EF4-FFF2-40B4-BE49-F238E27FC236}">
-                <a16:creationId xmlns:a16="http://schemas.microsoft.com/office/drawing/2014/main" id="{BF6ADF24-37BB-4A76-BD53-37DE0E0C9FAB}"/>
+                <a16:creationId xmlns:a16="http://schemas.microsoft.com/office/drawing/2014/main" id="{02C44BCE-DA1C-405D-94AB-3F5AC846A2B9}"/>
               </a:ext>
             </a:extLst>
           </p:cNvPr>
@@ -4257,73 +4280,7 @@
         </p:nvSpPr>
         <p:spPr>
           <a:xfrm xmlns:a="http://schemas.openxmlformats.org/drawingml/2006/main">
-            <a:off x="942975" y="1866900"/>
-            <a:ext cx="4857750" cy="457200"/>
-          </a:xfrm>
-          <a:prstGeom xmlns:a="http://schemas.openxmlformats.org/drawingml/2006/main" prst="rect">
-            <a:avLst/>
-          </a:prstGeom>
-          <a:noFill xmlns:a="http://schemas.openxmlformats.org/drawingml/2006/main"/>
-          <a:ln xmlns:a="http://schemas.openxmlformats.org/drawingml/2006/main" w="0">
-            <a:noFill/>
-          </a:ln>
-        </p:spPr>
-        <p:txBody>
-          <a:bodyPr xmlns:a="http://schemas.openxmlformats.org/drawingml/2006/main" lIns="0" tIns="0" rIns="0" bIns="0"/>
-          <a:lstStyle xmlns:a="http://schemas.openxmlformats.org/drawingml/2006/main">
-            <a:defPPr>
-              <a:defRPr sz="1575">
-                <a:solidFill>
-                  <a:srgbClr val="38332E"/>
-                </a:solidFill>
-                <a:latin typeface="Ubuntu Condensed"/>
-                <a:ea typeface="Ubuntu Condensed"/>
-                <a:cs typeface="Ubuntu Condensed"/>
-              </a:defRPr>
-            </a:defPPr>
-          </a:lstStyle>
-          <a:p xmlns:a="http://schemas.openxmlformats.org/drawingml/2006/main">
-            <a:pPr>
-              <a:defRPr sz="1575">
-                <a:solidFill>
-                  <a:srgbClr val="38332E"/>
-                </a:solidFill>
-                <a:latin typeface="Ubuntu Condensed"/>
-                <a:ea typeface="Ubuntu Condensed"/>
-                <a:cs typeface="Ubuntu Condensed"/>
-              </a:defRPr>
-            </a:pPr>
-            <a:r>
-              <a:rPr sz="1575">
-                <a:solidFill>
-                  <a:srgbClr val="38332E"/>
-                </a:solidFill>
-                <a:latin typeface="Ubuntu Condensed"/>
-                <a:ea typeface="Ubuntu Condensed"/>
-                <a:cs typeface="Ubuntu Condensed"/>
-              </a:rPr>
-              <a:t>Text file: pokemon-review.csv. Open Sheet 1.</a:t>
-            </a:r>
-          </a:p>
-        </p:txBody>
-      </p:sp>
-      <p:sp>
-        <p:nvSpPr>
-          <p:cNvPr id="6" name="">
-            <a:extLst xmlns:a="http://schemas.openxmlformats.org/drawingml/2006/main">
-              <a:ext uri="{FF2B5EF4-FFF2-40B4-BE49-F238E27FC236}">
-                <a16:creationId xmlns:a16="http://schemas.microsoft.com/office/drawing/2014/main" id="{C39C8BA8-DD32-446C-83EF-386D31BCF0C2}"/>
-              </a:ext>
-            </a:extLst>
-          </p:cNvPr>
-          <p:cNvSpPr>
-            <a:spLocks xmlns:a="http://schemas.openxmlformats.org/drawingml/2006/main" noGrp="1"/>
-          </p:cNvSpPr>
-          <p:nvPr/>
-        </p:nvSpPr>
-        <p:spPr>
-          <a:xfrm xmlns:a="http://schemas.openxmlformats.org/drawingml/2006/main">
-            <a:off x="457200" y="2295525"/>
+            <a:off x="457200" y="2352675"/>
             <a:ext cx="361950" cy="304800"/>
           </a:xfrm>
           <a:prstGeom xmlns:a="http://schemas.openxmlformats.org/drawingml/2006/main" prst="rect">
@@ -4338,7 +4295,7 @@
           <a:bodyPr xmlns:a="http://schemas.openxmlformats.org/drawingml/2006/main" lIns="0" tIns="0" rIns="0" bIns="0"/>
           <a:lstStyle xmlns:a="http://schemas.openxmlformats.org/drawingml/2006/main">
             <a:defPPr>
-              <a:defRPr sz="2025">
+              <a:defRPr sz="1875">
                 <a:solidFill>
                   <a:srgbClr val="B23C50"/>
                 </a:solidFill>
@@ -4350,7 +4307,7 @@
           </a:lstStyle>
           <a:p xmlns:a="http://schemas.openxmlformats.org/drawingml/2006/main">
             <a:pPr>
-              <a:defRPr sz="2025">
+              <a:defRPr sz="1875">
                 <a:solidFill>
                   <a:srgbClr val="B23C50"/>
                 </a:solidFill>
@@ -4360,7 +4317,7 @@
               </a:defRPr>
             </a:pPr>
             <a:r>
-              <a:rPr sz="2025">
+              <a:rPr sz="1875">
                 <a:solidFill>
                   <a:srgbClr val="B23C50"/>
                 </a:solidFill>
@@ -4375,10 +4332,10 @@
       </p:sp>
       <p:sp>
         <p:nvSpPr>
-          <p:cNvPr id="7" name="">
+          <p:cNvPr id="6" name="">
             <a:extLst xmlns:a="http://schemas.openxmlformats.org/drawingml/2006/main">
               <a:ext uri="{FF2B5EF4-FFF2-40B4-BE49-F238E27FC236}">
-                <a16:creationId xmlns:a16="http://schemas.microsoft.com/office/drawing/2014/main" id="{7F5E95B9-747B-4B96-9EED-9522112B3F29}"/>
+                <a16:creationId xmlns:a16="http://schemas.microsoft.com/office/drawing/2014/main" id="{C25D7BCF-9C19-471F-BDEE-D773A76CA70A}"/>
               </a:ext>
             </a:extLst>
           </p:cNvPr>
@@ -4389,8 +4346,8 @@
         </p:nvSpPr>
         <p:spPr>
           <a:xfrm xmlns:a="http://schemas.openxmlformats.org/drawingml/2006/main">
-            <a:off x="942975" y="2295525"/>
-            <a:ext cx="4667250" cy="304800"/>
+            <a:off x="942975" y="2352675"/>
+            <a:ext cx="5048250" cy="581025"/>
           </a:xfrm>
           <a:prstGeom xmlns:a="http://schemas.openxmlformats.org/drawingml/2006/main" prst="rect">
             <a:avLst/>
@@ -4404,9 +4361,9 @@
           <a:bodyPr xmlns:a="http://schemas.openxmlformats.org/drawingml/2006/main" lIns="0" tIns="0" rIns="0" bIns="0"/>
           <a:lstStyle xmlns:a="http://schemas.openxmlformats.org/drawingml/2006/main">
             <a:defPPr>
-              <a:defRPr sz="2025">
-                <a:solidFill>
-                  <a:srgbClr val="B23C50"/>
+              <a:defRPr sz="1800">
+                <a:solidFill>
+                  <a:srgbClr val="38332E"/>
                 </a:solidFill>
                 <a:latin typeface="Ubuntu Condensed"/>
                 <a:ea typeface="Ubuntu Condensed"/>
@@ -4416,9 +4373,9 @@
           </a:lstStyle>
           <a:p xmlns:a="http://schemas.openxmlformats.org/drawingml/2006/main">
             <a:pPr>
-              <a:defRPr sz="2025">
-                <a:solidFill>
-                  <a:srgbClr val="B23C50"/>
+              <a:defRPr sz="1800">
+                <a:solidFill>
+                  <a:srgbClr val="38332E"/>
                 </a:solidFill>
                 <a:latin typeface="Ubuntu Condensed"/>
                 <a:ea typeface="Ubuntu Condensed"/>
@@ -4426,114 +4383,25 @@
               </a:defRPr>
             </a:pPr>
             <a:r>
-              <a:rPr sz="2025">
-                <a:solidFill>
-                  <a:srgbClr val="B23C50"/>
+              <a:rPr sz="1800">
+                <a:solidFill>
+                  <a:srgbClr val="38332E"/>
                 </a:solidFill>
                 <a:latin typeface="Ubuntu Condensed"/>
                 <a:ea typeface="Ubuntu Condensed"/>
                 <a:cs typeface="Ubuntu Condensed"/>
               </a:rPr>
-              <a:t>Choose five Pokémon</a:t>
+              <a:t>Name to Filters: select the five shown.</a:t>
             </a:r>
           </a:p>
         </p:txBody>
       </p:sp>
       <p:sp>
         <p:nvSpPr>
-          <p:cNvPr id="8" name="">
+          <p:cNvPr id="7" name="">
             <a:extLst xmlns:a="http://schemas.openxmlformats.org/drawingml/2006/main">
               <a:ext uri="{FF2B5EF4-FFF2-40B4-BE49-F238E27FC236}">
-                <a16:creationId xmlns:a16="http://schemas.microsoft.com/office/drawing/2014/main" id="{40086466-FCD0-4440-82DC-42103C71AED7}"/>
-              </a:ext>
-            </a:extLst>
-          </p:cNvPr>
-          <p:cNvSpPr>
-            <a:spLocks xmlns:a="http://schemas.openxmlformats.org/drawingml/2006/main" noGrp="1"/>
-          </p:cNvSpPr>
-          <p:nvPr/>
-        </p:nvSpPr>
-        <p:spPr>
-          <a:xfrm xmlns:a="http://schemas.openxmlformats.org/drawingml/2006/main">
-            <a:off x="942975" y="2590800"/>
-            <a:ext cx="4857750" cy="457200"/>
-          </a:xfrm>
-          <a:prstGeom xmlns:a="http://schemas.openxmlformats.org/drawingml/2006/main" prst="rect">
-            <a:avLst/>
-          </a:prstGeom>
-          <a:noFill xmlns:a="http://schemas.openxmlformats.org/drawingml/2006/main"/>
-          <a:ln xmlns:a="http://schemas.openxmlformats.org/drawingml/2006/main" w="0">
-            <a:noFill/>
-          </a:ln>
-        </p:spPr>
-        <p:txBody>
-          <a:bodyPr xmlns:a="http://schemas.openxmlformats.org/drawingml/2006/main" lIns="0" tIns="0" rIns="0" bIns="0"/>
-          <a:lstStyle xmlns:a="http://schemas.openxmlformats.org/drawingml/2006/main">
-            <a:defPPr>
-              <a:defRPr sz="1575">
-                <a:solidFill>
-                  <a:srgbClr val="38332E"/>
-                </a:solidFill>
-                <a:latin typeface="Ubuntu Condensed"/>
-                <a:ea typeface="Ubuntu Condensed"/>
-                <a:cs typeface="Ubuntu Condensed"/>
-              </a:defRPr>
-            </a:defPPr>
-          </a:lstStyle>
-          <a:p xmlns:a="http://schemas.openxmlformats.org/drawingml/2006/main">
-            <a:pPr>
-              <a:defRPr sz="1575">
-                <a:solidFill>
-                  <a:srgbClr val="38332E"/>
-                </a:solidFill>
-                <a:latin typeface="Ubuntu Condensed"/>
-                <a:ea typeface="Ubuntu Condensed"/>
-                <a:cs typeface="Ubuntu Condensed"/>
-              </a:defRPr>
-            </a:pPr>
-            <a:r>
-              <a:rPr sz="1575">
-                <a:solidFill>
-                  <a:srgbClr val="38332E"/>
-                </a:solidFill>
-                <a:latin typeface="Ubuntu Condensed"/>
-                <a:ea typeface="Ubuntu Condensed"/>
-                <a:cs typeface="Ubuntu Condensed"/>
-              </a:rPr>
-              <a:t>Name to Filters: Bulbasaur, Charmander, Eevee,</a:t>
-            </a:r>
-          </a:p>
-          <a:p xmlns:a="http://schemas.openxmlformats.org/drawingml/2006/main">
-            <a:pPr>
-              <a:defRPr sz="1575">
-                <a:solidFill>
-                  <a:srgbClr val="38332E"/>
-                </a:solidFill>
-                <a:latin typeface="Ubuntu Condensed"/>
-                <a:ea typeface="Ubuntu Condensed"/>
-                <a:cs typeface="Ubuntu Condensed"/>
-              </a:defRPr>
-            </a:pPr>
-            <a:r>
-              <a:rPr sz="1575">
-                <a:solidFill>
-                  <a:srgbClr val="38332E"/>
-                </a:solidFill>
-                <a:latin typeface="Ubuntu Condensed"/>
-                <a:ea typeface="Ubuntu Condensed"/>
-                <a:cs typeface="Ubuntu Condensed"/>
-              </a:rPr>
-              <a:t>Pikachu and Squirtle.</a:t>
-            </a:r>
-          </a:p>
-        </p:txBody>
-      </p:sp>
-      <p:sp>
-        <p:nvSpPr>
-          <p:cNvPr id="9" name="">
-            <a:extLst xmlns:a="http://schemas.openxmlformats.org/drawingml/2006/main">
-              <a:ext uri="{FF2B5EF4-FFF2-40B4-BE49-F238E27FC236}">
-                <a16:creationId xmlns:a16="http://schemas.microsoft.com/office/drawing/2014/main" id="{45C8B533-1967-4E5E-8F2C-FA3CED4F293F}"/>
+                <a16:creationId xmlns:a16="http://schemas.microsoft.com/office/drawing/2014/main" id="{96F526F5-5587-4A69-A943-C5EB92955C6B}"/>
               </a:ext>
             </a:extLst>
           </p:cNvPr>
@@ -4559,7 +4427,7 @@
           <a:bodyPr xmlns:a="http://schemas.openxmlformats.org/drawingml/2006/main" lIns="0" tIns="0" rIns="0" bIns="0"/>
           <a:lstStyle xmlns:a="http://schemas.openxmlformats.org/drawingml/2006/main">
             <a:defPPr>
-              <a:defRPr sz="2025">
+              <a:defRPr sz="1875">
                 <a:solidFill>
                   <a:srgbClr val="B23C50"/>
                 </a:solidFill>
@@ -4571,7 +4439,7 @@
           </a:lstStyle>
           <a:p xmlns:a="http://schemas.openxmlformats.org/drawingml/2006/main">
             <a:pPr>
-              <a:defRPr sz="2025">
+              <a:defRPr sz="1875">
                 <a:solidFill>
                   <a:srgbClr val="B23C50"/>
                 </a:solidFill>
@@ -4581,7 +4449,7 @@
               </a:defRPr>
             </a:pPr>
             <a:r>
-              <a:rPr sz="2025">
+              <a:rPr sz="1875">
                 <a:solidFill>
                   <a:srgbClr val="B23C50"/>
                 </a:solidFill>
@@ -4596,10 +4464,10 @@
       </p:sp>
       <p:sp>
         <p:nvSpPr>
-          <p:cNvPr id="10" name="">
+          <p:cNvPr id="8" name="">
             <a:extLst xmlns:a="http://schemas.openxmlformats.org/drawingml/2006/main">
               <a:ext uri="{FF2B5EF4-FFF2-40B4-BE49-F238E27FC236}">
-                <a16:creationId xmlns:a16="http://schemas.microsoft.com/office/drawing/2014/main" id="{98837F7C-D5C2-445A-A5C2-8832F91F4C49}"/>
+                <a16:creationId xmlns:a16="http://schemas.microsoft.com/office/drawing/2014/main" id="{CED914E1-9769-48AE-ACCB-38B25CC26DD5}"/>
               </a:ext>
             </a:extLst>
           </p:cNvPr>
@@ -4611,7 +4479,7 @@
         <p:spPr>
           <a:xfrm xmlns:a="http://schemas.openxmlformats.org/drawingml/2006/main">
             <a:off x="942975" y="3019425"/>
-            <a:ext cx="4667250" cy="304800"/>
+            <a:ext cx="5048250" cy="581025"/>
           </a:xfrm>
           <a:prstGeom xmlns:a="http://schemas.openxmlformats.org/drawingml/2006/main" prst="rect">
             <a:avLst/>
@@ -4625,9 +4493,9 @@
           <a:bodyPr xmlns:a="http://schemas.openxmlformats.org/drawingml/2006/main" lIns="0" tIns="0" rIns="0" bIns="0"/>
           <a:lstStyle xmlns:a="http://schemas.openxmlformats.org/drawingml/2006/main">
             <a:defPPr>
-              <a:defRPr sz="2025">
-                <a:solidFill>
-                  <a:srgbClr val="B23C50"/>
+              <a:defRPr sz="1800">
+                <a:solidFill>
+                  <a:srgbClr val="38332E"/>
                 </a:solidFill>
                 <a:latin typeface="Ubuntu Condensed"/>
                 <a:ea typeface="Ubuntu Condensed"/>
@@ -4637,9 +4505,9 @@
           </a:lstStyle>
           <a:p xmlns:a="http://schemas.openxmlformats.org/drawingml/2006/main">
             <a:pPr>
-              <a:defRPr sz="2025">
-                <a:solidFill>
-                  <a:srgbClr val="B23C50"/>
+              <a:defRPr sz="1800">
+                <a:solidFill>
+                  <a:srgbClr val="38332E"/>
                 </a:solidFill>
                 <a:latin typeface="Ubuntu Condensed"/>
                 <a:ea typeface="Ubuntu Condensed"/>
@@ -4647,25 +4515,48 @@
               </a:defRPr>
             </a:pPr>
             <a:r>
-              <a:rPr sz="2025">
-                <a:solidFill>
-                  <a:srgbClr val="B23C50"/>
+              <a:rPr sz="1800">
+                <a:solidFill>
+                  <a:srgbClr val="38332E"/>
                 </a:solidFill>
                 <a:latin typeface="Ubuntu Condensed"/>
                 <a:ea typeface="Ubuntu Condensed"/>
                 <a:cs typeface="Ubuntu Condensed"/>
               </a:rPr>
-              <a:t>Enable image URLs</a:t>
+              <a:t>Right-click Image_URL in the Data pane:</a:t>
+            </a:r>
+          </a:p>
+          <a:p xmlns:a="http://schemas.openxmlformats.org/drawingml/2006/main">
+            <a:pPr>
+              <a:defRPr sz="1800">
+                <a:solidFill>
+                  <a:srgbClr val="38332E"/>
+                </a:solidFill>
+                <a:latin typeface="Ubuntu Condensed"/>
+                <a:ea typeface="Ubuntu Condensed"/>
+                <a:cs typeface="Ubuntu Condensed"/>
+              </a:defRPr>
+            </a:pPr>
+            <a:r>
+              <a:rPr sz="1800">
+                <a:solidFill>
+                  <a:srgbClr val="38332E"/>
+                </a:solidFill>
+                <a:latin typeface="Ubuntu Condensed"/>
+                <a:ea typeface="Ubuntu Condensed"/>
+                <a:cs typeface="Ubuntu Condensed"/>
+              </a:rPr>
+              <a:t>Image Role &gt; URL.</a:t>
             </a:r>
           </a:p>
         </p:txBody>
       </p:sp>
       <p:sp>
         <p:nvSpPr>
-          <p:cNvPr id="11" name="">
+          <p:cNvPr id="9" name="">
             <a:extLst xmlns:a="http://schemas.openxmlformats.org/drawingml/2006/main">
               <a:ext uri="{FF2B5EF4-FFF2-40B4-BE49-F238E27FC236}">
-                <a16:creationId xmlns:a16="http://schemas.microsoft.com/office/drawing/2014/main" id="{085E88F2-4627-4B42-A1B0-E5DF9B1CDB98}"/>
+                <a16:creationId xmlns:a16="http://schemas.microsoft.com/office/drawing/2014/main" id="{3489EC73-5978-4362-8A94-8325D421D9AB}"/>
               </a:ext>
             </a:extLst>
           </p:cNvPr>
@@ -4676,96 +4567,7 @@
         </p:nvSpPr>
         <p:spPr>
           <a:xfrm xmlns:a="http://schemas.openxmlformats.org/drawingml/2006/main">
-            <a:off x="942975" y="3314700"/>
-            <a:ext cx="4857750" cy="457200"/>
-          </a:xfrm>
-          <a:prstGeom xmlns:a="http://schemas.openxmlformats.org/drawingml/2006/main" prst="rect">
-            <a:avLst/>
-          </a:prstGeom>
-          <a:noFill xmlns:a="http://schemas.openxmlformats.org/drawingml/2006/main"/>
-          <a:ln xmlns:a="http://schemas.openxmlformats.org/drawingml/2006/main" w="0">
-            <a:noFill/>
-          </a:ln>
-        </p:spPr>
-        <p:txBody>
-          <a:bodyPr xmlns:a="http://schemas.openxmlformats.org/drawingml/2006/main" lIns="0" tIns="0" rIns="0" bIns="0"/>
-          <a:lstStyle xmlns:a="http://schemas.openxmlformats.org/drawingml/2006/main">
-            <a:defPPr>
-              <a:defRPr sz="1575">
-                <a:solidFill>
-                  <a:srgbClr val="38332E"/>
-                </a:solidFill>
-                <a:latin typeface="Ubuntu Condensed"/>
-                <a:ea typeface="Ubuntu Condensed"/>
-                <a:cs typeface="Ubuntu Condensed"/>
-              </a:defRPr>
-            </a:defPPr>
-          </a:lstStyle>
-          <a:p xmlns:a="http://schemas.openxmlformats.org/drawingml/2006/main">
-            <a:pPr>
-              <a:defRPr sz="1575">
-                <a:solidFill>
-                  <a:srgbClr val="38332E"/>
-                </a:solidFill>
-                <a:latin typeface="Ubuntu Condensed"/>
-                <a:ea typeface="Ubuntu Condensed"/>
-                <a:cs typeface="Ubuntu Condensed"/>
-              </a:defRPr>
-            </a:pPr>
-            <a:r>
-              <a:rPr sz="1575">
-                <a:solidFill>
-                  <a:srgbClr val="38332E"/>
-                </a:solidFill>
-                <a:latin typeface="Ubuntu Condensed"/>
-                <a:ea typeface="Ubuntu Condensed"/>
-                <a:cs typeface="Ubuntu Condensed"/>
-              </a:rPr>
-              <a:t>Right-click Image_URL in the Data pane.</a:t>
-            </a:r>
-          </a:p>
-          <a:p xmlns:a="http://schemas.openxmlformats.org/drawingml/2006/main">
-            <a:pPr>
-              <a:defRPr sz="1575">
-                <a:solidFill>
-                  <a:srgbClr val="38332E"/>
-                </a:solidFill>
-                <a:latin typeface="Ubuntu Condensed"/>
-                <a:ea typeface="Ubuntu Condensed"/>
-                <a:cs typeface="Ubuntu Condensed"/>
-              </a:defRPr>
-            </a:pPr>
-            <a:r>
-              <a:rPr sz="1575">
-                <a:solidFill>
-                  <a:srgbClr val="38332E"/>
-                </a:solidFill>
-                <a:latin typeface="Ubuntu Condensed"/>
-                <a:ea typeface="Ubuntu Condensed"/>
-                <a:cs typeface="Ubuntu Condensed"/>
-              </a:rPr>
-              <a:t>Choose Image Role &gt; URL.</a:t>
-            </a:r>
-          </a:p>
-        </p:txBody>
-      </p:sp>
-      <p:sp>
-        <p:nvSpPr>
-          <p:cNvPr id="12" name="">
-            <a:extLst xmlns:a="http://schemas.openxmlformats.org/drawingml/2006/main">
-              <a:ext uri="{FF2B5EF4-FFF2-40B4-BE49-F238E27FC236}">
-                <a16:creationId xmlns:a16="http://schemas.microsoft.com/office/drawing/2014/main" id="{F603F0BE-E824-4381-B47C-FE84B72EAB3F}"/>
-              </a:ext>
-            </a:extLst>
-          </p:cNvPr>
-          <p:cNvSpPr>
-            <a:spLocks xmlns:a="http://schemas.openxmlformats.org/drawingml/2006/main" noGrp="1"/>
-          </p:cNvSpPr>
-          <p:nvPr/>
-        </p:nvSpPr>
-        <p:spPr>
-          <a:xfrm xmlns:a="http://schemas.openxmlformats.org/drawingml/2006/main">
-            <a:off x="457200" y="3743325"/>
+            <a:off x="457200" y="3686175"/>
             <a:ext cx="361950" cy="304800"/>
           </a:xfrm>
           <a:prstGeom xmlns:a="http://schemas.openxmlformats.org/drawingml/2006/main" prst="rect">
@@ -4780,7 +4582,7 @@
           <a:bodyPr xmlns:a="http://schemas.openxmlformats.org/drawingml/2006/main" lIns="0" tIns="0" rIns="0" bIns="0"/>
           <a:lstStyle xmlns:a="http://schemas.openxmlformats.org/drawingml/2006/main">
             <a:defPPr>
-              <a:defRPr sz="2025">
+              <a:defRPr sz="1875">
                 <a:solidFill>
                   <a:srgbClr val="B23C50"/>
                 </a:solidFill>
@@ -4792,7 +4594,7 @@
           </a:lstStyle>
           <a:p xmlns:a="http://schemas.openxmlformats.org/drawingml/2006/main">
             <a:pPr>
-              <a:defRPr sz="2025">
+              <a:defRPr sz="1875">
                 <a:solidFill>
                   <a:srgbClr val="B23C50"/>
                 </a:solidFill>
@@ -4802,7 +4604,7 @@
               </a:defRPr>
             </a:pPr>
             <a:r>
-              <a:rPr sz="2025">
+              <a:rPr sz="1875">
                 <a:solidFill>
                   <a:srgbClr val="B23C50"/>
                 </a:solidFill>
@@ -4817,10 +4619,10 @@
       </p:sp>
       <p:sp>
         <p:nvSpPr>
-          <p:cNvPr id="13" name="">
+          <p:cNvPr id="10" name="">
             <a:extLst xmlns:a="http://schemas.openxmlformats.org/drawingml/2006/main">
               <a:ext uri="{FF2B5EF4-FFF2-40B4-BE49-F238E27FC236}">
-                <a16:creationId xmlns:a16="http://schemas.microsoft.com/office/drawing/2014/main" id="{A6FD208B-AFB8-435A-81B4-92C2F4A40C08}"/>
+                <a16:creationId xmlns:a16="http://schemas.microsoft.com/office/drawing/2014/main" id="{79112E9D-C501-4BB0-BAC2-9C39DC912873}"/>
               </a:ext>
             </a:extLst>
           </p:cNvPr>
@@ -4831,8 +4633,8 @@
         </p:nvSpPr>
         <p:spPr>
           <a:xfrm xmlns:a="http://schemas.openxmlformats.org/drawingml/2006/main">
-            <a:off x="942975" y="3743325"/>
-            <a:ext cx="4667250" cy="304800"/>
+            <a:off x="942975" y="3686175"/>
+            <a:ext cx="5048250" cy="581025"/>
           </a:xfrm>
           <a:prstGeom xmlns:a="http://schemas.openxmlformats.org/drawingml/2006/main" prst="rect">
             <a:avLst/>
@@ -4846,9 +4648,9 @@
           <a:bodyPr xmlns:a="http://schemas.openxmlformats.org/drawingml/2006/main" lIns="0" tIns="0" rIns="0" bIns="0"/>
           <a:lstStyle xmlns:a="http://schemas.openxmlformats.org/drawingml/2006/main">
             <a:defPPr>
-              <a:defRPr sz="2025">
-                <a:solidFill>
-                  <a:srgbClr val="B23C50"/>
+              <a:defRPr sz="1800">
+                <a:solidFill>
+                  <a:srgbClr val="38332E"/>
                 </a:solidFill>
                 <a:latin typeface="Ubuntu Condensed"/>
                 <a:ea typeface="Ubuntu Condensed"/>
@@ -4858,9 +4660,9 @@
           </a:lstStyle>
           <a:p xmlns:a="http://schemas.openxmlformats.org/drawingml/2006/main">
             <a:pPr>
-              <a:defRPr sz="2025">
-                <a:solidFill>
-                  <a:srgbClr val="B23C50"/>
+              <a:defRPr sz="1800">
+                <a:solidFill>
+                  <a:srgbClr val="38332E"/>
                 </a:solidFill>
                 <a:latin typeface="Ubuntu Condensed"/>
                 <a:ea typeface="Ubuntu Condensed"/>
@@ -4868,25 +4670,25 @@
               </a:defRPr>
             </a:pPr>
             <a:r>
-              <a:rPr sz="2025">
-                <a:solidFill>
-                  <a:srgbClr val="B23C50"/>
+              <a:rPr sz="1800">
+                <a:solidFill>
+                  <a:srgbClr val="38332E"/>
                 </a:solidFill>
                 <a:latin typeface="Ubuntu Condensed"/>
                 <a:ea typeface="Ubuntu Condensed"/>
                 <a:cs typeface="Ubuntu Condensed"/>
               </a:rPr>
-              <a:t>Build the rows</a:t>
+              <a:t>Rows: Image_URL first, then Name.</a:t>
             </a:r>
           </a:p>
         </p:txBody>
       </p:sp>
       <p:sp>
         <p:nvSpPr>
-          <p:cNvPr id="14" name="">
+          <p:cNvPr id="11" name="">
             <a:extLst xmlns:a="http://schemas.openxmlformats.org/drawingml/2006/main">
               <a:ext uri="{FF2B5EF4-FFF2-40B4-BE49-F238E27FC236}">
-                <a16:creationId xmlns:a16="http://schemas.microsoft.com/office/drawing/2014/main" id="{D91B40B4-70E3-4A3E-BAD2-62B8E2523DBA}"/>
+                <a16:creationId xmlns:a16="http://schemas.microsoft.com/office/drawing/2014/main" id="{0597A047-859D-421B-823A-0E73A4446906}"/>
               </a:ext>
             </a:extLst>
           </p:cNvPr>
@@ -4897,73 +4699,7 @@
         </p:nvSpPr>
         <p:spPr>
           <a:xfrm xmlns:a="http://schemas.openxmlformats.org/drawingml/2006/main">
-            <a:off x="942975" y="4038600"/>
-            <a:ext cx="4857750" cy="457200"/>
-          </a:xfrm>
-          <a:prstGeom xmlns:a="http://schemas.openxmlformats.org/drawingml/2006/main" prst="rect">
-            <a:avLst/>
-          </a:prstGeom>
-          <a:noFill xmlns:a="http://schemas.openxmlformats.org/drawingml/2006/main"/>
-          <a:ln xmlns:a="http://schemas.openxmlformats.org/drawingml/2006/main" w="0">
-            <a:noFill/>
-          </a:ln>
-        </p:spPr>
-        <p:txBody>
-          <a:bodyPr xmlns:a="http://schemas.openxmlformats.org/drawingml/2006/main" lIns="0" tIns="0" rIns="0" bIns="0"/>
-          <a:lstStyle xmlns:a="http://schemas.openxmlformats.org/drawingml/2006/main">
-            <a:defPPr>
-              <a:defRPr sz="1575">
-                <a:solidFill>
-                  <a:srgbClr val="38332E"/>
-                </a:solidFill>
-                <a:latin typeface="Ubuntu Condensed"/>
-                <a:ea typeface="Ubuntu Condensed"/>
-                <a:cs typeface="Ubuntu Condensed"/>
-              </a:defRPr>
-            </a:defPPr>
-          </a:lstStyle>
-          <a:p xmlns:a="http://schemas.openxmlformats.org/drawingml/2006/main">
-            <a:pPr>
-              <a:defRPr sz="1575">
-                <a:solidFill>
-                  <a:srgbClr val="38332E"/>
-                </a:solidFill>
-                <a:latin typeface="Ubuntu Condensed"/>
-                <a:ea typeface="Ubuntu Condensed"/>
-                <a:cs typeface="Ubuntu Condensed"/>
-              </a:defRPr>
-            </a:pPr>
-            <a:r>
-              <a:rPr sz="1575">
-                <a:solidFill>
-                  <a:srgbClr val="38332E"/>
-                </a:solidFill>
-                <a:latin typeface="Ubuntu Condensed"/>
-                <a:ea typeface="Ubuntu Condensed"/>
-                <a:cs typeface="Ubuntu Condensed"/>
-              </a:rPr>
-              <a:t>Rows: Image_URL first, then Name to its right.</a:t>
-            </a:r>
-          </a:p>
-        </p:txBody>
-      </p:sp>
-      <p:sp>
-        <p:nvSpPr>
-          <p:cNvPr id="15" name="">
-            <a:extLst xmlns:a="http://schemas.openxmlformats.org/drawingml/2006/main">
-              <a:ext uri="{FF2B5EF4-FFF2-40B4-BE49-F238E27FC236}">
-                <a16:creationId xmlns:a16="http://schemas.microsoft.com/office/drawing/2014/main" id="{233A4525-E5F0-4305-A5D6-9E032E3FC4FC}"/>
-              </a:ext>
-            </a:extLst>
-          </p:cNvPr>
-          <p:cNvSpPr>
-            <a:spLocks xmlns:a="http://schemas.openxmlformats.org/drawingml/2006/main" noGrp="1"/>
-          </p:cNvSpPr>
-          <p:nvPr/>
-        </p:nvSpPr>
-        <p:spPr>
-          <a:xfrm xmlns:a="http://schemas.openxmlformats.org/drawingml/2006/main">
-            <a:off x="457200" y="4467225"/>
+            <a:off x="457200" y="4352925"/>
             <a:ext cx="361950" cy="304800"/>
           </a:xfrm>
           <a:prstGeom xmlns:a="http://schemas.openxmlformats.org/drawingml/2006/main" prst="rect">
@@ -4978,7 +4714,7 @@
           <a:bodyPr xmlns:a="http://schemas.openxmlformats.org/drawingml/2006/main" lIns="0" tIns="0" rIns="0" bIns="0"/>
           <a:lstStyle xmlns:a="http://schemas.openxmlformats.org/drawingml/2006/main">
             <a:defPPr>
-              <a:defRPr sz="2025">
+              <a:defRPr sz="1875">
                 <a:solidFill>
                   <a:srgbClr val="B23C50"/>
                 </a:solidFill>
@@ -4990,7 +4726,7 @@
           </a:lstStyle>
           <a:p xmlns:a="http://schemas.openxmlformats.org/drawingml/2006/main">
             <a:pPr>
-              <a:defRPr sz="2025">
+              <a:defRPr sz="1875">
                 <a:solidFill>
                   <a:srgbClr val="B23C50"/>
                 </a:solidFill>
@@ -5000,7 +4736,7 @@
               </a:defRPr>
             </a:pPr>
             <a:r>
-              <a:rPr sz="2025">
+              <a:rPr sz="1875">
                 <a:solidFill>
                   <a:srgbClr val="B23C50"/>
                 </a:solidFill>
@@ -5015,10 +4751,10 @@
       </p:sp>
       <p:sp>
         <p:nvSpPr>
-          <p:cNvPr id="16" name="">
+          <p:cNvPr id="12" name="">
             <a:extLst xmlns:a="http://schemas.openxmlformats.org/drawingml/2006/main">
               <a:ext uri="{FF2B5EF4-FFF2-40B4-BE49-F238E27FC236}">
-                <a16:creationId xmlns:a16="http://schemas.microsoft.com/office/drawing/2014/main" id="{CE0800E8-E3ED-46E7-A436-0EF0464E9107}"/>
+                <a16:creationId xmlns:a16="http://schemas.microsoft.com/office/drawing/2014/main" id="{D9671E02-6D0E-4917-A7AD-6C5CBDEBE220}"/>
               </a:ext>
             </a:extLst>
           </p:cNvPr>
@@ -5029,8 +4765,8 @@
         </p:nvSpPr>
         <p:spPr>
           <a:xfrm xmlns:a="http://schemas.openxmlformats.org/drawingml/2006/main">
-            <a:off x="942975" y="4467225"/>
-            <a:ext cx="4667250" cy="304800"/>
+            <a:off x="942975" y="4352925"/>
+            <a:ext cx="5048250" cy="581025"/>
           </a:xfrm>
           <a:prstGeom xmlns:a="http://schemas.openxmlformats.org/drawingml/2006/main" prst="rect">
             <a:avLst/>
@@ -5044,9 +4780,9 @@
           <a:bodyPr xmlns:a="http://schemas.openxmlformats.org/drawingml/2006/main" lIns="0" tIns="0" rIns="0" bIns="0"/>
           <a:lstStyle xmlns:a="http://schemas.openxmlformats.org/drawingml/2006/main">
             <a:defPPr>
-              <a:defRPr sz="2025">
-                <a:solidFill>
-                  <a:srgbClr val="B23C50"/>
+              <a:defRPr sz="1800">
+                <a:solidFill>
+                  <a:srgbClr val="38332E"/>
                 </a:solidFill>
                 <a:latin typeface="Ubuntu Condensed"/>
                 <a:ea typeface="Ubuntu Condensed"/>
@@ -5056,9 +4792,9 @@
           </a:lstStyle>
           <a:p xmlns:a="http://schemas.openxmlformats.org/drawingml/2006/main">
             <a:pPr>
-              <a:defRPr sz="2025">
-                <a:solidFill>
-                  <a:srgbClr val="B23C50"/>
+              <a:defRPr sz="1800">
+                <a:solidFill>
+                  <a:srgbClr val="38332E"/>
                 </a:solidFill>
                 <a:latin typeface="Ubuntu Condensed"/>
                 <a:ea typeface="Ubuntu Condensed"/>
@@ -5066,25 +4802,48 @@
               </a:defRPr>
             </a:pPr>
             <a:r>
-              <a:rPr sz="2025">
-                <a:solidFill>
-                  <a:srgbClr val="B23C50"/>
+              <a:rPr sz="1800">
+                <a:solidFill>
+                  <a:srgbClr val="38332E"/>
                 </a:solidFill>
                 <a:latin typeface="Ubuntu Condensed"/>
                 <a:ea typeface="Ubuntu Condensed"/>
                 <a:cs typeface="Ubuntu Condensed"/>
               </a:rPr>
-              <a:t>Build the bars</a:t>
+              <a:t>Columns: Attack &gt; Measure &gt; Average.</a:t>
+            </a:r>
+          </a:p>
+          <a:p xmlns:a="http://schemas.openxmlformats.org/drawingml/2006/main">
+            <a:pPr>
+              <a:defRPr sz="1800">
+                <a:solidFill>
+                  <a:srgbClr val="38332E"/>
+                </a:solidFill>
+                <a:latin typeface="Ubuntu Condensed"/>
+                <a:ea typeface="Ubuntu Condensed"/>
+                <a:cs typeface="Ubuntu Condensed"/>
+              </a:defRPr>
+            </a:pPr>
+            <a:r>
+              <a:rPr sz="1800">
+                <a:solidFill>
+                  <a:srgbClr val="38332E"/>
+                </a:solidFill>
+                <a:latin typeface="Ubuntu Condensed"/>
+                <a:ea typeface="Ubuntu Condensed"/>
+                <a:cs typeface="Ubuntu Condensed"/>
+              </a:rPr>
+              <a:t>Marks: Bar.</a:t>
             </a:r>
           </a:p>
         </p:txBody>
       </p:sp>
       <p:sp>
         <p:nvSpPr>
-          <p:cNvPr id="17" name="">
+          <p:cNvPr id="13" name="">
             <a:extLst xmlns:a="http://schemas.openxmlformats.org/drawingml/2006/main">
               <a:ext uri="{FF2B5EF4-FFF2-40B4-BE49-F238E27FC236}">
-                <a16:creationId xmlns:a16="http://schemas.microsoft.com/office/drawing/2014/main" id="{D795E5B3-DE4B-4C84-A205-CC45C7129B6F}"/>
+                <a16:creationId xmlns:a16="http://schemas.microsoft.com/office/drawing/2014/main" id="{6258DE90-C518-4CAB-B488-F8A4340A8542}"/>
               </a:ext>
             </a:extLst>
           </p:cNvPr>
@@ -5095,96 +4854,7 @@
         </p:nvSpPr>
         <p:spPr>
           <a:xfrm xmlns:a="http://schemas.openxmlformats.org/drawingml/2006/main">
-            <a:off x="942975" y="4762500"/>
-            <a:ext cx="4857750" cy="457200"/>
-          </a:xfrm>
-          <a:prstGeom xmlns:a="http://schemas.openxmlformats.org/drawingml/2006/main" prst="rect">
-            <a:avLst/>
-          </a:prstGeom>
-          <a:noFill xmlns:a="http://schemas.openxmlformats.org/drawingml/2006/main"/>
-          <a:ln xmlns:a="http://schemas.openxmlformats.org/drawingml/2006/main" w="0">
-            <a:noFill/>
-          </a:ln>
-        </p:spPr>
-        <p:txBody>
-          <a:bodyPr xmlns:a="http://schemas.openxmlformats.org/drawingml/2006/main" lIns="0" tIns="0" rIns="0" bIns="0"/>
-          <a:lstStyle xmlns:a="http://schemas.openxmlformats.org/drawingml/2006/main">
-            <a:defPPr>
-              <a:defRPr sz="1575">
-                <a:solidFill>
-                  <a:srgbClr val="38332E"/>
-                </a:solidFill>
-                <a:latin typeface="Ubuntu Condensed"/>
-                <a:ea typeface="Ubuntu Condensed"/>
-                <a:cs typeface="Ubuntu Condensed"/>
-              </a:defRPr>
-            </a:defPPr>
-          </a:lstStyle>
-          <a:p xmlns:a="http://schemas.openxmlformats.org/drawingml/2006/main">
-            <a:pPr>
-              <a:defRPr sz="1575">
-                <a:solidFill>
-                  <a:srgbClr val="38332E"/>
-                </a:solidFill>
-                <a:latin typeface="Ubuntu Condensed"/>
-                <a:ea typeface="Ubuntu Condensed"/>
-                <a:cs typeface="Ubuntu Condensed"/>
-              </a:defRPr>
-            </a:pPr>
-            <a:r>
-              <a:rPr sz="1575">
-                <a:solidFill>
-                  <a:srgbClr val="38332E"/>
-                </a:solidFill>
-                <a:latin typeface="Ubuntu Condensed"/>
-                <a:ea typeface="Ubuntu Condensed"/>
-                <a:cs typeface="Ubuntu Condensed"/>
-              </a:rPr>
-              <a:t>Attack to Columns. Pill menu: Measure &gt; Average.</a:t>
-            </a:r>
-          </a:p>
-          <a:p xmlns:a="http://schemas.openxmlformats.org/drawingml/2006/main">
-            <a:pPr>
-              <a:defRPr sz="1575">
-                <a:solidFill>
-                  <a:srgbClr val="38332E"/>
-                </a:solidFill>
-                <a:latin typeface="Ubuntu Condensed"/>
-                <a:ea typeface="Ubuntu Condensed"/>
-                <a:cs typeface="Ubuntu Condensed"/>
-              </a:defRPr>
-            </a:pPr>
-            <a:r>
-              <a:rPr sz="1575">
-                <a:solidFill>
-                  <a:srgbClr val="38332E"/>
-                </a:solidFill>
-                <a:latin typeface="Ubuntu Condensed"/>
-                <a:ea typeface="Ubuntu Condensed"/>
-                <a:cs typeface="Ubuntu Condensed"/>
-              </a:rPr>
-              <a:t>On the Marks card, choose Bar.</a:t>
-            </a:r>
-          </a:p>
-        </p:txBody>
-      </p:sp>
-      <p:sp>
-        <p:nvSpPr>
-          <p:cNvPr id="18" name="">
-            <a:extLst xmlns:a="http://schemas.openxmlformats.org/drawingml/2006/main">
-              <a:ext uri="{FF2B5EF4-FFF2-40B4-BE49-F238E27FC236}">
-                <a16:creationId xmlns:a16="http://schemas.microsoft.com/office/drawing/2014/main" id="{432815D9-F21C-4064-AC1C-446EECD0844F}"/>
-              </a:ext>
-            </a:extLst>
-          </p:cNvPr>
-          <p:cNvSpPr>
-            <a:spLocks xmlns:a="http://schemas.openxmlformats.org/drawingml/2006/main" noGrp="1"/>
-          </p:cNvSpPr>
-          <p:nvPr/>
-        </p:nvSpPr>
-        <p:spPr>
-          <a:xfrm xmlns:a="http://schemas.openxmlformats.org/drawingml/2006/main">
-            <a:off x="457200" y="5191125"/>
+            <a:off x="457200" y="5019675"/>
             <a:ext cx="361950" cy="304800"/>
           </a:xfrm>
           <a:prstGeom xmlns:a="http://schemas.openxmlformats.org/drawingml/2006/main" prst="rect">
@@ -5199,7 +4869,7 @@
           <a:bodyPr xmlns:a="http://schemas.openxmlformats.org/drawingml/2006/main" lIns="0" tIns="0" rIns="0" bIns="0"/>
           <a:lstStyle xmlns:a="http://schemas.openxmlformats.org/drawingml/2006/main">
             <a:defPPr>
-              <a:defRPr sz="2025">
+              <a:defRPr sz="1875">
                 <a:solidFill>
                   <a:srgbClr val="B23C50"/>
                 </a:solidFill>
@@ -5211,7 +4881,7 @@
           </a:lstStyle>
           <a:p xmlns:a="http://schemas.openxmlformats.org/drawingml/2006/main">
             <a:pPr>
-              <a:defRPr sz="2025">
+              <a:defRPr sz="1875">
                 <a:solidFill>
                   <a:srgbClr val="B23C50"/>
                 </a:solidFill>
@@ -5221,7 +4891,7 @@
               </a:defRPr>
             </a:pPr>
             <a:r>
-              <a:rPr sz="2025">
+              <a:rPr sz="1875">
                 <a:solidFill>
                   <a:srgbClr val="B23C50"/>
                 </a:solidFill>
@@ -5236,10 +4906,10 @@
       </p:sp>
       <p:sp>
         <p:nvSpPr>
-          <p:cNvPr id="19" name="">
+          <p:cNvPr id="14" name="">
             <a:extLst xmlns:a="http://schemas.openxmlformats.org/drawingml/2006/main">
               <a:ext uri="{FF2B5EF4-FFF2-40B4-BE49-F238E27FC236}">
-                <a16:creationId xmlns:a16="http://schemas.microsoft.com/office/drawing/2014/main" id="{C8DA61B2-76BA-48D3-948B-3AB9D776004D}"/>
+                <a16:creationId xmlns:a16="http://schemas.microsoft.com/office/drawing/2014/main" id="{00B817AB-3654-465F-AB0A-E08A9A49F378}"/>
               </a:ext>
             </a:extLst>
           </p:cNvPr>
@@ -5250,8 +4920,8 @@
         </p:nvSpPr>
         <p:spPr>
           <a:xfrm xmlns:a="http://schemas.openxmlformats.org/drawingml/2006/main">
-            <a:off x="942975" y="5191125"/>
-            <a:ext cx="4667250" cy="304800"/>
+            <a:off x="942975" y="5019675"/>
+            <a:ext cx="5048250" cy="581025"/>
           </a:xfrm>
           <a:prstGeom xmlns:a="http://schemas.openxmlformats.org/drawingml/2006/main" prst="rect">
             <a:avLst/>
@@ -5265,9 +4935,9 @@
           <a:bodyPr xmlns:a="http://schemas.openxmlformats.org/drawingml/2006/main" lIns="0" tIns="0" rIns="0" bIns="0"/>
           <a:lstStyle xmlns:a="http://schemas.openxmlformats.org/drawingml/2006/main">
             <a:defPPr>
-              <a:defRPr sz="2025">
-                <a:solidFill>
-                  <a:srgbClr val="B23C50"/>
+              <a:defRPr sz="1800">
+                <a:solidFill>
+                  <a:srgbClr val="38332E"/>
                 </a:solidFill>
                 <a:latin typeface="Ubuntu Condensed"/>
                 <a:ea typeface="Ubuntu Condensed"/>
@@ -5277,9 +4947,9 @@
           </a:lstStyle>
           <a:p xmlns:a="http://schemas.openxmlformats.org/drawingml/2006/main">
             <a:pPr>
-              <a:defRPr sz="2025">
-                <a:solidFill>
-                  <a:srgbClr val="B23C50"/>
+              <a:defRPr sz="1800">
+                <a:solidFill>
+                  <a:srgbClr val="38332E"/>
                 </a:solidFill>
                 <a:latin typeface="Ubuntu Condensed"/>
                 <a:ea typeface="Ubuntu Condensed"/>
@@ -5287,25 +4957,48 @@
               </a:defRPr>
             </a:pPr>
             <a:r>
-              <a:rPr sz="2025">
-                <a:solidFill>
-                  <a:srgbClr val="B23C50"/>
+              <a:rPr sz="1800">
+                <a:solidFill>
+                  <a:srgbClr val="38332E"/>
                 </a:solidFill>
                 <a:latin typeface="Ubuntu Condensed"/>
                 <a:ea typeface="Ubuntu Condensed"/>
                 <a:cs typeface="Ubuntu Condensed"/>
               </a:rPr>
-              <a:t>Sort and label</a:t>
+              <a:t>Image_URL &gt; Sort: Descending, Field,</a:t>
+            </a:r>
+          </a:p>
+          <a:p xmlns:a="http://schemas.openxmlformats.org/drawingml/2006/main">
+            <a:pPr>
+              <a:defRPr sz="1800">
+                <a:solidFill>
+                  <a:srgbClr val="38332E"/>
+                </a:solidFill>
+                <a:latin typeface="Ubuntu Condensed"/>
+                <a:ea typeface="Ubuntu Condensed"/>
+                <a:cs typeface="Ubuntu Condensed"/>
+              </a:defRPr>
+            </a:pPr>
+            <a:r>
+              <a:rPr sz="1800">
+                <a:solidFill>
+                  <a:srgbClr val="38332E"/>
+                </a:solidFill>
+                <a:latin typeface="Ubuntu Condensed"/>
+                <a:ea typeface="Ubuntu Condensed"/>
+                <a:cs typeface="Ubuntu Condensed"/>
+              </a:rPr>
+              <a:t>Attack, Average. Marks &gt; Label: show labels.</a:t>
             </a:r>
           </a:p>
         </p:txBody>
       </p:sp>
       <p:sp>
         <p:nvSpPr>
-          <p:cNvPr id="20" name="">
+          <p:cNvPr id="15" name="">
             <a:extLst xmlns:a="http://schemas.openxmlformats.org/drawingml/2006/main">
               <a:ext uri="{FF2B5EF4-FFF2-40B4-BE49-F238E27FC236}">
-                <a16:creationId xmlns:a16="http://schemas.microsoft.com/office/drawing/2014/main" id="{596A10C9-B80D-413F-8932-A9050E912DCB}"/>
+                <a16:creationId xmlns:a16="http://schemas.microsoft.com/office/drawing/2014/main" id="{345CFEAD-5C65-4DD8-8C81-04454CABB986}"/>
               </a:ext>
             </a:extLst>
           </p:cNvPr>
@@ -5316,96 +5009,7 @@
         </p:nvSpPr>
         <p:spPr>
           <a:xfrm xmlns:a="http://schemas.openxmlformats.org/drawingml/2006/main">
-            <a:off x="942975" y="5486400"/>
-            <a:ext cx="4857750" cy="457200"/>
-          </a:xfrm>
-          <a:prstGeom xmlns:a="http://schemas.openxmlformats.org/drawingml/2006/main" prst="rect">
-            <a:avLst/>
-          </a:prstGeom>
-          <a:noFill xmlns:a="http://schemas.openxmlformats.org/drawingml/2006/main"/>
-          <a:ln xmlns:a="http://schemas.openxmlformats.org/drawingml/2006/main" w="0">
-            <a:noFill/>
-          </a:ln>
-        </p:spPr>
-        <p:txBody>
-          <a:bodyPr xmlns:a="http://schemas.openxmlformats.org/drawingml/2006/main" lIns="0" tIns="0" rIns="0" bIns="0"/>
-          <a:lstStyle xmlns:a="http://schemas.openxmlformats.org/drawingml/2006/main">
-            <a:defPPr>
-              <a:defRPr sz="1575">
-                <a:solidFill>
-                  <a:srgbClr val="38332E"/>
-                </a:solidFill>
-                <a:latin typeface="Ubuntu Condensed"/>
-                <a:ea typeface="Ubuntu Condensed"/>
-                <a:cs typeface="Ubuntu Condensed"/>
-              </a:defRPr>
-            </a:defPPr>
-          </a:lstStyle>
-          <a:p xmlns:a="http://schemas.openxmlformats.org/drawingml/2006/main">
-            <a:pPr>
-              <a:defRPr sz="1575">
-                <a:solidFill>
-                  <a:srgbClr val="38332E"/>
-                </a:solidFill>
-                <a:latin typeface="Ubuntu Condensed"/>
-                <a:ea typeface="Ubuntu Condensed"/>
-                <a:cs typeface="Ubuntu Condensed"/>
-              </a:defRPr>
-            </a:pPr>
-            <a:r>
-              <a:rPr sz="1575">
-                <a:solidFill>
-                  <a:srgbClr val="38332E"/>
-                </a:solidFill>
-                <a:latin typeface="Ubuntu Condensed"/>
-                <a:ea typeface="Ubuntu Condensed"/>
-                <a:cs typeface="Ubuntu Condensed"/>
-              </a:rPr>
-              <a:t>Image_URL &gt; Sort: Field, Attack, Average.</a:t>
-            </a:r>
-          </a:p>
-          <a:p xmlns:a="http://schemas.openxmlformats.org/drawingml/2006/main">
-            <a:pPr>
-              <a:defRPr sz="1575">
-                <a:solidFill>
-                  <a:srgbClr val="38332E"/>
-                </a:solidFill>
-                <a:latin typeface="Ubuntu Condensed"/>
-                <a:ea typeface="Ubuntu Condensed"/>
-                <a:cs typeface="Ubuntu Condensed"/>
-              </a:defRPr>
-            </a:pPr>
-            <a:r>
-              <a:rPr sz="1575">
-                <a:solidFill>
-                  <a:srgbClr val="38332E"/>
-                </a:solidFill>
-                <a:latin typeface="Ubuntu Condensed"/>
-                <a:ea typeface="Ubuntu Condensed"/>
-                <a:cs typeface="Ubuntu Condensed"/>
-              </a:rPr>
-              <a:t>Descending. Marks &gt; Label: show mark labels.</a:t>
-            </a:r>
-          </a:p>
-        </p:txBody>
-      </p:sp>
-      <p:sp>
-        <p:nvSpPr>
-          <p:cNvPr id="21" name="">
-            <a:extLst xmlns:a="http://schemas.openxmlformats.org/drawingml/2006/main">
-              <a:ext uri="{FF2B5EF4-FFF2-40B4-BE49-F238E27FC236}">
-                <a16:creationId xmlns:a16="http://schemas.microsoft.com/office/drawing/2014/main" id="{A3ABA3A7-A1EC-43F4-B9B2-7DF604C92DD8}"/>
-              </a:ext>
-            </a:extLst>
-          </p:cNvPr>
-          <p:cNvSpPr>
-            <a:spLocks xmlns:a="http://schemas.openxmlformats.org/drawingml/2006/main" noGrp="1"/>
-          </p:cNvSpPr>
-          <p:nvPr/>
-        </p:nvSpPr>
-        <p:spPr>
-          <a:xfrm xmlns:a="http://schemas.openxmlformats.org/drawingml/2006/main">
-            <a:off x="457200" y="5915025"/>
+            <a:off x="457200" y="5686425"/>
             <a:ext cx="361950" cy="304800"/>
           </a:xfrm>
           <a:prstGeom xmlns:a="http://schemas.openxmlformats.org/drawingml/2006/main" prst="rect">
@@ -5420,7 +5024,7 @@
           <a:bodyPr xmlns:a="http://schemas.openxmlformats.org/drawingml/2006/main" lIns="0" tIns="0" rIns="0" bIns="0"/>
           <a:lstStyle xmlns:a="http://schemas.openxmlformats.org/drawingml/2006/main">
             <a:defPPr>
-              <a:defRPr sz="2025">
+              <a:defRPr sz="1875">
                 <a:solidFill>
                   <a:srgbClr val="B23C50"/>
                 </a:solidFill>
@@ -5432,7 +5036,7 @@
           </a:lstStyle>
           <a:p xmlns:a="http://schemas.openxmlformats.org/drawingml/2006/main">
             <a:pPr>
-              <a:defRPr sz="2025">
+              <a:defRPr sz="1875">
                 <a:solidFill>
                   <a:srgbClr val="B23C50"/>
                 </a:solidFill>
@@ -5442,7 +5046,7 @@
               </a:defRPr>
             </a:pPr>
             <a:r>
-              <a:rPr sz="2025">
+              <a:rPr sz="1875">
                 <a:solidFill>
                   <a:srgbClr val="B23C50"/>
                 </a:solidFill>
@@ -5457,10 +5061,10 @@
       </p:sp>
       <p:sp>
         <p:nvSpPr>
-          <p:cNvPr id="22" name="">
+          <p:cNvPr id="16" name="">
             <a:extLst xmlns:a="http://schemas.openxmlformats.org/drawingml/2006/main">
               <a:ext uri="{FF2B5EF4-FFF2-40B4-BE49-F238E27FC236}">
-                <a16:creationId xmlns:a16="http://schemas.microsoft.com/office/drawing/2014/main" id="{6BD190D0-3237-48B0-B503-C9B7C1AAAE8F}"/>
+                <a16:creationId xmlns:a16="http://schemas.microsoft.com/office/drawing/2014/main" id="{7E098EB3-E7CE-467E-B574-2C3919F101C8}"/>
               </a:ext>
             </a:extLst>
           </p:cNvPr>
@@ -5471,8 +5075,8 @@
         </p:nvSpPr>
         <p:spPr>
           <a:xfrm xmlns:a="http://schemas.openxmlformats.org/drawingml/2006/main">
-            <a:off x="942975" y="5915025"/>
-            <a:ext cx="4667250" cy="304800"/>
+            <a:off x="942975" y="5686425"/>
+            <a:ext cx="5048250" cy="581025"/>
           </a:xfrm>
           <a:prstGeom xmlns:a="http://schemas.openxmlformats.org/drawingml/2006/main" prst="rect">
             <a:avLst/>
@@ -5486,9 +5090,9 @@
           <a:bodyPr xmlns:a="http://schemas.openxmlformats.org/drawingml/2006/main" lIns="0" tIns="0" rIns="0" bIns="0"/>
           <a:lstStyle xmlns:a="http://schemas.openxmlformats.org/drawingml/2006/main">
             <a:defPPr>
-              <a:defRPr sz="2025">
-                <a:solidFill>
-                  <a:srgbClr val="B23C50"/>
+              <a:defRPr sz="1800">
+                <a:solidFill>
+                  <a:srgbClr val="38332E"/>
                 </a:solidFill>
                 <a:latin typeface="Ubuntu Condensed"/>
                 <a:ea typeface="Ubuntu Condensed"/>
@@ -5498,9 +5102,9 @@
           </a:lstStyle>
           <a:p xmlns:a="http://schemas.openxmlformats.org/drawingml/2006/main">
             <a:pPr>
-              <a:defRPr sz="2025">
-                <a:solidFill>
-                  <a:srgbClr val="B23C50"/>
+              <a:defRPr sz="1800">
+                <a:solidFill>
+                  <a:srgbClr val="38332E"/>
                 </a:solidFill>
                 <a:latin typeface="Ubuntu Condensed"/>
                 <a:ea typeface="Ubuntu Condensed"/>
@@ -5508,86 +5112,20 @@
               </a:defRPr>
             </a:pPr>
             <a:r>
-              <a:rPr sz="2025">
-                <a:solidFill>
-                  <a:srgbClr val="B23C50"/>
+              <a:rPr sz="1800">
+                <a:solidFill>
+                  <a:srgbClr val="38332E"/>
                 </a:solidFill>
                 <a:latin typeface="Ubuntu Condensed"/>
                 <a:ea typeface="Ubuntu Condensed"/>
                 <a:cs typeface="Ubuntu Condensed"/>
               </a:rPr>
-              <a:t>Make the images larger</a:t>
-            </a:r>
-          </a:p>
-        </p:txBody>
-      </p:sp>
-      <p:sp>
-        <p:nvSpPr>
-          <p:cNvPr id="23" name="">
-            <a:extLst xmlns:a="http://schemas.openxmlformats.org/drawingml/2006/main">
-              <a:ext uri="{FF2B5EF4-FFF2-40B4-BE49-F238E27FC236}">
-                <a16:creationId xmlns:a16="http://schemas.microsoft.com/office/drawing/2014/main" id="{2A3F6483-D283-48AB-91AB-0271FFAD708E}"/>
-              </a:ext>
-            </a:extLst>
-          </p:cNvPr>
-          <p:cNvSpPr>
-            <a:spLocks xmlns:a="http://schemas.openxmlformats.org/drawingml/2006/main" noGrp="1"/>
-          </p:cNvSpPr>
-          <p:nvPr/>
-        </p:nvSpPr>
-        <p:spPr>
-          <a:xfrm xmlns:a="http://schemas.openxmlformats.org/drawingml/2006/main">
-            <a:off x="942975" y="6210300"/>
-            <a:ext cx="4857750" cy="457200"/>
-          </a:xfrm>
-          <a:prstGeom xmlns:a="http://schemas.openxmlformats.org/drawingml/2006/main" prst="rect">
-            <a:avLst/>
-          </a:prstGeom>
-          <a:noFill xmlns:a="http://schemas.openxmlformats.org/drawingml/2006/main"/>
-          <a:ln xmlns:a="http://schemas.openxmlformats.org/drawingml/2006/main" w="0">
-            <a:noFill/>
-          </a:ln>
-        </p:spPr>
-        <p:txBody>
-          <a:bodyPr xmlns:a="http://schemas.openxmlformats.org/drawingml/2006/main" lIns="0" tIns="0" rIns="0" bIns="0"/>
-          <a:lstStyle xmlns:a="http://schemas.openxmlformats.org/drawingml/2006/main">
-            <a:defPPr>
-              <a:defRPr sz="1575">
-                <a:solidFill>
-                  <a:srgbClr val="38332E"/>
-                </a:solidFill>
-                <a:latin typeface="Ubuntu Condensed"/>
-                <a:ea typeface="Ubuntu Condensed"/>
-                <a:cs typeface="Ubuntu Condensed"/>
-              </a:defRPr>
-            </a:defPPr>
-          </a:lstStyle>
-          <a:p xmlns:a="http://schemas.openxmlformats.org/drawingml/2006/main">
-            <a:pPr>
-              <a:defRPr sz="1575">
-                <a:solidFill>
-                  <a:srgbClr val="38332E"/>
-                </a:solidFill>
-                <a:latin typeface="Ubuntu Condensed"/>
-                <a:ea typeface="Ubuntu Condensed"/>
-                <a:cs typeface="Ubuntu Condensed"/>
-              </a:defRPr>
-            </a:pPr>
-            <a:r>
-              <a:rPr sz="1575">
-                <a:solidFill>
-                  <a:srgbClr val="38332E"/>
-                </a:solidFill>
-                <a:latin typeface="Ubuntu Condensed"/>
-                <a:ea typeface="Ubuntu Condensed"/>
-                <a:cs typeface="Ubuntu Condensed"/>
-              </a:rPr>
-              <a:t>Widen the image column. Make rows about 80px tall.</a:t>
+              <a:t>Standard view. Widen the image header.</a:t>
             </a:r>
           </a:p>
           <a:p xmlns:a="http://schemas.openxmlformats.org/drawingml/2006/main">
             <a:pPr>
-              <a:defRPr sz="1575">
+              <a:defRPr sz="1800">
                 <a:solidFill>
                   <a:srgbClr val="38332E"/>
                 </a:solidFill>
@@ -5597,7 +5135,7 @@
               </a:defRPr>
             </a:pPr>
             <a:r>
-              <a:rPr sz="1575">
+              <a:rPr sz="1800">
                 <a:solidFill>
                   <a:srgbClr val="38332E"/>
                 </a:solidFill>
@@ -5605,17 +5143,17 @@
                 <a:ea typeface="Ubuntu Condensed"/>
                 <a:cs typeface="Ubuntu Condensed"/>
               </a:rPr>
-              <a:t>View: Standard. Attack axis starts at 0.</a:t>
+              <a:t>Format &gt; Cell Size &gt; Taller. Axis starts at 0.</a:t>
             </a:r>
           </a:p>
         </p:txBody>
       </p:sp>
       <p:graphicFrame>
         <p:nvGraphicFramePr>
-          <p:cNvPr id="24" name="Chart">
+          <p:cNvPr id="17" name="Chart">
             <a:extLst xmlns:a="http://schemas.openxmlformats.org/drawingml/2006/main">
               <a:ext uri="{FF2B5EF4-FFF2-40B4-BE49-F238E27FC236}">
-                <a16:creationId xmlns:a16="http://schemas.microsoft.com/office/drawing/2014/main" id="{5266D5E8-3B73-4057-B347-21CBF9CB280D}"/>
+                <a16:creationId xmlns:a16="http://schemas.microsoft.com/office/drawing/2014/main" id="{F83585DF-EB87-472B-B9AF-AF5B781D817E}"/>
               </a:ext>
             </a:extLst>
           </p:cNvPr>
@@ -5628,16 +5166,16 @@
         </p:xfrm>
         <a:graphic xmlns:a="http://schemas.openxmlformats.org/drawingml/2006/main">
           <a:graphicData uri="http://schemas.openxmlformats.org/drawingml/2006/chart">
-            <c:chart xmlns:r="http://schemas.openxmlformats.org/officeDocument/2006/relationships" xmlns:c="http://schemas.openxmlformats.org/drawingml/2006/chart" r:id="Rbd35ded1622645bc"/>
+            <c:chart xmlns:r="http://schemas.openxmlformats.org/officeDocument/2006/relationships" xmlns:c="http://schemas.openxmlformats.org/drawingml/2006/chart" r:id="R509e56747d68494b"/>
           </a:graphicData>
         </a:graphic>
       </p:graphicFrame>
       <p:pic>
         <p:nvPicPr>
-          <p:cNvPr id="25" name="">
+          <p:cNvPr id="18" name="">
             <a:extLst xmlns:a="http://schemas.openxmlformats.org/drawingml/2006/main">
               <a:ext uri="{FF2B5EF4-FFF2-40B4-BE49-F238E27FC236}">
-                <a16:creationId xmlns:a16="http://schemas.microsoft.com/office/drawing/2014/main" id="{53744288-78C1-420D-80DF-41CF6E7B1D78}"/>
+                <a16:creationId xmlns:a16="http://schemas.microsoft.com/office/drawing/2014/main" id="{A561BF6A-CD7C-44B5-9B02-02052AEC89DC}"/>
               </a:ext>
             </a:extLst>
           </p:cNvPr>
@@ -5647,7 +5185,7 @@
           <p:nvPr/>
         </p:nvPicPr>
         <p:blipFill>
-          <a:blip xmlns:r="http://schemas.openxmlformats.org/officeDocument/2006/relationships" xmlns:a="http://schemas.openxmlformats.org/drawingml/2006/main" r:embed="Ra0e3554614d44a4b"/>
+          <a:blip xmlns:r="http://schemas.openxmlformats.org/officeDocument/2006/relationships" xmlns:a="http://schemas.openxmlformats.org/drawingml/2006/main" r:embed="R233eb2298d9e4c30"/>
           <a:stretch xmlns:a="http://schemas.openxmlformats.org/drawingml/2006/main"/>
         </p:blipFill>
         <p:spPr>
@@ -5662,10 +5200,10 @@
       </p:pic>
       <p:pic>
         <p:nvPicPr>
-          <p:cNvPr id="26" name="">
+          <p:cNvPr id="19" name="">
             <a:extLst xmlns:a="http://schemas.openxmlformats.org/drawingml/2006/main">
               <a:ext uri="{FF2B5EF4-FFF2-40B4-BE49-F238E27FC236}">
-                <a16:creationId xmlns:a16="http://schemas.microsoft.com/office/drawing/2014/main" id="{353506BB-9D6F-4423-AAF6-3091D23A0DEA}"/>
+                <a16:creationId xmlns:a16="http://schemas.microsoft.com/office/drawing/2014/main" id="{DFD8D265-6000-4F6A-AFF0-E1FFAC37CB72}"/>
               </a:ext>
             </a:extLst>
           </p:cNvPr>
@@ -5675,7 +5213,7 @@
           <p:nvPr/>
         </p:nvPicPr>
         <p:blipFill>
-          <a:blip xmlns:r="http://schemas.openxmlformats.org/officeDocument/2006/relationships" xmlns:a="http://schemas.openxmlformats.org/drawingml/2006/main" r:embed="R2be998b2b64d445f"/>
+          <a:blip xmlns:r="http://schemas.openxmlformats.org/officeDocument/2006/relationships" xmlns:a="http://schemas.openxmlformats.org/drawingml/2006/main" r:embed="Rf308243859f0426d"/>
           <a:stretch xmlns:a="http://schemas.openxmlformats.org/drawingml/2006/main"/>
         </p:blipFill>
         <p:spPr>
@@ -5690,10 +5228,10 @@
       </p:pic>
       <p:pic>
         <p:nvPicPr>
-          <p:cNvPr id="27" name="">
+          <p:cNvPr id="20" name="">
             <a:extLst xmlns:a="http://schemas.openxmlformats.org/drawingml/2006/main">
               <a:ext uri="{FF2B5EF4-FFF2-40B4-BE49-F238E27FC236}">
-                <a16:creationId xmlns:a16="http://schemas.microsoft.com/office/drawing/2014/main" id="{99F7ACFA-EF8E-4760-8AB1-A5005C56A1FF}"/>
+                <a16:creationId xmlns:a16="http://schemas.microsoft.com/office/drawing/2014/main" id="{E0A814E3-3380-498B-AAAB-246C870DCC7B}"/>
               </a:ext>
             </a:extLst>
           </p:cNvPr>
@@ -5703,7 +5241,7 @@
           <p:nvPr/>
         </p:nvPicPr>
         <p:blipFill>
-          <a:blip xmlns:r="http://schemas.openxmlformats.org/officeDocument/2006/relationships" xmlns:a="http://schemas.openxmlformats.org/drawingml/2006/main" r:embed="Reb463f4bbf00482e"/>
+          <a:blip xmlns:r="http://schemas.openxmlformats.org/officeDocument/2006/relationships" xmlns:a="http://schemas.openxmlformats.org/drawingml/2006/main" r:embed="Rc992b85c380b42ed"/>
           <a:stretch xmlns:a="http://schemas.openxmlformats.org/drawingml/2006/main"/>
         </p:blipFill>
         <p:spPr>
@@ -5718,10 +5256,10 @@
       </p:pic>
       <p:pic>
         <p:nvPicPr>
-          <p:cNvPr id="28" name="">
+          <p:cNvPr id="21" name="">
             <a:extLst xmlns:a="http://schemas.openxmlformats.org/drawingml/2006/main">
               <a:ext uri="{FF2B5EF4-FFF2-40B4-BE49-F238E27FC236}">
-                <a16:creationId xmlns:a16="http://schemas.microsoft.com/office/drawing/2014/main" id="{2AF28EFF-F56F-419A-8F44-050B4F6161A9}"/>
+                <a16:creationId xmlns:a16="http://schemas.microsoft.com/office/drawing/2014/main" id="{44A793EC-C82A-426D-839B-22B7FB76FE60}"/>
               </a:ext>
             </a:extLst>
           </p:cNvPr>
@@ -5731,7 +5269,7 @@
           <p:nvPr/>
         </p:nvPicPr>
         <p:blipFill>
-          <a:blip xmlns:r="http://schemas.openxmlformats.org/officeDocument/2006/relationships" xmlns:a="http://schemas.openxmlformats.org/drawingml/2006/main" r:embed="Rf101016f816e4b77"/>
+          <a:blip xmlns:r="http://schemas.openxmlformats.org/officeDocument/2006/relationships" xmlns:a="http://schemas.openxmlformats.org/drawingml/2006/main" r:embed="R6b1de88dc0af4d11"/>
           <a:stretch xmlns:a="http://schemas.openxmlformats.org/drawingml/2006/main"/>
         </p:blipFill>
         <p:spPr>
@@ -5746,10 +5284,10 @@
       </p:pic>
       <p:pic>
         <p:nvPicPr>
-          <p:cNvPr id="29" name="">
+          <p:cNvPr id="22" name="">
             <a:extLst xmlns:a="http://schemas.openxmlformats.org/drawingml/2006/main">
               <a:ext uri="{FF2B5EF4-FFF2-40B4-BE49-F238E27FC236}">
-                <a16:creationId xmlns:a16="http://schemas.microsoft.com/office/drawing/2014/main" id="{13E9A050-19D0-472E-A760-EAD2197AD112}"/>
+                <a16:creationId xmlns:a16="http://schemas.microsoft.com/office/drawing/2014/main" id="{2E5FB876-D85D-49AB-9497-33B69006D868}"/>
               </a:ext>
             </a:extLst>
           </p:cNvPr>
@@ -5759,7 +5297,7 @@
           <p:nvPr/>
         </p:nvPicPr>
         <p:blipFill>
-          <a:blip xmlns:r="http://schemas.openxmlformats.org/officeDocument/2006/relationships" xmlns:a="http://schemas.openxmlformats.org/drawingml/2006/main" r:embed="Rfbe13734c9224428"/>
+          <a:blip xmlns:r="http://schemas.openxmlformats.org/officeDocument/2006/relationships" xmlns:a="http://schemas.openxmlformats.org/drawingml/2006/main" r:embed="R926376722e364b0d"/>
           <a:stretch xmlns:a="http://schemas.openxmlformats.org/drawingml/2006/main"/>
         </p:blipFill>
         <p:spPr>
@@ -5774,10 +5312,10 @@
       </p:pic>
       <p:sp>
         <p:nvSpPr>
-          <p:cNvPr id="30" name="">
+          <p:cNvPr id="23" name="">
             <a:extLst xmlns:a="http://schemas.openxmlformats.org/drawingml/2006/main">
               <a:ext uri="{FF2B5EF4-FFF2-40B4-BE49-F238E27FC236}">
-                <a16:creationId xmlns:a16="http://schemas.microsoft.com/office/drawing/2014/main" id="{56FFFFC0-3210-4EC2-A4A7-0FD85110E108}"/>
+                <a16:creationId xmlns:a16="http://schemas.microsoft.com/office/drawing/2014/main" id="{8DB4041F-7A07-4B5D-9C15-8072C54616D1}"/>
               </a:ext>
             </a:extLst>
           </p:cNvPr>
@@ -5833,7 +5371,7 @@
                 <a:ea typeface="Ubuntu Condensed"/>
                 <a:cs typeface="Ubuntu Condensed"/>
               </a:rPr>
-              <a:t>Images appear in row headers. Bars show average Attack.</a:t>
+              <a:t>Images are row headers.</a:t>
             </a:r>
           </a:p>
         </p:txBody>
@@ -5841,7 +5379,7 @@
     </p:spTree>
     <p:extLst>
       <p:ext uri="{BB962C8B-B14F-4D97-AF65-F5344CB8AC3E}">
-        <p14:creationId xmlns:p14="http://schemas.microsoft.com/office/powerpoint/2010/main" val="1279685801"/>
+        <p14:creationId xmlns:p14="http://schemas.microsoft.com/office/powerpoint/2010/main" val="1850392550"/>
       </p:ext>
     </p:extLst>
   </p:cSld>

</xml_diff>